<commit_message>
Refactor autograd notebooks and update PPT files
</commit_message>
<xml_diff>
--- a/material/5_AI/11_딥러닝 학습 안정화 전략.pptx
+++ b/material/5_AI/11_딥러닝 학습 안정화 전략.pptx
@@ -5,7 +5,7 @@
     <p:sldMasterId id="2147483660" r:id="rId1"/>
   </p:sldMasterIdLst>
   <p:notesMasterIdLst>
-    <p:notesMasterId r:id="rId39"/>
+    <p:notesMasterId r:id="rId35"/>
   </p:notesMasterIdLst>
   <p:sldIdLst>
     <p:sldId id="1044" r:id="rId2"/>
@@ -36,15 +36,11 @@
     <p:sldId id="1040" r:id="rId27"/>
     <p:sldId id="751" r:id="rId28"/>
     <p:sldId id="1041" r:id="rId29"/>
-    <p:sldId id="706" r:id="rId30"/>
-    <p:sldId id="1042" r:id="rId31"/>
-    <p:sldId id="1043" r:id="rId32"/>
-    <p:sldId id="694" r:id="rId33"/>
-    <p:sldId id="707" r:id="rId34"/>
-    <p:sldId id="708" r:id="rId35"/>
-    <p:sldId id="696" r:id="rId36"/>
-    <p:sldId id="712" r:id="rId37"/>
-    <p:sldId id="836" r:id="rId38"/>
+    <p:sldId id="1046" r:id="rId30"/>
+    <p:sldId id="707" r:id="rId31"/>
+    <p:sldId id="708" r:id="rId32"/>
+    <p:sldId id="696" r:id="rId33"/>
+    <p:sldId id="836" r:id="rId34"/>
   </p:sldIdLst>
   <p:sldSz cx="12192000" cy="6858000"/>
   <p:notesSz cx="6858000" cy="9144000"/>
@@ -900,8 +896,8 @@
         </p:nvSpPr>
         <p:spPr/>
       </p:sp>
-      <mc:AlternateContent xmlns:mc="http://schemas.openxmlformats.org/markup-compatibility/2006">
-        <mc:Choice xmlns:a14="http://schemas.microsoft.com/office/drawing/2010/main" Requires="a14">
+      <mc:AlternateContent xmlns:mc="http://schemas.openxmlformats.org/markup-compatibility/2006" xmlns:a14="http://schemas.microsoft.com/office/drawing/2010/main">
+        <mc:Choice Requires="a14">
           <p:sp>
             <p:nvSpPr>
               <p:cNvPr id="3" name="슬라이드 노트 개체 틀 2"/>
@@ -971,6 +967,7 @@
                 </a:r>
               </a:p>
               <a:p>
+                <a:pPr/>
                 <a14:m>
                   <m:oMathPara xmlns:m="http://schemas.openxmlformats.org/officeDocument/2006/math">
                     <m:oMathParaPr>
@@ -982,7 +979,7 @@
                           <a:solidFill>
                             <a:schemeClr val="tx1"/>
                           </a:solidFill>
-                          <a:latin typeface="Kim jung chul Gothic Regular" panose="020B0503000000000000" pitchFamily="50" charset="-127"/>
+                          <a:latin typeface="Cambria Math" panose="02040503050406030204" pitchFamily="18" charset="0"/>
                           <a:ea typeface="Kim jung chul Gothic Regular" panose="020B0503000000000000" pitchFamily="50" charset="-127"/>
                           <a:cs typeface="+mn-cs"/>
                         </a:rPr>
@@ -993,7 +990,7 @@
                           <a:solidFill>
                             <a:schemeClr val="tx1"/>
                           </a:solidFill>
-                          <a:latin typeface="Kim jung chul Gothic Regular" panose="020B0503000000000000" pitchFamily="50" charset="-127"/>
+                          <a:latin typeface="Cambria Math" panose="02040503050406030204" pitchFamily="18" charset="0"/>
                           <a:ea typeface="Kim jung chul Gothic Regular" panose="020B0503000000000000" pitchFamily="50" charset="-127"/>
                           <a:cs typeface="+mn-cs"/>
                         </a:rPr>
@@ -1004,7 +1001,7 @@
                           <a:solidFill>
                             <a:schemeClr val="tx1"/>
                           </a:solidFill>
-                          <a:latin typeface="Kim jung chul Gothic Regular" panose="020B0503000000000000" pitchFamily="50" charset="-127"/>
+                          <a:latin typeface="Cambria Math" panose="02040503050406030204" pitchFamily="18" charset="0"/>
                           <a:ea typeface="Kim jung chul Gothic Regular" panose="020B0503000000000000" pitchFamily="50" charset="-127"/>
                           <a:cs typeface="+mn-cs"/>
                         </a:rPr>
@@ -1018,7 +1015,7 @@
                               <a:solidFill>
                                 <a:schemeClr val="tx1"/>
                               </a:solidFill>
-                              <a:latin typeface="Kim jung chul Gothic Regular" panose="020B0503000000000000" pitchFamily="50" charset="-127"/>
+                              <a:latin typeface="Cambria Math" panose="02040503050406030204" pitchFamily="18" charset="0"/>
                               <a:ea typeface="Kim jung chul Gothic Regular" panose="020B0503000000000000" pitchFamily="50" charset="-127"/>
                               <a:cs typeface="+mn-cs"/>
                             </a:rPr>
@@ -1030,7 +1027,7 @@
                               <a:solidFill>
                                 <a:schemeClr val="tx1"/>
                               </a:solidFill>
-                              <a:latin typeface="Kim jung chul Gothic Regular" panose="020B0503000000000000" pitchFamily="50" charset="-127"/>
+                              <a:latin typeface="Cambria Math" panose="02040503050406030204" pitchFamily="18" charset="0"/>
                               <a:ea typeface="Kim jung chul Gothic Regular" panose="020B0503000000000000" pitchFamily="50" charset="-127"/>
                               <a:cs typeface="+mn-cs"/>
                             </a:rPr>
@@ -1043,7 +1040,7 @@
                           <a:solidFill>
                             <a:schemeClr val="tx1"/>
                           </a:solidFill>
-                          <a:latin typeface="Kim jung chul Gothic Regular" panose="020B0503000000000000" pitchFamily="50" charset="-127"/>
+                          <a:latin typeface="Cambria Math" panose="02040503050406030204" pitchFamily="18" charset="0"/>
                           <a:ea typeface="Kim jung chul Gothic Regular" panose="020B0503000000000000" pitchFamily="50" charset="-127"/>
                           <a:cs typeface="+mn-cs"/>
                         </a:rPr>
@@ -1054,7 +1051,7 @@
                           <a:solidFill>
                             <a:schemeClr val="tx1"/>
                           </a:solidFill>
-                          <a:latin typeface="Kim jung chul Gothic Regular" panose="020B0503000000000000" pitchFamily="50" charset="-127"/>
+                          <a:latin typeface="Cambria Math" panose="02040503050406030204" pitchFamily="18" charset="0"/>
                           <a:ea typeface="Kim jung chul Gothic Regular" panose="020B0503000000000000" pitchFamily="50" charset="-127"/>
                           <a:cs typeface="+mn-cs"/>
                         </a:rPr>
@@ -1133,7 +1130,7 @@
             </p:txBody>
           </p:sp>
         </mc:Choice>
-        <mc:Fallback>
+        <mc:Fallback xmlns="">
           <p:sp>
             <p:nvSpPr>
               <p:cNvPr id="3" name="슬라이드 노트 개체 틀 2"/>
@@ -1813,9 +1810,101 @@
           <a:lstStyle/>
           <a:p>
             <a:r>
-              <a:rPr lang="ko-KR" altLang="en-US" dirty="0"/>
-              <a:t>모델이 패턴이 아니라 데이터 자체를 암기했기 때문</a:t>
-            </a:r>
+              <a:rPr lang="ko-KR" altLang="en-US" sz="1200" b="0" i="0" kern="1200" dirty="0">
+                <a:solidFill>
+                  <a:schemeClr val="tx1"/>
+                </a:solidFill>
+                <a:effectLst/>
+                <a:latin typeface="Kim jung chul Gothic Regular" panose="020B0503000000000000" pitchFamily="50" charset="-127"/>
+                <a:ea typeface="Kim jung chul Gothic Regular" panose="020B0503000000000000" pitchFamily="50" charset="-127"/>
+                <a:cs typeface="+mn-cs"/>
+              </a:rPr>
+              <a:t>과적합을 해결하려면 </a:t>
+            </a:r>
+            <a:endParaRPr lang="en-US" altLang="ko-KR" sz="1200" b="0" i="0" kern="1200" dirty="0">
+              <a:solidFill>
+                <a:schemeClr val="tx1"/>
+              </a:solidFill>
+              <a:effectLst/>
+              <a:latin typeface="Kim jung chul Gothic Regular" panose="020B0503000000000000" pitchFamily="50" charset="-127"/>
+              <a:ea typeface="Kim jung chul Gothic Regular" panose="020B0503000000000000" pitchFamily="50" charset="-127"/>
+              <a:cs typeface="+mn-cs"/>
+            </a:endParaRPr>
+          </a:p>
+          <a:p>
+            <a:r>
+              <a:rPr lang="en-US" altLang="ko-KR" sz="1200" b="0" i="0" kern="1200" dirty="0">
+                <a:solidFill>
+                  <a:schemeClr val="tx1"/>
+                </a:solidFill>
+                <a:effectLst/>
+                <a:latin typeface="Kim jung chul Gothic Regular" panose="020B0503000000000000" pitchFamily="50" charset="-127"/>
+                <a:ea typeface="Kim jung chul Gothic Regular" panose="020B0503000000000000" pitchFamily="50" charset="-127"/>
+                <a:cs typeface="+mn-cs"/>
+              </a:rPr>
+              <a:t>train loss</a:t>
+            </a:r>
+            <a:r>
+              <a:rPr lang="ko-KR" altLang="en-US" sz="1200" b="0" i="0" kern="1200" dirty="0">
+                <a:solidFill>
+                  <a:schemeClr val="tx1"/>
+                </a:solidFill>
+                <a:effectLst/>
+                <a:latin typeface="Kim jung chul Gothic Regular" panose="020B0503000000000000" pitchFamily="50" charset="-127"/>
+                <a:ea typeface="Kim jung chul Gothic Regular" panose="020B0503000000000000" pitchFamily="50" charset="-127"/>
+                <a:cs typeface="+mn-cs"/>
+              </a:rPr>
+              <a:t>는 약간 증가하지만 결과적으로</a:t>
+            </a:r>
+            <a:r>
+              <a:rPr lang="en-US" altLang="ko-KR" sz="1200" b="0" i="0" kern="1200" dirty="0">
+                <a:solidFill>
+                  <a:schemeClr val="tx1"/>
+                </a:solidFill>
+                <a:effectLst/>
+                <a:latin typeface="Kim jung chul Gothic Regular" panose="020B0503000000000000" pitchFamily="50" charset="-127"/>
+                <a:ea typeface="Kim jung chul Gothic Regular" panose="020B0503000000000000" pitchFamily="50" charset="-127"/>
+                <a:cs typeface="+mn-cs"/>
+              </a:rPr>
+              <a:t>, validation loss</a:t>
+            </a:r>
+            <a:r>
+              <a:rPr lang="ko-KR" altLang="en-US" sz="1200" b="0" i="0" kern="1200" dirty="0">
+                <a:solidFill>
+                  <a:schemeClr val="tx1"/>
+                </a:solidFill>
+                <a:effectLst/>
+                <a:latin typeface="Kim jung chul Gothic Regular" panose="020B0503000000000000" pitchFamily="50" charset="-127"/>
+                <a:ea typeface="Kim jung chul Gothic Regular" panose="020B0503000000000000" pitchFamily="50" charset="-127"/>
+                <a:cs typeface="+mn-cs"/>
+              </a:rPr>
+              <a:t>나 최종 </a:t>
+            </a:r>
+            <a:r>
+              <a:rPr lang="en-US" altLang="ko-KR" sz="1200" b="0" i="0" kern="1200" dirty="0">
+                <a:solidFill>
+                  <a:schemeClr val="tx1"/>
+                </a:solidFill>
+                <a:effectLst/>
+                <a:latin typeface="Kim jung chul Gothic Regular" panose="020B0503000000000000" pitchFamily="50" charset="-127"/>
+                <a:ea typeface="Kim jung chul Gothic Regular" panose="020B0503000000000000" pitchFamily="50" charset="-127"/>
+                <a:cs typeface="+mn-cs"/>
+              </a:rPr>
+              <a:t>test loss</a:t>
+            </a:r>
+            <a:r>
+              <a:rPr lang="ko-KR" altLang="en-US" sz="1200" b="0" i="0" kern="1200" dirty="0">
+                <a:solidFill>
+                  <a:schemeClr val="tx1"/>
+                </a:solidFill>
+                <a:effectLst/>
+                <a:latin typeface="Kim jung chul Gothic Regular" panose="020B0503000000000000" pitchFamily="50" charset="-127"/>
+                <a:ea typeface="Kim jung chul Gothic Regular" panose="020B0503000000000000" pitchFamily="50" charset="-127"/>
+                <a:cs typeface="+mn-cs"/>
+              </a:rPr>
+              <a:t>를 감소시키려는 목적을 가진다</a:t>
+            </a:r>
+            <a:endParaRPr lang="ko-KR" altLang="en-US" dirty="0"/>
           </a:p>
         </p:txBody>
       </p:sp>
@@ -1837,7 +1926,7 @@
             <a:fld id="{3E35EA20-6519-4513-9EDC-C89C5369BAEC}" type="slidenum">
               <a:rPr lang="ko-KR" altLang="en-US" smtClean="0"/>
               <a:pPr/>
-              <a:t>24</a:t>
+              <a:t>23</a:t>
             </a:fld>
             <a:endParaRPr lang="ko-KR" altLang="en-US" dirty="0"/>
           </a:p>
@@ -1846,7 +1935,7 @@
     </p:spTree>
     <p:extLst>
       <p:ext uri="{BB962C8B-B14F-4D97-AF65-F5344CB8AC3E}">
-        <p14:creationId xmlns:p14="http://schemas.microsoft.com/office/powerpoint/2010/main" val="4083919061"/>
+        <p14:creationId xmlns:p14="http://schemas.microsoft.com/office/powerpoint/2010/main" val="834884099"/>
       </p:ext>
     </p:extLst>
   </p:cSld>
@@ -1902,18 +1991,7 @@
           <a:p>
             <a:r>
               <a:rPr lang="ko-KR" altLang="en-US" dirty="0"/>
-              <a:t>훈련할 때 일부 뉴런을 랜덤하게 끕니다</a:t>
-            </a:r>
-            <a:endParaRPr lang="en-US" altLang="ko-KR" dirty="0"/>
-          </a:p>
-          <a:p>
-            <a:r>
-              <a:rPr lang="en-US" altLang="ko-KR" dirty="0"/>
-              <a:t>-&gt; </a:t>
-            </a:r>
-            <a:r>
-              <a:rPr lang="ko-KR" altLang="en-US" dirty="0"/>
-              <a:t>모델이 특정 경로에만 의존하지 못하게 하기 위해</a:t>
+              <a:t>모델이 패턴이 아니라 데이터 자체를 암기했기 때문</a:t>
             </a:r>
           </a:p>
         </p:txBody>
@@ -1936,7 +2014,7 @@
             <a:fld id="{3E35EA20-6519-4513-9EDC-C89C5369BAEC}" type="slidenum">
               <a:rPr lang="ko-KR" altLang="en-US" smtClean="0"/>
               <a:pPr/>
-              <a:t>27</a:t>
+              <a:t>24</a:t>
             </a:fld>
             <a:endParaRPr lang="ko-KR" altLang="en-US" dirty="0"/>
           </a:p>
@@ -1945,7 +2023,7 @@
     </p:spTree>
     <p:extLst>
       <p:ext uri="{BB962C8B-B14F-4D97-AF65-F5344CB8AC3E}">
-        <p14:creationId xmlns:p14="http://schemas.microsoft.com/office/powerpoint/2010/main" val="4205139593"/>
+        <p14:creationId xmlns:p14="http://schemas.microsoft.com/office/powerpoint/2010/main" val="4083919061"/>
       </p:ext>
     </p:extLst>
   </p:cSld>
@@ -1960,13 +2038,7 @@
   <p:cSld>
     <p:spTree>
       <p:nvGrpSpPr>
-        <p:cNvPr id="1" name="">
-          <a:extLst>
-            <a:ext uri="{FF2B5EF4-FFF2-40B4-BE49-F238E27FC236}">
-              <a16:creationId xmlns:a16="http://schemas.microsoft.com/office/drawing/2014/main" id="{A9D2EE83-52CB-E118-49CB-3EBDD6EF25B9}"/>
-            </a:ext>
-          </a:extLst>
-        </p:cNvPr>
+        <p:cNvPr id="1" name=""/>
         <p:cNvGrpSpPr/>
         <p:nvPr/>
       </p:nvGrpSpPr>
@@ -1980,13 +2052,7 @@
       </p:grpSpPr>
       <p:sp>
         <p:nvSpPr>
-          <p:cNvPr id="2" name="슬라이드 이미지 개체 틀 1">
-            <a:extLst>
-              <a:ext uri="{FF2B5EF4-FFF2-40B4-BE49-F238E27FC236}">
-                <a16:creationId xmlns:a16="http://schemas.microsoft.com/office/drawing/2014/main" id="{30F83B01-3943-C359-9322-8EB719FB824B}"/>
-              </a:ext>
-            </a:extLst>
-          </p:cNvPr>
+          <p:cNvPr id="2" name="슬라이드 이미지 개체 틀 1"/>
           <p:cNvSpPr>
             <a:spLocks noGrp="1" noRot="1" noChangeAspect="1"/>
           </p:cNvSpPr>
@@ -1998,13 +2064,7 @@
       </p:sp>
       <p:sp>
         <p:nvSpPr>
-          <p:cNvPr id="3" name="슬라이드 노트 개체 틀 2">
-            <a:extLst>
-              <a:ext uri="{FF2B5EF4-FFF2-40B4-BE49-F238E27FC236}">
-                <a16:creationId xmlns:a16="http://schemas.microsoft.com/office/drawing/2014/main" id="{F2F259CF-8156-0FB2-87BB-C2421F329EA1}"/>
-              </a:ext>
-            </a:extLst>
-          </p:cNvPr>
+          <p:cNvPr id="3" name="슬라이드 노트 개체 틀 2"/>
           <p:cNvSpPr>
             <a:spLocks noGrp="1"/>
           </p:cNvSpPr>
@@ -2017,24 +2077,32 @@
           <a:bodyPr/>
           <a:lstStyle/>
           <a:p>
-            <a:endParaRPr lang="ko-KR" altLang="en-US" dirty="0"/>
+            <a:r>
+              <a:rPr lang="ko-KR" altLang="en-US" dirty="0"/>
+              <a:t>훈련할 때 일부 뉴런을 랜덤하게 끕니다</a:t>
+            </a:r>
+            <a:endParaRPr lang="en-US" altLang="ko-KR" dirty="0"/>
+          </a:p>
+          <a:p>
+            <a:r>
+              <a:rPr lang="en-US" altLang="ko-KR" dirty="0"/>
+              <a:t>-&gt; </a:t>
+            </a:r>
+            <a:r>
+              <a:rPr lang="ko-KR" altLang="en-US" dirty="0"/>
+              <a:t>모델이 특정 경로에만 의존하지 못하게 하기 위해</a:t>
+            </a:r>
           </a:p>
         </p:txBody>
       </p:sp>
       <p:sp>
         <p:nvSpPr>
-          <p:cNvPr id="4" name="슬라이드 번호 개체 틀 3">
-            <a:extLst>
-              <a:ext uri="{FF2B5EF4-FFF2-40B4-BE49-F238E27FC236}">
-                <a16:creationId xmlns:a16="http://schemas.microsoft.com/office/drawing/2014/main" id="{5301DD34-5BFE-877A-E657-9B3A6B1B5CDD}"/>
-              </a:ext>
-            </a:extLst>
-          </p:cNvPr>
+          <p:cNvPr id="4" name="슬라이드 번호 개체 틀 3"/>
           <p:cNvSpPr>
             <a:spLocks noGrp="1"/>
           </p:cNvSpPr>
           <p:nvPr>
-            <p:ph type="sldNum" sz="quarter" idx="10"/>
+            <p:ph type="sldNum" sz="quarter" idx="5"/>
           </p:nvPr>
         </p:nvSpPr>
         <p:spPr/>
@@ -2042,18 +2110,19 @@
           <a:bodyPr/>
           <a:lstStyle/>
           <a:p>
-            <a:fld id="{A0085365-8376-4996-BDD6-F39608FADAF3}" type="slidenum">
+            <a:fld id="{3E35EA20-6519-4513-9EDC-C89C5369BAEC}" type="slidenum">
               <a:rPr lang="ko-KR" altLang="en-US" smtClean="0"/>
-              <a:t>37</a:t>
+              <a:pPr/>
+              <a:t>27</a:t>
             </a:fld>
-            <a:endParaRPr lang="ko-KR" altLang="en-US"/>
+            <a:endParaRPr lang="ko-KR" altLang="en-US" dirty="0"/>
           </a:p>
         </p:txBody>
       </p:sp>
     </p:spTree>
     <p:extLst>
       <p:ext uri="{BB962C8B-B14F-4D97-AF65-F5344CB8AC3E}">
-        <p14:creationId xmlns:p14="http://schemas.microsoft.com/office/powerpoint/2010/main" val="2391645545"/>
+        <p14:creationId xmlns:p14="http://schemas.microsoft.com/office/powerpoint/2010/main" val="4205139593"/>
       </p:ext>
     </p:extLst>
   </p:cSld>
@@ -2176,6 +2245,1152 @@
     <p:extLst>
       <p:ext uri="{BB962C8B-B14F-4D97-AF65-F5344CB8AC3E}">
         <p14:creationId xmlns:p14="http://schemas.microsoft.com/office/powerpoint/2010/main" val="4276040896"/>
+      </p:ext>
+    </p:extLst>
+  </p:cSld>
+  <p:clrMapOvr>
+    <a:masterClrMapping/>
+  </p:clrMapOvr>
+</p:notes>
+</file>
+
+<file path=ppt/notesSlides/notesSlide20.xml><?xml version="1.0" encoding="utf-8"?>
+<p:notes xmlns:a="http://schemas.openxmlformats.org/drawingml/2006/main" xmlns:r="http://schemas.openxmlformats.org/officeDocument/2006/relationships" xmlns:p="http://schemas.openxmlformats.org/presentationml/2006/main">
+  <p:cSld>
+    <p:spTree>
+      <p:nvGrpSpPr>
+        <p:cNvPr id="1" name=""/>
+        <p:cNvGrpSpPr/>
+        <p:nvPr/>
+      </p:nvGrpSpPr>
+      <p:grpSpPr>
+        <a:xfrm>
+          <a:off x="0" y="0"/>
+          <a:ext cx="0" cy="0"/>
+          <a:chOff x="0" y="0"/>
+          <a:chExt cx="0" cy="0"/>
+        </a:xfrm>
+      </p:grpSpPr>
+      <p:sp>
+        <p:nvSpPr>
+          <p:cNvPr id="2" name="슬라이드 이미지 개체 틀 1"/>
+          <p:cNvSpPr>
+            <a:spLocks noGrp="1" noRot="1" noChangeAspect="1"/>
+          </p:cNvSpPr>
+          <p:nvPr>
+            <p:ph type="sldImg"/>
+          </p:nvPr>
+        </p:nvSpPr>
+        <p:spPr/>
+      </p:sp>
+      <p:sp>
+        <p:nvSpPr>
+          <p:cNvPr id="3" name="슬라이드 노트 개체 틀 2"/>
+          <p:cNvSpPr>
+            <a:spLocks noGrp="1"/>
+          </p:cNvSpPr>
+          <p:nvPr>
+            <p:ph type="body" idx="1"/>
+          </p:nvPr>
+        </p:nvSpPr>
+        <p:spPr/>
+        <p:txBody>
+          <a:bodyPr/>
+          <a:lstStyle/>
+          <a:p>
+            <a:r>
+              <a:rPr lang="ko-KR" altLang="en-US" dirty="0"/>
+              <a:t>오차만 줄이는 게 아니라</a:t>
+            </a:r>
+            <a:r>
+              <a:rPr lang="en-US" altLang="ko-KR" dirty="0"/>
+              <a:t>,</a:t>
+            </a:r>
+            <a:br>
+              <a:rPr lang="en-US" altLang="ko-KR" dirty="0"/>
+            </a:br>
+            <a:r>
+              <a:rPr lang="en-US" altLang="ko-KR" dirty="0"/>
+              <a:t>“</a:t>
+            </a:r>
+            <a:r>
+              <a:rPr lang="ko-KR" altLang="en-US" dirty="0"/>
+              <a:t>가중치 크기까지 함께 </a:t>
+            </a:r>
+            <a:r>
+              <a:rPr lang="ko-KR" altLang="en-US" dirty="0" err="1"/>
+              <a:t>제어”하겠다는</a:t>
+            </a:r>
+            <a:r>
+              <a:rPr lang="ko-KR" altLang="en-US" dirty="0"/>
+              <a:t> 것</a:t>
+            </a:r>
+            <a:endParaRPr lang="en-US" altLang="ko-KR" dirty="0"/>
+          </a:p>
+          <a:p>
+            <a:endParaRPr lang="en-US" altLang="ko-KR" dirty="0"/>
+          </a:p>
+          <a:p>
+            <a:r>
+              <a:rPr lang="ko-KR" altLang="en-US" dirty="0"/>
+              <a:t>이미지는 뒤에서 활용</a:t>
+            </a:r>
+          </a:p>
+        </p:txBody>
+      </p:sp>
+      <p:sp>
+        <p:nvSpPr>
+          <p:cNvPr id="4" name="슬라이드 번호 개체 틀 3"/>
+          <p:cNvSpPr>
+            <a:spLocks noGrp="1"/>
+          </p:cNvSpPr>
+          <p:nvPr>
+            <p:ph type="sldNum" sz="quarter" idx="5"/>
+          </p:nvPr>
+        </p:nvSpPr>
+        <p:spPr/>
+        <p:txBody>
+          <a:bodyPr/>
+          <a:lstStyle/>
+          <a:p>
+            <a:fld id="{3E35EA20-6519-4513-9EDC-C89C5369BAEC}" type="slidenum">
+              <a:rPr lang="ko-KR" altLang="en-US" smtClean="0"/>
+              <a:pPr/>
+              <a:t>29</a:t>
+            </a:fld>
+            <a:endParaRPr lang="ko-KR" altLang="en-US" dirty="0"/>
+          </a:p>
+        </p:txBody>
+      </p:sp>
+    </p:spTree>
+    <p:extLst>
+      <p:ext uri="{BB962C8B-B14F-4D97-AF65-F5344CB8AC3E}">
+        <p14:creationId xmlns:p14="http://schemas.microsoft.com/office/powerpoint/2010/main" val="1738745894"/>
+      </p:ext>
+    </p:extLst>
+  </p:cSld>
+  <p:clrMapOvr>
+    <a:masterClrMapping/>
+  </p:clrMapOvr>
+</p:notes>
+</file>
+
+<file path=ppt/notesSlides/notesSlide21.xml><?xml version="1.0" encoding="utf-8"?>
+<p:notes xmlns:a="http://schemas.openxmlformats.org/drawingml/2006/main" xmlns:r="http://schemas.openxmlformats.org/officeDocument/2006/relationships" xmlns:p="http://schemas.openxmlformats.org/presentationml/2006/main">
+  <p:cSld>
+    <p:spTree>
+      <p:nvGrpSpPr>
+        <p:cNvPr id="1" name=""/>
+        <p:cNvGrpSpPr/>
+        <p:nvPr/>
+      </p:nvGrpSpPr>
+      <p:grpSpPr>
+        <a:xfrm>
+          <a:off x="0" y="0"/>
+          <a:ext cx="0" cy="0"/>
+          <a:chOff x="0" y="0"/>
+          <a:chExt cx="0" cy="0"/>
+        </a:xfrm>
+      </p:grpSpPr>
+      <p:sp>
+        <p:nvSpPr>
+          <p:cNvPr id="2" name="슬라이드 이미지 개체 틀 1"/>
+          <p:cNvSpPr>
+            <a:spLocks noGrp="1" noRot="1" noChangeAspect="1"/>
+          </p:cNvSpPr>
+          <p:nvPr>
+            <p:ph type="sldImg"/>
+          </p:nvPr>
+        </p:nvSpPr>
+        <p:spPr/>
+      </p:sp>
+      <mc:AlternateContent xmlns:mc="http://schemas.openxmlformats.org/markup-compatibility/2006">
+        <mc:Choice xmlns:a14="http://schemas.microsoft.com/office/drawing/2010/main" Requires="a14">
+          <p:sp>
+            <p:nvSpPr>
+              <p:cNvPr id="3" name="슬라이드 노트 개체 틀 2"/>
+              <p:cNvSpPr>
+                <a:spLocks noGrp="1"/>
+              </p:cNvSpPr>
+              <p:nvPr>
+                <p:ph type="body" idx="1"/>
+              </p:nvPr>
+            </p:nvSpPr>
+            <p:spPr/>
+            <p:txBody>
+              <a:bodyPr/>
+              <a:lstStyle/>
+              <a:p>
+                <a:r>
+                  <a:rPr lang="ko-KR" altLang="en-US" dirty="0"/>
+                  <a:t>가중치 절댓값의 합을 더함</a:t>
+                </a:r>
+                <a:endParaRPr lang="en-US" altLang="ko-KR" dirty="0"/>
+              </a:p>
+              <a:p>
+                <a:endParaRPr lang="en-US" altLang="ko-KR" dirty="0"/>
+              </a:p>
+              <a:p>
+                <a:r>
+                  <a:rPr lang="ko-KR" altLang="en-US" dirty="0"/>
+                  <a:t>마름모는 모서리가 있기 때문에</a:t>
+                </a:r>
+                <a:br>
+                  <a:rPr lang="ko-KR" altLang="en-US" dirty="0"/>
+                </a:br>
+                <a:r>
+                  <a:rPr lang="ko-KR" altLang="en-US" dirty="0"/>
+                  <a:t>등고선이 </a:t>
+                </a:r>
+                <a:r>
+                  <a:rPr lang="ko-KR" altLang="en-US" b="1" dirty="0"/>
+                  <a:t>꼭짓점에서 만날 확률이 높음</a:t>
+                </a:r>
+                <a:r>
+                  <a:rPr lang="en-US" altLang="ko-KR" dirty="0"/>
+                  <a:t>.</a:t>
+                </a:r>
+              </a:p>
+              <a:p>
+                <a:r>
+                  <a:rPr lang="ko-KR" altLang="en-US" dirty="0"/>
+                  <a:t>그 꼭짓점은</a:t>
+                </a:r>
+                <a:r>
+                  <a:rPr lang="en-US" altLang="ko-KR" dirty="0"/>
+                  <a:t>:</a:t>
+                </a:r>
+                <a:r>
+                  <a:rPr lang="en-US" altLang="ko-KR" baseline="0" dirty="0"/>
+                  <a:t>        </a:t>
+                </a:r>
+                <a14:m>
+                  <m:oMath xmlns:m="http://schemas.openxmlformats.org/officeDocument/2006/math">
+                    <m:sSub>
+                      <m:sSubPr>
+                        <m:ctrlPr>
+                          <a:rPr lang="ko-KR" altLang="en-US" sz="1200" kern="1200">
+                            <a:solidFill>
+                              <a:schemeClr val="tx1"/>
+                            </a:solidFill>
+                            <a:latin typeface="Kim jung chul Gothic Regular" panose="020B0503000000000000" pitchFamily="50" charset="-127"/>
+                            <a:ea typeface="Kim jung chul Gothic Regular" panose="020B0503000000000000" pitchFamily="50" charset="-127"/>
+                            <a:cs typeface="+mn-cs"/>
+                          </a:rPr>
+                        </m:ctrlPr>
+                      </m:sSubPr>
+                      <m:e>
+                        <m:r>
+                          <a:rPr lang="ko-KR" altLang="en-US" sz="1200" i="1" kern="1200">
+                            <a:solidFill>
+                              <a:schemeClr val="tx1"/>
+                            </a:solidFill>
+                            <a:latin typeface="Kim jung chul Gothic Regular" panose="020B0503000000000000" pitchFamily="50" charset="-127"/>
+                            <a:ea typeface="Kim jung chul Gothic Regular" panose="020B0503000000000000" pitchFamily="50" charset="-127"/>
+                            <a:cs typeface="+mn-cs"/>
+                          </a:rPr>
+                          <m:t>𝑤</m:t>
+                        </m:r>
+                      </m:e>
+                      <m:sub>
+                        <m:r>
+                          <a:rPr lang="en-US" altLang="ko-KR" sz="1200" i="0" kern="1200">
+                            <a:solidFill>
+                              <a:schemeClr val="tx1"/>
+                            </a:solidFill>
+                            <a:latin typeface="Kim jung chul Gothic Regular" panose="020B0503000000000000" pitchFamily="50" charset="-127"/>
+                            <a:ea typeface="Kim jung chul Gothic Regular" panose="020B0503000000000000" pitchFamily="50" charset="-127"/>
+                            <a:cs typeface="+mn-cs"/>
+                          </a:rPr>
+                          <m:t>1</m:t>
+                        </m:r>
+                      </m:sub>
+                    </m:sSub>
+                    <m:r>
+                      <a:rPr lang="en-US" altLang="ko-KR" sz="1200" i="0" kern="1200">
+                        <a:solidFill>
+                          <a:schemeClr val="tx1"/>
+                        </a:solidFill>
+                        <a:latin typeface="Kim jung chul Gothic Regular" panose="020B0503000000000000" pitchFamily="50" charset="-127"/>
+                        <a:ea typeface="Kim jung chul Gothic Regular" panose="020B0503000000000000" pitchFamily="50" charset="-127"/>
+                        <a:cs typeface="+mn-cs"/>
+                      </a:rPr>
+                      <m:t>=</m:t>
+                    </m:r>
+                    <m:r>
+                      <a:rPr lang="en-US" altLang="ko-KR" sz="1200" i="0" kern="1200">
+                        <a:solidFill>
+                          <a:schemeClr val="tx1"/>
+                        </a:solidFill>
+                        <a:latin typeface="Kim jung chul Gothic Regular" panose="020B0503000000000000" pitchFamily="50" charset="-127"/>
+                        <a:ea typeface="Kim jung chul Gothic Regular" panose="020B0503000000000000" pitchFamily="50" charset="-127"/>
+                        <a:cs typeface="+mn-cs"/>
+                      </a:rPr>
+                      <m:t>0</m:t>
+                    </m:r>
+                    <m:r>
+                      <a:rPr lang="en-US" altLang="ko-KR" sz="1200" i="0" kern="1200">
+                        <a:solidFill>
+                          <a:schemeClr val="tx1"/>
+                        </a:solidFill>
+                        <a:latin typeface="Kim jung chul Gothic Regular" panose="020B0503000000000000" pitchFamily="50" charset="-127"/>
+                        <a:ea typeface="Kim jung chul Gothic Regular" panose="020B0503000000000000" pitchFamily="50" charset="-127"/>
+                        <a:cs typeface="+mn-cs"/>
+                      </a:rPr>
+                      <m:t> </m:t>
+                    </m:r>
+                    <m:r>
+                      <m:rPr>
+                        <m:nor/>
+                      </m:rPr>
+                      <a:rPr lang="ko-KR" altLang="en-US" sz="1200" b="0" i="1" kern="1200">
+                        <a:solidFill>
+                          <a:schemeClr val="tx1"/>
+                        </a:solidFill>
+                        <a:latin typeface="Kim jung chul Gothic Regular" panose="020B0503000000000000" pitchFamily="50" charset="-127"/>
+                        <a:ea typeface="Kim jung chul Gothic Regular" panose="020B0503000000000000" pitchFamily="50" charset="-127"/>
+                        <a:cs typeface="+mn-cs"/>
+                      </a:rPr>
+                      <m:t>또는</m:t>
+                    </m:r>
+                    <m:r>
+                      <a:rPr lang="ko-KR" altLang="en-US" sz="1200" b="0" i="0" kern="1200">
+                        <a:solidFill>
+                          <a:schemeClr val="tx1"/>
+                        </a:solidFill>
+                        <a:latin typeface="Kim jung chul Gothic Regular" panose="020B0503000000000000" pitchFamily="50" charset="-127"/>
+                        <a:ea typeface="Kim jung chul Gothic Regular" panose="020B0503000000000000" pitchFamily="50" charset="-127"/>
+                        <a:cs typeface="+mn-cs"/>
+                      </a:rPr>
+                      <m:t> </m:t>
+                    </m:r>
+                    <m:sSub>
+                      <m:sSubPr>
+                        <m:ctrlPr>
+                          <a:rPr lang="ko-KR" altLang="en-US" sz="1200" b="0" i="1" kern="1200">
+                            <a:solidFill>
+                              <a:schemeClr val="tx1"/>
+                            </a:solidFill>
+                            <a:latin typeface="Kim jung chul Gothic Regular" panose="020B0503000000000000" pitchFamily="50" charset="-127"/>
+                            <a:ea typeface="Kim jung chul Gothic Regular" panose="020B0503000000000000" pitchFamily="50" charset="-127"/>
+                            <a:cs typeface="+mn-cs"/>
+                          </a:rPr>
+                        </m:ctrlPr>
+                      </m:sSubPr>
+                      <m:e>
+                        <m:r>
+                          <a:rPr lang="ko-KR" altLang="en-US" sz="1200" b="0" i="1" kern="1200">
+                            <a:solidFill>
+                              <a:schemeClr val="tx1"/>
+                            </a:solidFill>
+                            <a:latin typeface="Kim jung chul Gothic Regular" panose="020B0503000000000000" pitchFamily="50" charset="-127"/>
+                            <a:ea typeface="Kim jung chul Gothic Regular" panose="020B0503000000000000" pitchFamily="50" charset="-127"/>
+                            <a:cs typeface="+mn-cs"/>
+                          </a:rPr>
+                          <m:t>𝑤</m:t>
+                        </m:r>
+                      </m:e>
+                      <m:sub>
+                        <m:r>
+                          <a:rPr lang="en-US" altLang="ko-KR" sz="1200" b="0" i="0" kern="1200">
+                            <a:solidFill>
+                              <a:schemeClr val="tx1"/>
+                            </a:solidFill>
+                            <a:latin typeface="Kim jung chul Gothic Regular" panose="020B0503000000000000" pitchFamily="50" charset="-127"/>
+                            <a:ea typeface="Kim jung chul Gothic Regular" panose="020B0503000000000000" pitchFamily="50" charset="-127"/>
+                            <a:cs typeface="+mn-cs"/>
+                          </a:rPr>
+                          <m:t>2</m:t>
+                        </m:r>
+                      </m:sub>
+                    </m:sSub>
+                    <m:r>
+                      <a:rPr lang="en-US" altLang="ko-KR" sz="1200" b="0" i="0" kern="1200">
+                        <a:solidFill>
+                          <a:schemeClr val="tx1"/>
+                        </a:solidFill>
+                        <a:latin typeface="Kim jung chul Gothic Regular" panose="020B0503000000000000" pitchFamily="50" charset="-127"/>
+                        <a:ea typeface="Kim jung chul Gothic Regular" panose="020B0503000000000000" pitchFamily="50" charset="-127"/>
+                        <a:cs typeface="+mn-cs"/>
+                      </a:rPr>
+                      <m:t>=</m:t>
+                    </m:r>
+                    <m:r>
+                      <a:rPr lang="en-US" altLang="ko-KR" sz="1200" b="0" i="0" kern="1200">
+                        <a:solidFill>
+                          <a:schemeClr val="tx1"/>
+                        </a:solidFill>
+                        <a:latin typeface="Kim jung chul Gothic Regular" panose="020B0503000000000000" pitchFamily="50" charset="-127"/>
+                        <a:ea typeface="Kim jung chul Gothic Regular" panose="020B0503000000000000" pitchFamily="50" charset="-127"/>
+                        <a:cs typeface="+mn-cs"/>
+                      </a:rPr>
+                      <m:t>0</m:t>
+                    </m:r>
+                  </m:oMath>
+                </a14:m>
+                <a:endParaRPr lang="ko-KR" altLang="en-US" b="0" dirty="0"/>
+              </a:p>
+              <a:p>
+                <a:r>
+                  <a:rPr lang="ko-KR" altLang="en-US" dirty="0"/>
+                  <a:t>그래서</a:t>
+                </a:r>
+              </a:p>
+              <a:p>
+                <a:r>
+                  <a:rPr lang="ko-KR" altLang="en-US" dirty="0"/>
+                  <a:t>일부 가중치가 정확히 </a:t>
+                </a:r>
+                <a:r>
+                  <a:rPr lang="en-US" altLang="ko-KR" dirty="0"/>
+                  <a:t>0</a:t>
+                </a:r>
+                <a:r>
+                  <a:rPr lang="ko-KR" altLang="en-US" dirty="0"/>
+                  <a:t>이 됨</a:t>
+                </a:r>
+              </a:p>
+              <a:p>
+                <a:r>
+                  <a:rPr lang="ko-KR" altLang="en-US" dirty="0"/>
+                  <a:t>이게 </a:t>
+                </a:r>
+                <a:r>
+                  <a:rPr lang="en-US" altLang="ko-KR" dirty="0"/>
+                  <a:t>PPT</a:t>
+                </a:r>
+                <a:r>
+                  <a:rPr lang="ko-KR" altLang="en-US" dirty="0"/>
+                  <a:t>에서 말하는</a:t>
+                </a:r>
+                <a:r>
+                  <a:rPr lang="en-US" altLang="ko-KR" dirty="0"/>
+                  <a:t>:</a:t>
+                </a:r>
+              </a:p>
+              <a:p>
+                <a:r>
+                  <a:rPr lang="en-US" altLang="ko-KR" dirty="0"/>
+                  <a:t>Feature selection </a:t>
+                </a:r>
+                <a:r>
+                  <a:rPr lang="ko-KR" altLang="en-US" dirty="0"/>
+                  <a:t>효과</a:t>
+                </a:r>
+              </a:p>
+              <a:p>
+                <a:r>
+                  <a:rPr lang="ko-KR" altLang="en-US" dirty="0"/>
+                  <a:t>입니다</a:t>
+                </a:r>
+                <a:r>
+                  <a:rPr lang="en-US" altLang="ko-KR" dirty="0"/>
+                  <a:t>.</a:t>
+                </a:r>
+              </a:p>
+              <a:p>
+                <a:endParaRPr lang="en-US" altLang="ko-KR" dirty="0"/>
+              </a:p>
+              <a:p>
+                <a:endParaRPr lang="en-US" altLang="ko-KR" dirty="0"/>
+              </a:p>
+              <a:p>
+                <a:endParaRPr lang="en-US" altLang="ko-KR" dirty="0"/>
+              </a:p>
+              <a:p>
+                <a:r>
+                  <a:rPr lang="ko-KR" altLang="en-US" dirty="0"/>
+                  <a:t>아래 람다</a:t>
+                </a:r>
+                <a:endParaRPr lang="en-US" altLang="ko-KR" dirty="0"/>
+              </a:p>
+              <a:p>
+                <a:r>
+                  <a:rPr lang="ko-KR" altLang="en-US" dirty="0"/>
+                  <a:t>오차에 “절대값 </a:t>
+                </a:r>
+                <a:r>
+                  <a:rPr lang="ko-KR" altLang="en-US" dirty="0" err="1"/>
+                  <a:t>벌점”을</a:t>
+                </a:r>
+                <a:r>
+                  <a:rPr lang="ko-KR" altLang="en-US" dirty="0"/>
+                  <a:t> 추가합니다</a:t>
+                </a:r>
+                <a:r>
+                  <a:rPr lang="en-US" altLang="ko-KR" dirty="0"/>
+                  <a:t>.</a:t>
+                </a:r>
+                <a:br>
+                  <a:rPr lang="en-US" altLang="ko-KR" dirty="0"/>
+                </a:br>
+                <a:r>
+                  <a:rPr lang="ko-KR" altLang="en-US" dirty="0"/>
+                  <a:t>그래서 가중치가 조금이라도 존재하면 계속 벌점을 받습니다</a:t>
+                </a:r>
+                <a:r>
+                  <a:rPr lang="en-US" altLang="ko-KR" dirty="0"/>
+                  <a:t>.</a:t>
+                </a:r>
+                <a:br>
+                  <a:rPr lang="en-US" altLang="ko-KR" dirty="0"/>
+                </a:br>
+                <a:r>
+                  <a:rPr lang="ko-KR" altLang="en-US" dirty="0"/>
+                  <a:t>결국 일부 가중치는 완전히 </a:t>
+                </a:r>
+                <a:r>
+                  <a:rPr lang="en-US" altLang="ko-KR" dirty="0"/>
+                  <a:t>0</a:t>
+                </a:r>
+                <a:r>
+                  <a:rPr lang="ko-KR" altLang="en-US" dirty="0"/>
+                  <a:t>이 됩니다</a:t>
+                </a:r>
+                <a:r>
+                  <a:rPr lang="en-US" altLang="ko-KR" dirty="0"/>
+                  <a:t>.</a:t>
+                </a:r>
+                <a:endParaRPr lang="ko-KR" altLang="en-US" dirty="0"/>
+              </a:p>
+            </p:txBody>
+          </p:sp>
+        </mc:Choice>
+        <mc:Fallback>
+          <p:sp>
+            <p:nvSpPr>
+              <p:cNvPr id="3" name="슬라이드 노트 개체 틀 2"/>
+              <p:cNvSpPr>
+                <a:spLocks noGrp="1"/>
+              </p:cNvSpPr>
+              <p:nvPr>
+                <p:ph type="body" idx="1"/>
+              </p:nvPr>
+            </p:nvSpPr>
+            <p:spPr/>
+            <p:txBody>
+              <a:bodyPr/>
+              <a:lstStyle/>
+              <a:p>
+                <a:r>
+                  <a:rPr lang="ko-KR" altLang="en-US" dirty="0"/>
+                  <a:t>가중치 절댓값의 합을 더함</a:t>
+                </a:r>
+                <a:endParaRPr lang="en-US" altLang="ko-KR" dirty="0"/>
+              </a:p>
+              <a:p>
+                <a:endParaRPr lang="en-US" altLang="ko-KR" dirty="0"/>
+              </a:p>
+              <a:p>
+                <a:r>
+                  <a:rPr lang="ko-KR" altLang="en-US" dirty="0"/>
+                  <a:t>마름모는 모서리가 있기 때문에</a:t>
+                </a:r>
+                <a:br>
+                  <a:rPr lang="ko-KR" altLang="en-US" dirty="0"/>
+                </a:br>
+                <a:r>
+                  <a:rPr lang="ko-KR" altLang="en-US" dirty="0"/>
+                  <a:t>등고선이 </a:t>
+                </a:r>
+                <a:r>
+                  <a:rPr lang="ko-KR" altLang="en-US" b="1" dirty="0"/>
+                  <a:t>꼭짓점에서 만날 확률이 높음</a:t>
+                </a:r>
+                <a:r>
+                  <a:rPr lang="en-US" altLang="ko-KR" dirty="0"/>
+                  <a:t>.</a:t>
+                </a:r>
+              </a:p>
+              <a:p>
+                <a:r>
+                  <a:rPr lang="ko-KR" altLang="en-US" dirty="0"/>
+                  <a:t>그 꼭짓점은</a:t>
+                </a:r>
+                <a:r>
+                  <a:rPr lang="en-US" altLang="ko-KR" dirty="0"/>
+                  <a:t>:</a:t>
+                </a:r>
+                <a:r>
+                  <a:rPr lang="en-US" altLang="ko-KR" baseline="0" dirty="0"/>
+                  <a:t>        </a:t>
+                </a:r>
+                <a:r>
+                  <a:rPr lang="ko-KR" altLang="en-US" sz="1200" i="0" kern="1200">
+                    <a:solidFill>
+                      <a:schemeClr val="tx1"/>
+                    </a:solidFill>
+                    <a:latin typeface="Kim jung chul Gothic Regular" panose="020B0503000000000000" pitchFamily="50" charset="-127"/>
+                    <a:ea typeface="Kim jung chul Gothic Regular" panose="020B0503000000000000" pitchFamily="50" charset="-127"/>
+                    <a:cs typeface="+mn-cs"/>
+                  </a:rPr>
+                  <a:t>𝑤_</a:t>
+                </a:r>
+                <a:r>
+                  <a:rPr lang="en-US" altLang="ko-KR" sz="1200" i="0" kern="1200">
+                    <a:solidFill>
+                      <a:schemeClr val="tx1"/>
+                    </a:solidFill>
+                    <a:latin typeface="Kim jung chul Gothic Regular" panose="020B0503000000000000" pitchFamily="50" charset="-127"/>
+                    <a:ea typeface="Kim jung chul Gothic Regular" panose="020B0503000000000000" pitchFamily="50" charset="-127"/>
+                    <a:cs typeface="+mn-cs"/>
+                  </a:rPr>
+                  <a:t>1=0 </a:t>
+                </a:r>
+                <a:r>
+                  <a:rPr lang="ko-KR" altLang="en-US" sz="1200" b="0" i="0" kern="1200">
+                    <a:solidFill>
+                      <a:schemeClr val="tx1"/>
+                    </a:solidFill>
+                    <a:latin typeface="Cambria Math" panose="02040503050406030204" pitchFamily="18" charset="0"/>
+                    <a:ea typeface="Kim jung chul Gothic Regular" panose="020B0503000000000000" pitchFamily="50" charset="-127"/>
+                    <a:cs typeface="+mn-cs"/>
+                  </a:rPr>
+                  <a:t>"또는</a:t>
+                </a:r>
+                <a:r>
+                  <a:rPr lang="ko-KR" altLang="en-US" sz="1200" b="0" i="0" kern="1200">
+                    <a:solidFill>
+                      <a:schemeClr val="tx1"/>
+                    </a:solidFill>
+                    <a:latin typeface="Kim jung chul Gothic Regular" panose="020B0503000000000000" pitchFamily="50" charset="-127"/>
+                    <a:ea typeface="Kim jung chul Gothic Regular" panose="020B0503000000000000" pitchFamily="50" charset="-127"/>
+                    <a:cs typeface="+mn-cs"/>
+                  </a:rPr>
+                  <a:t>" 𝑤_</a:t>
+                </a:r>
+                <a:r>
+                  <a:rPr lang="en-US" altLang="ko-KR" sz="1200" b="0" i="0" kern="1200">
+                    <a:solidFill>
+                      <a:schemeClr val="tx1"/>
+                    </a:solidFill>
+                    <a:latin typeface="Kim jung chul Gothic Regular" panose="020B0503000000000000" pitchFamily="50" charset="-127"/>
+                    <a:ea typeface="Kim jung chul Gothic Regular" panose="020B0503000000000000" pitchFamily="50" charset="-127"/>
+                    <a:cs typeface="+mn-cs"/>
+                  </a:rPr>
+                  <a:t>2=0</a:t>
+                </a:r>
+                <a:endParaRPr lang="ko-KR" altLang="en-US" b="0" dirty="0"/>
+              </a:p>
+              <a:p>
+                <a:r>
+                  <a:rPr lang="ko-KR" altLang="en-US" dirty="0"/>
+                  <a:t>그래서</a:t>
+                </a:r>
+              </a:p>
+              <a:p>
+                <a:r>
+                  <a:rPr lang="ko-KR" altLang="en-US" dirty="0"/>
+                  <a:t>일부 가중치가 정확히 </a:t>
+                </a:r>
+                <a:r>
+                  <a:rPr lang="en-US" altLang="ko-KR" dirty="0"/>
+                  <a:t>0</a:t>
+                </a:r>
+                <a:r>
+                  <a:rPr lang="ko-KR" altLang="en-US" dirty="0"/>
+                  <a:t>이 됨</a:t>
+                </a:r>
+              </a:p>
+              <a:p>
+                <a:r>
+                  <a:rPr lang="ko-KR" altLang="en-US" dirty="0"/>
+                  <a:t>이게 </a:t>
+                </a:r>
+                <a:r>
+                  <a:rPr lang="en-US" altLang="ko-KR" dirty="0"/>
+                  <a:t>PPT</a:t>
+                </a:r>
+                <a:r>
+                  <a:rPr lang="ko-KR" altLang="en-US" dirty="0"/>
+                  <a:t>에서 말하는</a:t>
+                </a:r>
+                <a:r>
+                  <a:rPr lang="en-US" altLang="ko-KR" dirty="0"/>
+                  <a:t>:</a:t>
+                </a:r>
+              </a:p>
+              <a:p>
+                <a:r>
+                  <a:rPr lang="en-US" altLang="ko-KR" dirty="0"/>
+                  <a:t>Feature selection </a:t>
+                </a:r>
+                <a:r>
+                  <a:rPr lang="ko-KR" altLang="en-US" dirty="0"/>
+                  <a:t>효과</a:t>
+                </a:r>
+              </a:p>
+              <a:p>
+                <a:r>
+                  <a:rPr lang="ko-KR" altLang="en-US" dirty="0"/>
+                  <a:t>입니다</a:t>
+                </a:r>
+                <a:r>
+                  <a:rPr lang="en-US" altLang="ko-KR" dirty="0"/>
+                  <a:t>.</a:t>
+                </a:r>
+              </a:p>
+              <a:p>
+                <a:endParaRPr lang="en-US" altLang="ko-KR" dirty="0"/>
+              </a:p>
+              <a:p>
+                <a:endParaRPr lang="en-US" altLang="ko-KR" dirty="0"/>
+              </a:p>
+              <a:p>
+                <a:endParaRPr lang="en-US" altLang="ko-KR" dirty="0"/>
+              </a:p>
+              <a:p>
+                <a:r>
+                  <a:rPr lang="ko-KR" altLang="en-US" dirty="0"/>
+                  <a:t>아래 람다</a:t>
+                </a:r>
+                <a:endParaRPr lang="en-US" altLang="ko-KR" dirty="0"/>
+              </a:p>
+              <a:p>
+                <a:r>
+                  <a:rPr lang="ko-KR" altLang="en-US" dirty="0"/>
+                  <a:t>오차에 “절대값 </a:t>
+                </a:r>
+                <a:r>
+                  <a:rPr lang="ko-KR" altLang="en-US" dirty="0" err="1"/>
+                  <a:t>벌점”을</a:t>
+                </a:r>
+                <a:r>
+                  <a:rPr lang="ko-KR" altLang="en-US" dirty="0"/>
+                  <a:t> 추가합니다</a:t>
+                </a:r>
+                <a:r>
+                  <a:rPr lang="en-US" altLang="ko-KR" dirty="0"/>
+                  <a:t>.</a:t>
+                </a:r>
+                <a:br>
+                  <a:rPr lang="en-US" altLang="ko-KR" dirty="0"/>
+                </a:br>
+                <a:r>
+                  <a:rPr lang="ko-KR" altLang="en-US" dirty="0"/>
+                  <a:t>그래서 가중치가 조금이라도 존재하면 계속 벌점을 받습니다</a:t>
+                </a:r>
+                <a:r>
+                  <a:rPr lang="en-US" altLang="ko-KR" dirty="0"/>
+                  <a:t>.</a:t>
+                </a:r>
+                <a:br>
+                  <a:rPr lang="en-US" altLang="ko-KR" dirty="0"/>
+                </a:br>
+                <a:r>
+                  <a:rPr lang="ko-KR" altLang="en-US" dirty="0"/>
+                  <a:t>결국 일부 가중치는 완전히 </a:t>
+                </a:r>
+                <a:r>
+                  <a:rPr lang="en-US" altLang="ko-KR" dirty="0"/>
+                  <a:t>0</a:t>
+                </a:r>
+                <a:r>
+                  <a:rPr lang="ko-KR" altLang="en-US" dirty="0"/>
+                  <a:t>이 됩니다</a:t>
+                </a:r>
+                <a:r>
+                  <a:rPr lang="en-US" altLang="ko-KR" dirty="0"/>
+                  <a:t>.</a:t>
+                </a:r>
+                <a:endParaRPr lang="ko-KR" altLang="en-US" dirty="0"/>
+              </a:p>
+            </p:txBody>
+          </p:sp>
+        </mc:Fallback>
+      </mc:AlternateContent>
+      <p:sp>
+        <p:nvSpPr>
+          <p:cNvPr id="4" name="슬라이드 번호 개체 틀 3"/>
+          <p:cNvSpPr>
+            <a:spLocks noGrp="1"/>
+          </p:cNvSpPr>
+          <p:nvPr>
+            <p:ph type="sldNum" sz="quarter" idx="5"/>
+          </p:nvPr>
+        </p:nvSpPr>
+        <p:spPr/>
+        <p:txBody>
+          <a:bodyPr/>
+          <a:lstStyle/>
+          <a:p>
+            <a:fld id="{3E35EA20-6519-4513-9EDC-C89C5369BAEC}" type="slidenum">
+              <a:rPr lang="ko-KR" altLang="en-US" smtClean="0"/>
+              <a:pPr/>
+              <a:t>30</a:t>
+            </a:fld>
+            <a:endParaRPr lang="ko-KR" altLang="en-US" dirty="0"/>
+          </a:p>
+        </p:txBody>
+      </p:sp>
+    </p:spTree>
+    <p:extLst>
+      <p:ext uri="{BB962C8B-B14F-4D97-AF65-F5344CB8AC3E}">
+        <p14:creationId xmlns:p14="http://schemas.microsoft.com/office/powerpoint/2010/main" val="1556189187"/>
+      </p:ext>
+    </p:extLst>
+  </p:cSld>
+  <p:clrMapOvr>
+    <a:masterClrMapping/>
+  </p:clrMapOvr>
+</p:notes>
+</file>
+
+<file path=ppt/notesSlides/notesSlide22.xml><?xml version="1.0" encoding="utf-8"?>
+<p:notes xmlns:a="http://schemas.openxmlformats.org/drawingml/2006/main" xmlns:r="http://schemas.openxmlformats.org/officeDocument/2006/relationships" xmlns:p="http://schemas.openxmlformats.org/presentationml/2006/main">
+  <p:cSld>
+    <p:spTree>
+      <p:nvGrpSpPr>
+        <p:cNvPr id="1" name=""/>
+        <p:cNvGrpSpPr/>
+        <p:nvPr/>
+      </p:nvGrpSpPr>
+      <p:grpSpPr>
+        <a:xfrm>
+          <a:off x="0" y="0"/>
+          <a:ext cx="0" cy="0"/>
+          <a:chOff x="0" y="0"/>
+          <a:chExt cx="0" cy="0"/>
+        </a:xfrm>
+      </p:grpSpPr>
+      <p:sp>
+        <p:nvSpPr>
+          <p:cNvPr id="2" name="슬라이드 이미지 개체 틀 1"/>
+          <p:cNvSpPr>
+            <a:spLocks noGrp="1" noRot="1" noChangeAspect="1"/>
+          </p:cNvSpPr>
+          <p:nvPr>
+            <p:ph type="sldImg"/>
+          </p:nvPr>
+        </p:nvSpPr>
+        <p:spPr/>
+      </p:sp>
+      <p:sp>
+        <p:nvSpPr>
+          <p:cNvPr id="3" name="슬라이드 노트 개체 틀 2"/>
+          <p:cNvSpPr>
+            <a:spLocks noGrp="1"/>
+          </p:cNvSpPr>
+          <p:nvPr>
+            <p:ph type="body" idx="1"/>
+          </p:nvPr>
+        </p:nvSpPr>
+        <p:spPr/>
+        <p:txBody>
+          <a:bodyPr/>
+          <a:lstStyle/>
+          <a:p>
+            <a:r>
+              <a:rPr lang="ko-KR" altLang="en-US" dirty="0"/>
+              <a:t>원은 매끄럽기 때문에</a:t>
+            </a:r>
+            <a:br>
+              <a:rPr lang="ko-KR" altLang="en-US" dirty="0"/>
+            </a:br>
+            <a:r>
+              <a:rPr lang="ko-KR" altLang="en-US" dirty="0"/>
+              <a:t>모서리가 없음</a:t>
+            </a:r>
+            <a:r>
+              <a:rPr lang="en-US" altLang="ko-KR" dirty="0"/>
+              <a:t>.</a:t>
+            </a:r>
+          </a:p>
+          <a:p>
+            <a:r>
+              <a:rPr lang="ko-KR" altLang="en-US" dirty="0"/>
+              <a:t>그래서 해는 보통</a:t>
+            </a:r>
+            <a:r>
+              <a:rPr lang="en-US" altLang="ko-KR" dirty="0"/>
+              <a:t>:</a:t>
+            </a:r>
+          </a:p>
+          <a:p>
+            <a:r>
+              <a:rPr lang="ko-KR" altLang="en-US" dirty="0"/>
+              <a:t>완전히 </a:t>
+            </a:r>
+            <a:r>
+              <a:rPr lang="en-US" altLang="ko-KR" dirty="0"/>
+              <a:t>0</a:t>
+            </a:r>
+            <a:r>
+              <a:rPr lang="ko-KR" altLang="en-US" dirty="0"/>
+              <a:t>이 되기보다는</a:t>
+            </a:r>
+          </a:p>
+          <a:p>
+            <a:r>
+              <a:rPr lang="ko-KR" altLang="en-US" dirty="0"/>
+              <a:t>전체적으로 </a:t>
+            </a:r>
+            <a:r>
+              <a:rPr lang="ko-KR" altLang="en-US" dirty="0" err="1"/>
+              <a:t>작아짐</a:t>
+            </a:r>
+            <a:endParaRPr lang="ko-KR" altLang="en-US" dirty="0"/>
+          </a:p>
+          <a:p>
+            <a:r>
+              <a:rPr lang="ko-KR" altLang="en-US" dirty="0"/>
+              <a:t>즉</a:t>
+            </a:r>
+            <a:r>
+              <a:rPr lang="en-US" altLang="ko-KR" dirty="0"/>
+              <a:t>,</a:t>
+            </a:r>
+          </a:p>
+          <a:p>
+            <a:r>
+              <a:rPr lang="ko-KR" altLang="en-US" dirty="0"/>
+              <a:t>모든 가중치를 부드럽게 줄임</a:t>
+            </a:r>
+          </a:p>
+          <a:p>
+            <a:r>
+              <a:rPr lang="ko-KR" altLang="en-US" dirty="0"/>
+              <a:t>이게 </a:t>
+            </a:r>
+            <a:r>
+              <a:rPr lang="en-US" altLang="ko-KR" dirty="0"/>
+              <a:t>PPT</a:t>
+            </a:r>
+            <a:r>
+              <a:rPr lang="ko-KR" altLang="en-US" dirty="0"/>
+              <a:t>에서 말하는</a:t>
+            </a:r>
+            <a:r>
+              <a:rPr lang="en-US" altLang="ko-KR" dirty="0"/>
+              <a:t>:</a:t>
+            </a:r>
+          </a:p>
+          <a:p>
+            <a:r>
+              <a:rPr lang="en-US" altLang="ko-KR" dirty="0"/>
+              <a:t>Weight decay </a:t>
+            </a:r>
+            <a:r>
+              <a:rPr lang="ko-KR" altLang="en-US" dirty="0"/>
+              <a:t>효과</a:t>
+            </a:r>
+          </a:p>
+          <a:p>
+            <a:r>
+              <a:rPr lang="ko-KR" altLang="en-US" dirty="0"/>
+              <a:t>입니다</a:t>
+            </a:r>
+            <a:r>
+              <a:rPr lang="en-US" altLang="ko-KR" dirty="0"/>
+              <a:t>.</a:t>
+            </a:r>
+          </a:p>
+          <a:p>
+            <a:endParaRPr lang="en-US" altLang="ko-KR" dirty="0"/>
+          </a:p>
+          <a:p>
+            <a:endParaRPr lang="en-US" altLang="ko-KR" dirty="0"/>
+          </a:p>
+          <a:p>
+            <a:r>
+              <a:rPr lang="en-US" altLang="ko-KR" dirty="0"/>
+              <a:t>*</a:t>
+            </a:r>
+            <a:r>
+              <a:rPr lang="ko-KR" altLang="en-US" dirty="0"/>
+              <a:t>수식</a:t>
+            </a:r>
+            <a:endParaRPr lang="en-US" altLang="ko-KR" dirty="0"/>
+          </a:p>
+          <a:p>
+            <a:r>
+              <a:rPr lang="ko-KR" altLang="en-US" dirty="0"/>
+              <a:t>오차에 “제곱 </a:t>
+            </a:r>
+            <a:r>
+              <a:rPr lang="ko-KR" altLang="en-US" dirty="0" err="1"/>
+              <a:t>벌점”을</a:t>
+            </a:r>
+            <a:r>
+              <a:rPr lang="ko-KR" altLang="en-US" dirty="0"/>
+              <a:t> 추가합니다</a:t>
+            </a:r>
+            <a:r>
+              <a:rPr lang="en-US" altLang="ko-KR" dirty="0"/>
+              <a:t>.</a:t>
+            </a:r>
+            <a:br>
+              <a:rPr lang="en-US" altLang="ko-KR" dirty="0"/>
+            </a:br>
+            <a:r>
+              <a:rPr lang="ko-KR" altLang="en-US" dirty="0"/>
+              <a:t>큰 가중치일수록 더 강하게 줄어듭니다</a:t>
+            </a:r>
+            <a:r>
+              <a:rPr lang="en-US" altLang="ko-KR" dirty="0"/>
+              <a:t>.</a:t>
+            </a:r>
+            <a:br>
+              <a:rPr lang="en-US" altLang="ko-KR" dirty="0"/>
+            </a:br>
+            <a:r>
+              <a:rPr lang="ko-KR" altLang="en-US" dirty="0"/>
+              <a:t>하지만 완전히 </a:t>
+            </a:r>
+            <a:r>
+              <a:rPr lang="en-US" altLang="ko-KR" dirty="0"/>
+              <a:t>0</a:t>
+            </a:r>
+            <a:r>
+              <a:rPr lang="ko-KR" altLang="en-US" dirty="0"/>
+              <a:t>으로 만들지는 않습니다</a:t>
+            </a:r>
+            <a:r>
+              <a:rPr lang="en-US" altLang="ko-KR" dirty="0"/>
+              <a:t>.</a:t>
+            </a:r>
+          </a:p>
+          <a:p>
+            <a:endParaRPr lang="ko-KR" altLang="en-US" dirty="0"/>
+          </a:p>
+        </p:txBody>
+      </p:sp>
+      <p:sp>
+        <p:nvSpPr>
+          <p:cNvPr id="4" name="슬라이드 번호 개체 틀 3"/>
+          <p:cNvSpPr>
+            <a:spLocks noGrp="1"/>
+          </p:cNvSpPr>
+          <p:nvPr>
+            <p:ph type="sldNum" sz="quarter" idx="5"/>
+          </p:nvPr>
+        </p:nvSpPr>
+        <p:spPr/>
+        <p:txBody>
+          <a:bodyPr/>
+          <a:lstStyle/>
+          <a:p>
+            <a:fld id="{3E35EA20-6519-4513-9EDC-C89C5369BAEC}" type="slidenum">
+              <a:rPr lang="ko-KR" altLang="en-US" smtClean="0"/>
+              <a:pPr/>
+              <a:t>31</a:t>
+            </a:fld>
+            <a:endParaRPr lang="ko-KR" altLang="en-US" dirty="0"/>
+          </a:p>
+        </p:txBody>
+      </p:sp>
+    </p:spTree>
+    <p:extLst>
+      <p:ext uri="{BB962C8B-B14F-4D97-AF65-F5344CB8AC3E}">
+        <p14:creationId xmlns:p14="http://schemas.microsoft.com/office/powerpoint/2010/main" val="663206782"/>
+      </p:ext>
+    </p:extLst>
+  </p:cSld>
+  <p:clrMapOvr>
+    <a:masterClrMapping/>
+  </p:clrMapOvr>
+</p:notes>
+</file>
+
+<file path=ppt/notesSlides/notesSlide23.xml><?xml version="1.0" encoding="utf-8"?>
+<p:notes xmlns:a="http://schemas.openxmlformats.org/drawingml/2006/main" xmlns:r="http://schemas.openxmlformats.org/officeDocument/2006/relationships" xmlns:p="http://schemas.openxmlformats.org/presentationml/2006/main">
+  <p:cSld>
+    <p:spTree>
+      <p:nvGrpSpPr>
+        <p:cNvPr id="1" name="">
+          <a:extLst>
+            <a:ext uri="{FF2B5EF4-FFF2-40B4-BE49-F238E27FC236}">
+              <a16:creationId xmlns:a16="http://schemas.microsoft.com/office/drawing/2014/main" id="{A9D2EE83-52CB-E118-49CB-3EBDD6EF25B9}"/>
+            </a:ext>
+          </a:extLst>
+        </p:cNvPr>
+        <p:cNvGrpSpPr/>
+        <p:nvPr/>
+      </p:nvGrpSpPr>
+      <p:grpSpPr>
+        <a:xfrm>
+          <a:off x="0" y="0"/>
+          <a:ext cx="0" cy="0"/>
+          <a:chOff x="0" y="0"/>
+          <a:chExt cx="0" cy="0"/>
+        </a:xfrm>
+      </p:grpSpPr>
+      <p:sp>
+        <p:nvSpPr>
+          <p:cNvPr id="2" name="슬라이드 이미지 개체 틀 1">
+            <a:extLst>
+              <a:ext uri="{FF2B5EF4-FFF2-40B4-BE49-F238E27FC236}">
+                <a16:creationId xmlns:a16="http://schemas.microsoft.com/office/drawing/2014/main" id="{30F83B01-3943-C359-9322-8EB719FB824B}"/>
+              </a:ext>
+            </a:extLst>
+          </p:cNvPr>
+          <p:cNvSpPr>
+            <a:spLocks noGrp="1" noRot="1" noChangeAspect="1"/>
+          </p:cNvSpPr>
+          <p:nvPr>
+            <p:ph type="sldImg"/>
+          </p:nvPr>
+        </p:nvSpPr>
+        <p:spPr/>
+      </p:sp>
+      <p:sp>
+        <p:nvSpPr>
+          <p:cNvPr id="3" name="슬라이드 노트 개체 틀 2">
+            <a:extLst>
+              <a:ext uri="{FF2B5EF4-FFF2-40B4-BE49-F238E27FC236}">
+                <a16:creationId xmlns:a16="http://schemas.microsoft.com/office/drawing/2014/main" id="{F2F259CF-8156-0FB2-87BB-C2421F329EA1}"/>
+              </a:ext>
+            </a:extLst>
+          </p:cNvPr>
+          <p:cNvSpPr>
+            <a:spLocks noGrp="1"/>
+          </p:cNvSpPr>
+          <p:nvPr>
+            <p:ph type="body" idx="1"/>
+          </p:nvPr>
+        </p:nvSpPr>
+        <p:spPr/>
+        <p:txBody>
+          <a:bodyPr/>
+          <a:lstStyle/>
+          <a:p>
+            <a:endParaRPr lang="ko-KR" altLang="en-US" dirty="0"/>
+          </a:p>
+        </p:txBody>
+      </p:sp>
+      <p:sp>
+        <p:nvSpPr>
+          <p:cNvPr id="4" name="슬라이드 번호 개체 틀 3">
+            <a:extLst>
+              <a:ext uri="{FF2B5EF4-FFF2-40B4-BE49-F238E27FC236}">
+                <a16:creationId xmlns:a16="http://schemas.microsoft.com/office/drawing/2014/main" id="{5301DD34-5BFE-877A-E657-9B3A6B1B5CDD}"/>
+              </a:ext>
+            </a:extLst>
+          </p:cNvPr>
+          <p:cNvSpPr>
+            <a:spLocks noGrp="1"/>
+          </p:cNvSpPr>
+          <p:nvPr>
+            <p:ph type="sldNum" sz="quarter" idx="10"/>
+          </p:nvPr>
+        </p:nvSpPr>
+        <p:spPr/>
+        <p:txBody>
+          <a:bodyPr/>
+          <a:lstStyle/>
+          <a:p>
+            <a:fld id="{A0085365-8376-4996-BDD6-F39608FADAF3}" type="slidenum">
+              <a:rPr lang="ko-KR" altLang="en-US" smtClean="0"/>
+              <a:t>33</a:t>
+            </a:fld>
+            <a:endParaRPr lang="ko-KR" altLang="en-US"/>
+          </a:p>
+        </p:txBody>
+      </p:sp>
+    </p:spTree>
+    <p:extLst>
+      <p:ext uri="{BB962C8B-B14F-4D97-AF65-F5344CB8AC3E}">
+        <p14:creationId xmlns:p14="http://schemas.microsoft.com/office/powerpoint/2010/main" val="2391645545"/>
       </p:ext>
     </p:extLst>
   </p:cSld>
@@ -8102,12 +9317,8 @@
               <a:t>전체 </a:t>
             </a:r>
             <a:r>
-              <a:rPr lang="en-US" altLang="ko-KR" sz="2000" dirty="0" err="1"/>
-              <a:t>Traning</a:t>
-            </a:r>
-            <a:r>
               <a:rPr lang="en-US" altLang="ko-KR" sz="2000" dirty="0"/>
-              <a:t> set</a:t>
+              <a:t>Training set</a:t>
             </a:r>
             <a:r>
               <a:rPr lang="ko-KR" altLang="en-US" sz="2000" dirty="0"/>
@@ -12119,7 +13330,7 @@
             <p:nvPr/>
           </p:nvPicPr>
           <p:blipFill>
-            <a:blip r:embed="rId2">
+            <a:blip r:embed="rId3">
               <a:extLst>
                 <a:ext uri="{28A0092B-C50C-407E-A947-70E740481C1C}">
                   <a14:useLocalDpi xmlns:a14="http://schemas.microsoft.com/office/drawing/2010/main" val="0"/>
@@ -12289,15 +13500,11 @@
             </a:r>
             <a:r>
               <a:rPr lang="en-US" altLang="ko-KR" b="1" dirty="0"/>
-              <a:t>(</a:t>
-            </a:r>
-            <a:r>
-              <a:rPr lang="en-US" altLang="ko-KR" b="1" dirty="0" err="1"/>
-              <a:t>Overfitting</a:t>
-            </a:r>
-            <a:r>
-              <a:rPr lang="en-US" altLang="ko-KR" b="1" dirty="0"/>
-              <a:t>)</a:t>
+              <a:t>(Overfitting) </a:t>
+            </a:r>
+            <a:r>
+              <a:rPr lang="ko-KR" altLang="en-US" b="1" dirty="0"/>
+              <a:t>원인</a:t>
             </a:r>
             <a:endParaRPr lang="ko-KR" altLang="en-US" b="1" dirty="0">
               <a:latin typeface="+mj-ea"/>
@@ -12656,15 +13863,11 @@
             </a:r>
             <a:r>
               <a:rPr lang="en-US" altLang="ko-KR" b="1" dirty="0"/>
-              <a:t>(</a:t>
-            </a:r>
-            <a:r>
-              <a:rPr lang="en-US" altLang="ko-KR" b="1" dirty="0" err="1"/>
-              <a:t>Overfitting</a:t>
-            </a:r>
-            <a:r>
-              <a:rPr lang="en-US" altLang="ko-KR" b="1" dirty="0"/>
-              <a:t>)</a:t>
+              <a:t>(Overfitting) </a:t>
+            </a:r>
+            <a:r>
+              <a:rPr lang="ko-KR" altLang="en-US" b="1" dirty="0"/>
+              <a:t>해결 전략</a:t>
             </a:r>
             <a:endParaRPr lang="ko-KR" altLang="en-US" b="1" dirty="0">
               <a:latin typeface="+mj-ea"/>
@@ -12710,7 +13913,7 @@
               <a:rPr lang="ko-KR" altLang="en-US" sz="2400" dirty="0">
                 <a:latin typeface="+mn-ea"/>
               </a:rPr>
-              <a:t>✅ 해결 방법</a:t>
+              <a:t>✅ 데이터 기반 해결</a:t>
             </a:r>
             <a:endParaRPr lang="en-US" altLang="ko-KR" sz="2400" dirty="0">
               <a:latin typeface="+mn-ea"/>
@@ -12959,7 +14162,7 @@
         </p:blipFill>
         <p:spPr bwMode="auto">
           <a:xfrm>
-            <a:off x="6690168" y="2378599"/>
+            <a:off x="6747318" y="2290813"/>
             <a:ext cx="5296623" cy="2354054"/>
           </a:xfrm>
           <a:prstGeom prst="rect">
@@ -13006,15 +14209,11 @@
             </a:r>
             <a:r>
               <a:rPr lang="en-US" altLang="ko-KR" b="1" dirty="0"/>
-              <a:t>(</a:t>
-            </a:r>
-            <a:r>
-              <a:rPr lang="en-US" altLang="ko-KR" b="1" dirty="0" err="1"/>
-              <a:t>Overfitting</a:t>
-            </a:r>
-            <a:r>
-              <a:rPr lang="en-US" altLang="ko-KR" b="1" dirty="0"/>
-              <a:t>)</a:t>
+              <a:t>(Overfitting) </a:t>
+            </a:r>
+            <a:r>
+              <a:rPr lang="ko-KR" altLang="en-US" b="1" dirty="0"/>
+              <a:t>해결 전략</a:t>
             </a:r>
             <a:endParaRPr lang="ko-KR" altLang="en-US" b="1" dirty="0">
               <a:latin typeface="+mj-ea"/>
@@ -13040,8 +14239,8 @@
         </p:nvSpPr>
         <p:spPr>
           <a:xfrm>
-            <a:off x="238991" y="1393596"/>
-            <a:ext cx="6158738" cy="4324060"/>
+            <a:off x="238990" y="1145407"/>
+            <a:ext cx="6961909" cy="5049653"/>
           </a:xfrm>
         </p:spPr>
         <p:txBody>
@@ -13060,9 +14259,15 @@
               <a:rPr lang="ko-KR" altLang="en-US" sz="2400" dirty="0">
                 <a:latin typeface="+mn-ea"/>
               </a:rPr>
-              <a:t>✅ 해결 방법</a:t>
-            </a:r>
-            <a:endParaRPr lang="en-US" altLang="ko-KR" sz="2400" dirty="0">
+              <a:t>✅ 모델 복잡도 제어 </a:t>
+            </a:r>
+            <a:r>
+              <a:rPr lang="en-US" altLang="ko-KR" sz="2400" dirty="0">
+                <a:latin typeface="+mn-ea"/>
+              </a:rPr>
+              <a:t>(Regularization)</a:t>
+            </a:r>
+            <a:endParaRPr lang="en-US" altLang="ko-KR" dirty="0">
               <a:latin typeface="+mn-ea"/>
             </a:endParaRPr>
           </a:p>
@@ -13071,18 +14276,19 @@
               <a:lnSpc>
                 <a:spcPct val="150000"/>
               </a:lnSpc>
-              <a:buFont typeface="Wingdings" panose="05000000000000000000" pitchFamily="2" charset="2"/>
-              <a:buChar char="§"/>
             </a:pPr>
             <a:r>
-              <a:rPr lang="en-US" altLang="ko-KR" dirty="0">
+              <a:rPr lang="ko-KR" altLang="en-US" dirty="0">
                 <a:latin typeface="+mn-ea"/>
               </a:rPr>
-              <a:t>Regularization</a:t>
-            </a:r>
-          </a:p>
-          <a:p>
-            <a:pPr lvl="2">
+              <a:t>모델의 복잡도를 제어하는 기법</a:t>
+            </a:r>
+            <a:endParaRPr lang="en-US" altLang="ko-KR" dirty="0">
+              <a:latin typeface="+mn-ea"/>
+            </a:endParaRPr>
+          </a:p>
+          <a:p>
+            <a:pPr lvl="1">
               <a:lnSpc>
                 <a:spcPct val="150000"/>
               </a:lnSpc>
@@ -13091,22 +14297,6 @@
               <a:rPr lang="ko-KR" altLang="en-US" dirty="0">
                 <a:latin typeface="+mn-ea"/>
               </a:rPr>
-              <a:t>모델의 복잡도를 제어하는 기법</a:t>
-            </a:r>
-            <a:endParaRPr lang="en-US" altLang="ko-KR" dirty="0">
-              <a:latin typeface="+mn-ea"/>
-            </a:endParaRPr>
-          </a:p>
-          <a:p>
-            <a:pPr lvl="2">
-              <a:lnSpc>
-                <a:spcPct val="150000"/>
-              </a:lnSpc>
-            </a:pPr>
-            <a:r>
-              <a:rPr lang="ko-KR" altLang="en-US" dirty="0">
-                <a:latin typeface="+mn-ea"/>
-              </a:rPr>
               <a:t>모델의 가중치 크기를 제한하거나 불필요한 특징</a:t>
             </a:r>
             <a:r>
@@ -13126,30 +14316,30 @@
             </a:endParaRPr>
           </a:p>
           <a:p>
-            <a:pPr marL="914400" lvl="2" indent="0">
+            <a:pPr marL="457200" lvl="1" indent="0">
               <a:lnSpc>
                 <a:spcPct val="150000"/>
               </a:lnSpc>
               <a:buNone/>
             </a:pPr>
             <a:r>
-              <a:rPr lang="en-US" altLang="ko-KR" sz="1800" dirty="0">
+              <a:rPr lang="en-US" altLang="ko-KR" sz="2200" dirty="0">
                 <a:latin typeface="+mn-ea"/>
               </a:rPr>
               <a:t>    </a:t>
             </a:r>
             <a:r>
-              <a:rPr lang="ko-KR" altLang="en-US" sz="1800" dirty="0">
+              <a:rPr lang="ko-KR" altLang="en-US" sz="2200" dirty="0">
                 <a:latin typeface="+mn-ea"/>
               </a:rPr>
               <a:t>→ 학습 데이터에만 지나치게 맞춰지는 것을 막는 역할</a:t>
             </a:r>
-            <a:endParaRPr lang="en-US" altLang="ko-KR" sz="1800" dirty="0">
+            <a:endParaRPr lang="en-US" altLang="ko-KR" sz="2200" dirty="0">
               <a:latin typeface="+mn-ea"/>
             </a:endParaRPr>
           </a:p>
           <a:p>
-            <a:pPr lvl="2">
+            <a:pPr lvl="1">
               <a:lnSpc>
                 <a:spcPct val="150000"/>
               </a:lnSpc>
@@ -13172,6 +14362,11 @@
               </a:rPr>
               <a:t>가중치가 작아지는 쪽으로 학습</a:t>
             </a:r>
+            <a:br>
+              <a:rPr lang="en-US" altLang="ko-KR" dirty="0">
+                <a:latin typeface="+mn-ea"/>
+              </a:rPr>
+            </a:br>
             <a:r>
               <a:rPr lang="en-US" altLang="ko-KR" dirty="0">
                 <a:latin typeface="+mn-ea"/>
@@ -13310,15 +14505,11 @@
             </a:r>
             <a:r>
               <a:rPr lang="en-US" altLang="ko-KR" b="1" dirty="0"/>
-              <a:t>(</a:t>
-            </a:r>
-            <a:r>
-              <a:rPr lang="en-US" altLang="ko-KR" b="1" dirty="0" err="1"/>
-              <a:t>Overfitting</a:t>
-            </a:r>
-            <a:r>
-              <a:rPr lang="en-US" altLang="ko-KR" b="1" dirty="0"/>
-              <a:t>)</a:t>
+              <a:t>(Overfitting) </a:t>
+            </a:r>
+            <a:r>
+              <a:rPr lang="ko-KR" altLang="en-US" b="1" dirty="0"/>
+              <a:t>해결 전략</a:t>
             </a:r>
             <a:endParaRPr lang="ko-KR" altLang="en-US" b="1" dirty="0">
               <a:latin typeface="+mj-ea"/>
@@ -13364,7 +14555,11 @@
               <a:rPr lang="ko-KR" altLang="en-US" sz="2400" dirty="0">
                 <a:latin typeface="+mn-ea"/>
               </a:rPr>
-              <a:t>✅ 해결 방법</a:t>
+              <a:t>✅ </a:t>
+            </a:r>
+            <a:r>
+              <a:rPr lang="ko-KR" altLang="en-US" sz="2400" dirty="0"/>
+              <a:t>네트워크 구조 기반 기법</a:t>
             </a:r>
             <a:endParaRPr lang="en-US" altLang="ko-KR" sz="2400" dirty="0">
               <a:latin typeface="+mn-ea"/>
@@ -13438,53 +14633,18 @@
               </a:lnSpc>
             </a:pPr>
             <a:r>
-              <a:rPr lang="ko-KR" altLang="en-US" dirty="0">
-                <a:latin typeface="+mn-ea"/>
-              </a:rPr>
-              <a:t>특정 뉴런의 </a:t>
-            </a:r>
-            <a:r>
-              <a:rPr lang="en-US" altLang="ko-KR" dirty="0">
-                <a:latin typeface="+mn-ea"/>
-              </a:rPr>
-              <a:t>w</a:t>
-            </a:r>
-            <a:r>
-              <a:rPr lang="ko-KR" altLang="en-US" dirty="0">
-                <a:latin typeface="+mn-ea"/>
-              </a:rPr>
-              <a:t>나 </a:t>
-            </a:r>
-            <a:r>
-              <a:rPr lang="en-US" altLang="ko-KR" dirty="0">
-                <a:latin typeface="+mn-ea"/>
-              </a:rPr>
-              <a:t>b</a:t>
-            </a:r>
-            <a:r>
-              <a:rPr lang="ko-KR" altLang="en-US" dirty="0">
-                <a:latin typeface="+mn-ea"/>
-              </a:rPr>
-              <a:t>가 너무 커졌을 때 해당 뉴런에 너무 많은 영향을 받지 않게 하는 효과</a:t>
-            </a:r>
-            <a:r>
-              <a:rPr lang="en-US" altLang="ko-KR" dirty="0">
-                <a:latin typeface="+mn-ea"/>
-              </a:rPr>
-              <a:t>(</a:t>
-            </a:r>
-            <a:r>
-              <a:rPr lang="ko-KR" altLang="en-US" dirty="0">
-                <a:latin typeface="+mn-ea"/>
-              </a:rPr>
-              <a:t>뉴런 동조화 방지</a:t>
-            </a:r>
-            <a:r>
-              <a:rPr lang="en-US" altLang="ko-KR" dirty="0">
-                <a:latin typeface="+mn-ea"/>
-              </a:rPr>
-              <a:t>)</a:t>
-            </a:r>
+              <a:rPr lang="ko-KR" altLang="en-US" dirty="0"/>
+              <a:t>뉴런 간의 과도한 의존</a:t>
+            </a:r>
+            <a:r>
+              <a:rPr lang="en-US" altLang="ko-KR" dirty="0"/>
+              <a:t>(co-adaptation) </a:t>
+            </a:r>
+            <a:r>
+              <a:rPr lang="ko-KR" altLang="en-US" dirty="0"/>
+              <a:t>방지</a:t>
+            </a:r>
+            <a:endParaRPr lang="en-US" altLang="ko-KR" dirty="0"/>
           </a:p>
           <a:p>
             <a:pPr lvl="2">
@@ -13777,7 +14937,7 @@
           <p:cNvPr id="2" name="제목 1">
             <a:extLst>
               <a:ext uri="{FF2B5EF4-FFF2-40B4-BE49-F238E27FC236}">
-                <a16:creationId xmlns:a16="http://schemas.microsoft.com/office/drawing/2014/main" id="{A8D8F1F4-4871-4B45-B08E-F92ACDB80FE6}"/>
+                <a16:creationId xmlns:a16="http://schemas.microsoft.com/office/drawing/2014/main" id="{0E5B589D-A2CB-6CAC-09EE-D6C93F5DDB1D}"/>
               </a:ext>
             </a:extLst>
           </p:cNvPr>
@@ -13786,45 +14946,6 @@
           </p:cNvSpPr>
           <p:nvPr>
             <p:ph type="title"/>
-          </p:nvPr>
-        </p:nvSpPr>
-        <p:spPr/>
-        <p:txBody>
-          <a:bodyPr>
-            <a:normAutofit/>
-          </a:bodyPr>
-          <a:lstStyle/>
-          <a:p>
-            <a:pPr marL="0" indent="0">
-              <a:buFont typeface="Arial" panose="020B0604020202020204" pitchFamily="34" charset="0"/>
-              <a:buNone/>
-            </a:pPr>
-            <a:r>
-              <a:rPr lang="en-US" altLang="ko-KR" b="1" dirty="0">
-                <a:latin typeface="+mj-ea"/>
-              </a:rPr>
-              <a:t>Weight normalization</a:t>
-            </a:r>
-            <a:endParaRPr lang="ko-KR" altLang="en-US" b="1" dirty="0">
-              <a:latin typeface="+mj-ea"/>
-            </a:endParaRPr>
-          </a:p>
-        </p:txBody>
-      </p:sp>
-      <p:sp>
-        <p:nvSpPr>
-          <p:cNvPr id="4" name="날짜 개체 틀 3">
-            <a:extLst>
-              <a:ext uri="{FF2B5EF4-FFF2-40B4-BE49-F238E27FC236}">
-                <a16:creationId xmlns:a16="http://schemas.microsoft.com/office/drawing/2014/main" id="{590F8720-7C11-4CC8-8215-3F57F085A24B}"/>
-              </a:ext>
-            </a:extLst>
-          </p:cNvPr>
-          <p:cNvSpPr>
-            <a:spLocks noGrp="1"/>
-          </p:cNvSpPr>
-          <p:nvPr>
-            <p:ph type="dt" sz="half" idx="10"/>
           </p:nvPr>
         </p:nvSpPr>
         <p:spPr/>
@@ -13832,20 +14953,23 @@
           <a:bodyPr/>
           <a:lstStyle/>
           <a:p>
-            <a:fld id="{0F78D9C4-20C1-4B15-A116-16DC77AD9A1E}" type="datetime1">
-              <a:rPr lang="ko-KR" altLang="en-US" smtClean="0"/>
-              <a:t>2026-02-19</a:t>
-            </a:fld>
-            <a:endParaRPr lang="ko-KR" altLang="en-US"/>
+            <a:r>
+              <a:rPr lang="en-US" altLang="ko-KR" dirty="0"/>
+              <a:t>Regularization </a:t>
+            </a:r>
+            <a:r>
+              <a:rPr lang="ko-KR" altLang="en-US" dirty="0"/>
+              <a:t>개념</a:t>
+            </a:r>
           </a:p>
         </p:txBody>
       </p:sp>
       <p:sp>
         <p:nvSpPr>
-          <p:cNvPr id="5" name="슬라이드 번호 개체 틀 4">
+          <p:cNvPr id="3" name="내용 개체 틀 2">
             <a:extLst>
               <a:ext uri="{FF2B5EF4-FFF2-40B4-BE49-F238E27FC236}">
-                <a16:creationId xmlns:a16="http://schemas.microsoft.com/office/drawing/2014/main" id="{E86D5960-457B-4CA2-B0B3-F7F0DADA85D8}"/>
+                <a16:creationId xmlns:a16="http://schemas.microsoft.com/office/drawing/2014/main" id="{23E9D5B7-E881-B474-4347-D7255685DDD2}"/>
               </a:ext>
             </a:extLst>
           </p:cNvPr>
@@ -13853,7 +14977,7 @@
             <a:spLocks noGrp="1"/>
           </p:cNvSpPr>
           <p:nvPr>
-            <p:ph type="sldNum" sz="quarter" idx="12"/>
+            <p:ph idx="1"/>
           </p:nvPr>
         </p:nvSpPr>
         <p:spPr/>
@@ -13861,28 +14985,56 @@
           <a:bodyPr/>
           <a:lstStyle/>
           <a:p>
-            <a:fld id="{083A2CE0-18CD-4102-B738-4ACFF9E68BA4}" type="slidenum">
-              <a:rPr lang="ko-KR" altLang="en-US" smtClean="0"/>
-              <a:t>29</a:t>
-            </a:fld>
-            <a:endParaRPr lang="ko-KR" altLang="en-US"/>
+            <a:r>
+              <a:rPr lang="ko-KR" altLang="en-US" dirty="0"/>
+              <a:t>손실 함수에 </a:t>
+            </a:r>
+            <a:r>
+              <a:rPr lang="ko-KR" altLang="en-US" dirty="0" err="1"/>
+              <a:t>패널티</a:t>
+            </a:r>
+            <a:r>
+              <a:rPr lang="ko-KR" altLang="en-US" dirty="0"/>
+              <a:t> 항 추가</a:t>
+            </a:r>
+            <a:endParaRPr lang="en-US" altLang="ko-KR" dirty="0"/>
+          </a:p>
+          <a:p>
+            <a:r>
+              <a:rPr lang="ko-KR" altLang="en-US" dirty="0"/>
+              <a:t>가중치 크기 제어</a:t>
+            </a:r>
+            <a:endParaRPr lang="en-US" altLang="ko-KR" dirty="0"/>
+          </a:p>
+          <a:p>
+            <a:r>
+              <a:rPr lang="ko-KR" altLang="en-US" dirty="0"/>
+              <a:t>모델 복잡도 감소</a:t>
+            </a:r>
           </a:p>
         </p:txBody>
       </p:sp>
       <p:sp>
         <p:nvSpPr>
-          <p:cNvPr id="6" name="직사각형 5"/>
-          <p:cNvSpPr/>
+          <p:cNvPr id="5" name="TextBox 4">
+            <a:extLst>
+              <a:ext uri="{FF2B5EF4-FFF2-40B4-BE49-F238E27FC236}">
+                <a16:creationId xmlns:a16="http://schemas.microsoft.com/office/drawing/2014/main" id="{FBB3A1F9-F654-82A5-951B-2C0F03813CBE}"/>
+              </a:ext>
+            </a:extLst>
+          </p:cNvPr>
+          <p:cNvSpPr txBox="1"/>
           <p:nvPr/>
         </p:nvSpPr>
         <p:spPr>
           <a:xfrm>
-            <a:off x="238991" y="1145407"/>
-            <a:ext cx="11397205" cy="3732497"/>
+            <a:off x="5272307" y="1493152"/>
+            <a:ext cx="6115050" cy="369332"/>
           </a:xfrm>
           <a:prstGeom prst="rect">
             <a:avLst/>
           </a:prstGeom>
+          <a:noFill/>
         </p:spPr>
         <p:txBody>
           <a:bodyPr wrap="square">
@@ -13890,275 +15042,336 @@
           </a:bodyPr>
           <a:lstStyle/>
           <a:p>
-            <a:pPr>
+            <a:r>
+              <a:rPr lang="en-US" altLang="ko-KR" dirty="0"/>
+              <a:t>Loss=Original </a:t>
+            </a:r>
+            <a:r>
+              <a:rPr lang="en-US" altLang="ko-KR" dirty="0" err="1"/>
+              <a:t>Loss+λ⋅Regularization</a:t>
+            </a:r>
+            <a:r>
+              <a:rPr lang="en-US" altLang="ko-KR" dirty="0"/>
+              <a:t> Term</a:t>
+            </a:r>
+            <a:endParaRPr lang="ko-KR" altLang="en-US" dirty="0"/>
+          </a:p>
+        </p:txBody>
+      </p:sp>
+      <p:sp>
+        <p:nvSpPr>
+          <p:cNvPr id="6" name="Rectangle 1">
+            <a:extLst>
+              <a:ext uri="{FF2B5EF4-FFF2-40B4-BE49-F238E27FC236}">
+                <a16:creationId xmlns:a16="http://schemas.microsoft.com/office/drawing/2014/main" id="{F07E4D84-5E46-FFF5-E9EB-9C2C8594D045}"/>
+              </a:ext>
+            </a:extLst>
+          </p:cNvPr>
+          <p:cNvSpPr>
+            <a:spLocks noChangeArrowheads="1"/>
+          </p:cNvSpPr>
+          <p:nvPr/>
+        </p:nvSpPr>
+        <p:spPr bwMode="auto">
+          <a:xfrm rot="10800000" flipV="1">
+            <a:off x="5971736" y="1880498"/>
+            <a:ext cx="4088130" cy="923330"/>
+          </a:xfrm>
+          <a:prstGeom prst="rect">
+            <a:avLst/>
+          </a:prstGeom>
+          <a:noFill/>
+          <a:ln>
+            <a:noFill/>
+          </a:ln>
+          <a:effectLst/>
+          <a:extLst>
+            <a:ext uri="{909E8E84-426E-40DD-AFC4-6F175D3DCCD1}">
+              <a14:hiddenFill xmlns:a14="http://schemas.microsoft.com/office/drawing/2010/main">
+                <a:solidFill>
+                  <a:schemeClr val="accent1"/>
+                </a:solidFill>
+              </a14:hiddenFill>
+            </a:ext>
+            <a:ext uri="{91240B29-F687-4F45-9708-019B960494DF}">
+              <a14:hiddenLine xmlns:a14="http://schemas.microsoft.com/office/drawing/2010/main" w="9525">
+                <a:solidFill>
+                  <a:schemeClr val="tx1"/>
+                </a:solidFill>
+                <a:miter lim="800000"/>
+                <a:headEnd/>
+                <a:tailEnd/>
+              </a14:hiddenLine>
+            </a:ext>
+            <a:ext uri="{AF507438-7753-43E0-B8FC-AC1667EBCBE1}">
+              <a14:hiddenEffects xmlns:a14="http://schemas.microsoft.com/office/drawing/2010/main">
+                <a:effectLst>
+                  <a:outerShdw dist="35921" dir="2700000" algn="ctr" rotWithShape="0">
+                    <a:schemeClr val="bg2"/>
+                  </a:outerShdw>
+                </a:effectLst>
+              </a14:hiddenEffects>
+            </a:ext>
+          </a:extLst>
+        </p:spPr>
+        <p:txBody>
+          <a:bodyPr vert="horz" wrap="square" lIns="91440" tIns="45720" rIns="91440" bIns="45720" numCol="1" anchor="ctr" anchorCtr="0" compatLnSpc="1">
+            <a:prstTxWarp prst="textNoShape">
+              <a:avLst/>
+            </a:prstTxWarp>
+            <a:spAutoFit/>
+          </a:bodyPr>
+          <a:lstStyle/>
+          <a:p>
+            <a:pPr marL="0" marR="0" lvl="0" indent="0" algn="l" defTabSz="914400" rtl="0" eaLnBrk="0" fontAlgn="base" latinLnBrk="0" hangingPunct="0">
               <a:lnSpc>
-                <a:spcPct val="150000"/>
+                <a:spcPct val="100000"/>
               </a:lnSpc>
+              <a:spcBef>
+                <a:spcPct val="0"/>
+              </a:spcBef>
+              <a:spcAft>
+                <a:spcPct val="0"/>
+              </a:spcAft>
+              <a:buClrTx/>
+              <a:buSzTx/>
+              <a:buFontTx/>
+              <a:buChar char="•"/>
+              <a:tabLst/>
             </a:pPr>
             <a:r>
-              <a:rPr lang="ko-KR" altLang="en-US" sz="2400" dirty="0"/>
-              <a:t>💡 딥러닝 모델의 가중치를 크기</a:t>
-            </a:r>
-            <a:r>
-              <a:rPr lang="en-US" altLang="ko-KR" sz="2400" dirty="0"/>
-              <a:t>(norm)</a:t>
-            </a:r>
-            <a:r>
-              <a:rPr lang="ko-KR" altLang="en-US" sz="2400" dirty="0"/>
-              <a:t>와 방향</a:t>
-            </a:r>
-            <a:r>
-              <a:rPr lang="en-US" altLang="ko-KR" sz="2400" dirty="0"/>
-              <a:t>(direction)</a:t>
-            </a:r>
-            <a:r>
-              <a:rPr lang="ko-KR" altLang="en-US" sz="2400" dirty="0"/>
-              <a:t>으로 나눠 표현해 학습을 더 빠르고 </a:t>
-            </a:r>
-            <a:br>
-              <a:rPr lang="en-US" altLang="ko-KR" sz="2400" dirty="0"/>
-            </a:br>
-            <a:r>
-              <a:rPr lang="en-US" altLang="ko-KR" sz="2400" dirty="0"/>
-              <a:t>      </a:t>
-            </a:r>
-            <a:r>
-              <a:rPr lang="ko-KR" altLang="en-US" sz="2400" dirty="0"/>
-              <a:t>안정적으로 만드는 방법</a:t>
-            </a:r>
-            <a:r>
-              <a:rPr lang="en-US" altLang="ko-KR" sz="2400" dirty="0"/>
-              <a:t>.</a:t>
-            </a:r>
-          </a:p>
-          <a:p>
-            <a:pPr marL="457200" indent="-457200">
-              <a:lnSpc>
-                <a:spcPct val="150000"/>
-              </a:lnSpc>
-              <a:buFont typeface="Arial" pitchFamily="34" charset="0"/>
-              <a:buChar char="•"/>
-            </a:pPr>
-            <a:endParaRPr lang="en-US" altLang="ko-KR" sz="2800" dirty="0"/>
-          </a:p>
-          <a:p>
-            <a:pPr>
-              <a:lnSpc>
-                <a:spcPct val="150000"/>
-              </a:lnSpc>
-            </a:pPr>
-            <a:r>
-              <a:rPr lang="ko-KR" altLang="en-US" sz="2400" b="1" dirty="0"/>
-              <a:t>✅ 필요한 이유</a:t>
-            </a:r>
-            <a:endParaRPr lang="en-US" altLang="ko-KR" sz="2400" b="1" dirty="0"/>
-          </a:p>
-          <a:p>
-            <a:pPr marL="800100" lvl="1" indent="-342900">
-              <a:lnSpc>
-                <a:spcPct val="150000"/>
-              </a:lnSpc>
-              <a:buFont typeface="Arial" panose="020B0604020202020204" pitchFamily="34" charset="0"/>
-              <a:buChar char="•"/>
-            </a:pPr>
-            <a:r>
-              <a:rPr lang="ko-KR" altLang="en-US" sz="2000" b="1" dirty="0">
-                <a:latin typeface="Pretendard Light" panose="02000403000000020004" pitchFamily="2" charset="-127"/>
-                <a:ea typeface="Pretendard Light" panose="02000403000000020004" pitchFamily="2" charset="-127"/>
-                <a:cs typeface="Pretendard Light" panose="02000403000000020004" pitchFamily="2" charset="-127"/>
+              <a:rPr kumimoji="0" lang="ko-KR" altLang="ko-KR" sz="1800" b="1" i="0" u="none" strike="noStrike" cap="none" normalizeH="0" baseline="0" dirty="0" err="1">
+                <a:ln>
+                  <a:noFill/>
+                </a:ln>
+                <a:solidFill>
+                  <a:schemeClr val="tx1"/>
+                </a:solidFill>
+                <a:effectLst/>
+                <a:latin typeface="Arial" panose="020B0604020202020204" pitchFamily="34" charset="0"/>
               </a:rPr>
-              <a:t>학습 안정성 향상 </a:t>
-            </a:r>
-            <a:r>
-              <a:rPr lang="en-US" altLang="ko-KR" sz="2000" b="1" dirty="0">
-                <a:latin typeface="Pretendard Light" panose="02000403000000020004" pitchFamily="2" charset="-127"/>
-                <a:ea typeface="Pretendard Light" panose="02000403000000020004" pitchFamily="2" charset="-127"/>
-                <a:cs typeface="Pretendard Light" panose="02000403000000020004" pitchFamily="2" charset="-127"/>
-              </a:rPr>
-              <a:t>: </a:t>
-            </a:r>
-            <a:r>
-              <a:rPr lang="ko-KR" altLang="en-US" sz="2000" dirty="0">
-                <a:latin typeface="Pretendard Light" panose="02000403000000020004" pitchFamily="2" charset="-127"/>
-                <a:ea typeface="Pretendard Light" panose="02000403000000020004" pitchFamily="2" charset="-127"/>
-                <a:cs typeface="Pretendard Light" panose="02000403000000020004" pitchFamily="2" charset="-127"/>
-              </a:rPr>
-              <a:t>가중치의 크기와 방향을 분리해 효율적 학습 가능</a:t>
-            </a:r>
-            <a:r>
-              <a:rPr lang="en-US" altLang="ko-KR" sz="2000" dirty="0">
-                <a:latin typeface="Pretendard Light" panose="02000403000000020004" pitchFamily="2" charset="-127"/>
-                <a:ea typeface="Pretendard Light" panose="02000403000000020004" pitchFamily="2" charset="-127"/>
-                <a:cs typeface="Pretendard Light" panose="02000403000000020004" pitchFamily="2" charset="-127"/>
-              </a:rPr>
-              <a:t>. </a:t>
-            </a:r>
-            <a:r>
-              <a:rPr lang="en-US" altLang="ko-KR" sz="2000" b="1" dirty="0" err="1">
-                <a:latin typeface="Pretendard Light" panose="02000403000000020004" pitchFamily="2" charset="-127"/>
-                <a:ea typeface="Pretendard Light" panose="02000403000000020004" pitchFamily="2" charset="-127"/>
-                <a:cs typeface="Pretendard Light" panose="02000403000000020004" pitchFamily="2" charset="-127"/>
-              </a:rPr>
-              <a:t>Overfiting</a:t>
-            </a:r>
-            <a:r>
-              <a:rPr lang="en-US" altLang="ko-KR" sz="2000" b="1" dirty="0">
-                <a:latin typeface="Pretendard Light" panose="02000403000000020004" pitchFamily="2" charset="-127"/>
-                <a:ea typeface="Pretendard Light" panose="02000403000000020004" pitchFamily="2" charset="-127"/>
-                <a:cs typeface="Pretendard Light" panose="02000403000000020004" pitchFamily="2" charset="-127"/>
+              <a:t>Original</a:t>
+            </a:r>
+            <a:r>
+              <a:rPr kumimoji="0" lang="ko-KR" altLang="ko-KR" sz="1800" b="1" i="0" u="none" strike="noStrike" cap="none" normalizeH="0" baseline="0" dirty="0">
+                <a:ln>
+                  <a:noFill/>
+                </a:ln>
+                <a:solidFill>
+                  <a:schemeClr val="tx1"/>
+                </a:solidFill>
+                <a:effectLst/>
+                <a:latin typeface="Arial" panose="020B0604020202020204" pitchFamily="34" charset="0"/>
               </a:rPr>
               <a:t> </a:t>
             </a:r>
             <a:r>
-              <a:rPr lang="ko-KR" altLang="en-US" sz="2000" b="1" dirty="0">
-                <a:latin typeface="Pretendard Light" panose="02000403000000020004" pitchFamily="2" charset="-127"/>
-                <a:ea typeface="Pretendard Light" panose="02000403000000020004" pitchFamily="2" charset="-127"/>
-                <a:cs typeface="Pretendard Light" panose="02000403000000020004" pitchFamily="2" charset="-127"/>
+              <a:rPr kumimoji="0" lang="ko-KR" altLang="ko-KR" sz="1800" b="1" i="0" u="none" strike="noStrike" cap="none" normalizeH="0" baseline="0" dirty="0" err="1">
+                <a:ln>
+                  <a:noFill/>
+                </a:ln>
+                <a:solidFill>
+                  <a:schemeClr val="tx1"/>
+                </a:solidFill>
+                <a:effectLst/>
+                <a:latin typeface="Arial" panose="020B0604020202020204" pitchFamily="34" charset="0"/>
               </a:rPr>
-              <a:t>완화</a:t>
-            </a:r>
-            <a:endParaRPr lang="en-US" altLang="ko-KR" sz="2000" b="1" dirty="0">
-              <a:latin typeface="Pretendard Light" panose="02000403000000020004" pitchFamily="2" charset="-127"/>
-              <a:ea typeface="Pretendard Light" panose="02000403000000020004" pitchFamily="2" charset="-127"/>
-              <a:cs typeface="Pretendard Light" panose="02000403000000020004" pitchFamily="2" charset="-127"/>
-            </a:endParaRPr>
-          </a:p>
-          <a:p>
-            <a:pPr marL="800100" lvl="1" indent="-342900">
+              <a:t>Loss</a:t>
+            </a:r>
+            <a:r>
+              <a:rPr kumimoji="0" lang="ko-KR" altLang="ko-KR" sz="1800" b="0" i="0" u="none" strike="noStrike" cap="none" normalizeH="0" baseline="0" dirty="0">
+                <a:ln>
+                  <a:noFill/>
+                </a:ln>
+                <a:solidFill>
+                  <a:schemeClr val="tx1"/>
+                </a:solidFill>
+                <a:effectLst/>
+                <a:latin typeface="Arial" panose="020B0604020202020204" pitchFamily="34" charset="0"/>
+              </a:rPr>
+              <a:t> → 예측 오차</a:t>
+            </a:r>
+          </a:p>
+          <a:p>
+            <a:pPr marL="0" marR="0" lvl="0" indent="0" algn="l" defTabSz="914400" rtl="0" eaLnBrk="0" fontAlgn="base" latinLnBrk="0" hangingPunct="0">
               <a:lnSpc>
-                <a:spcPct val="150000"/>
+                <a:spcPct val="100000"/>
               </a:lnSpc>
-              <a:buFont typeface="Arial" panose="020B0604020202020204" pitchFamily="34" charset="0"/>
+              <a:spcBef>
+                <a:spcPct val="0"/>
+              </a:spcBef>
+              <a:spcAft>
+                <a:spcPct val="0"/>
+              </a:spcAft>
+              <a:buClrTx/>
+              <a:buSzTx/>
+              <a:buFontTx/>
               <a:buChar char="•"/>
+              <a:tabLst/>
             </a:pPr>
             <a:r>
-              <a:rPr lang="ko-KR" altLang="en-US" sz="2000" b="1" dirty="0">
-                <a:latin typeface="Pretendard Light" panose="02000403000000020004" pitchFamily="2" charset="-127"/>
-                <a:ea typeface="Pretendard Light" panose="02000403000000020004" pitchFamily="2" charset="-127"/>
-                <a:cs typeface="Pretendard Light" panose="02000403000000020004" pitchFamily="2" charset="-127"/>
+              <a:rPr kumimoji="0" lang="ko-KR" altLang="ko-KR" b="1" i="0" u="none" strike="noStrike" cap="none" normalizeH="0" baseline="0" dirty="0" err="1">
+                <a:ln>
+                  <a:noFill/>
+                </a:ln>
+                <a:solidFill>
+                  <a:schemeClr val="tx1"/>
+                </a:solidFill>
+                <a:effectLst/>
+                <a:latin typeface="Arial" panose="020B0604020202020204" pitchFamily="34" charset="0"/>
               </a:rPr>
-              <a:t>문제 완화 </a:t>
-            </a:r>
-            <a:r>
-              <a:rPr lang="en-US" altLang="ko-KR" sz="2000" b="1" dirty="0">
-                <a:latin typeface="Pretendard Light" panose="02000403000000020004" pitchFamily="2" charset="-127"/>
-                <a:ea typeface="Pretendard Light" panose="02000403000000020004" pitchFamily="2" charset="-127"/>
-                <a:cs typeface="Pretendard Light" panose="02000403000000020004" pitchFamily="2" charset="-127"/>
+              <a:t>λ</a:t>
+            </a:r>
+            <a:r>
+              <a:rPr kumimoji="0" lang="ko-KR" altLang="ko-KR" b="1" i="0" u="none" strike="noStrike" cap="none" normalizeH="0" baseline="0" dirty="0">
+                <a:ln>
+                  <a:noFill/>
+                </a:ln>
+                <a:solidFill>
+                  <a:schemeClr val="tx1"/>
+                </a:solidFill>
+                <a:effectLst/>
+                <a:latin typeface="Arial" panose="020B0604020202020204" pitchFamily="34" charset="0"/>
               </a:rPr>
-              <a:t>: </a:t>
-            </a:r>
-            <a:r>
-              <a:rPr lang="ko-KR" altLang="en-US" sz="2000" dirty="0">
-                <a:latin typeface="Pretendard Light" panose="02000403000000020004" pitchFamily="2" charset="-127"/>
-                <a:ea typeface="Pretendard Light" panose="02000403000000020004" pitchFamily="2" charset="-127"/>
-                <a:cs typeface="Pretendard Light" panose="02000403000000020004" pitchFamily="2" charset="-127"/>
+              <a:t> (람다)</a:t>
+            </a:r>
+            <a:r>
+              <a:rPr kumimoji="0" lang="ko-KR" altLang="ko-KR" b="0" i="0" u="none" strike="noStrike" cap="none" normalizeH="0" baseline="0" dirty="0">
+                <a:ln>
+                  <a:noFill/>
+                </a:ln>
+                <a:solidFill>
+                  <a:schemeClr val="tx1"/>
+                </a:solidFill>
+                <a:effectLst/>
+                <a:latin typeface="Arial" panose="020B0604020202020204" pitchFamily="34" charset="0"/>
               </a:rPr>
-              <a:t>기울기 소실 문제를 줄이고</a:t>
-            </a:r>
-            <a:r>
-              <a:rPr lang="en-US" altLang="ko-KR" sz="2000" dirty="0">
-                <a:latin typeface="Pretendard Light" panose="02000403000000020004" pitchFamily="2" charset="-127"/>
-                <a:ea typeface="Pretendard Light" panose="02000403000000020004" pitchFamily="2" charset="-127"/>
-                <a:cs typeface="Pretendard Light" panose="02000403000000020004" pitchFamily="2" charset="-127"/>
+              <a:t> → 규제 강도</a:t>
+            </a:r>
+          </a:p>
+          <a:p>
+            <a:pPr marL="0" marR="0" lvl="0" indent="0" algn="l" defTabSz="914400" rtl="0" eaLnBrk="0" fontAlgn="base" latinLnBrk="0" hangingPunct="0">
+              <a:lnSpc>
+                <a:spcPct val="100000"/>
+              </a:lnSpc>
+              <a:spcBef>
+                <a:spcPct val="0"/>
+              </a:spcBef>
+              <a:spcAft>
+                <a:spcPct val="0"/>
+              </a:spcAft>
+              <a:buClrTx/>
+              <a:buSzTx/>
+              <a:buFontTx/>
+              <a:buChar char="•"/>
+              <a:tabLst/>
+            </a:pPr>
+            <a:r>
+              <a:rPr kumimoji="0" lang="ko-KR" altLang="ko-KR" sz="1800" b="1" i="0" u="none" strike="noStrike" cap="none" normalizeH="0" baseline="0" dirty="0" err="1">
+                <a:ln>
+                  <a:noFill/>
+                </a:ln>
+                <a:solidFill>
+                  <a:schemeClr val="tx1"/>
+                </a:solidFill>
+                <a:effectLst/>
+                <a:latin typeface="Arial" panose="020B0604020202020204" pitchFamily="34" charset="0"/>
               </a:rPr>
-              <a:t>, </a:t>
-            </a:r>
-            <a:r>
-              <a:rPr lang="ko-KR" altLang="en-US" sz="2000" dirty="0" err="1">
-                <a:latin typeface="Pretendard Light" panose="02000403000000020004" pitchFamily="2" charset="-127"/>
-                <a:ea typeface="Pretendard Light" panose="02000403000000020004" pitchFamily="2" charset="-127"/>
-                <a:cs typeface="Pretendard Light" panose="02000403000000020004" pitchFamily="2" charset="-127"/>
+              <a:t>Regularization</a:t>
+            </a:r>
+            <a:r>
+              <a:rPr kumimoji="0" lang="ko-KR" altLang="ko-KR" sz="1800" b="1" i="0" u="none" strike="noStrike" cap="none" normalizeH="0" baseline="0" dirty="0">
+                <a:ln>
+                  <a:noFill/>
+                </a:ln>
+                <a:solidFill>
+                  <a:schemeClr val="tx1"/>
+                </a:solidFill>
+                <a:effectLst/>
+                <a:latin typeface="Arial" panose="020B0604020202020204" pitchFamily="34" charset="0"/>
               </a:rPr>
-              <a:t>딥러닝이</a:t>
-            </a:r>
-            <a:r>
-              <a:rPr lang="ko-KR" altLang="en-US" sz="2000" dirty="0">
-                <a:latin typeface="Pretendard Light" panose="02000403000000020004" pitchFamily="2" charset="-127"/>
-                <a:ea typeface="Pretendard Light" panose="02000403000000020004" pitchFamily="2" charset="-127"/>
-                <a:cs typeface="Pretendard Light" panose="02000403000000020004" pitchFamily="2" charset="-127"/>
+              <a:t> </a:t>
+            </a:r>
+            <a:r>
+              <a:rPr kumimoji="0" lang="ko-KR" altLang="ko-KR" sz="1800" b="1" i="0" u="none" strike="noStrike" cap="none" normalizeH="0" baseline="0" dirty="0" err="1">
+                <a:ln>
+                  <a:noFill/>
+                </a:ln>
+                <a:solidFill>
+                  <a:schemeClr val="tx1"/>
+                </a:solidFill>
+                <a:effectLst/>
+                <a:latin typeface="Arial" panose="020B0604020202020204" pitchFamily="34" charset="0"/>
               </a:rPr>
-              <a:t> 깊어질 때도 학습이 잘 진행되도록 도움</a:t>
-            </a:r>
-            <a:r>
-              <a:rPr lang="en-US" altLang="ko-KR" sz="2000" dirty="0">
-                <a:latin typeface="Pretendard Light" panose="02000403000000020004" pitchFamily="2" charset="-127"/>
-                <a:ea typeface="Pretendard Light" panose="02000403000000020004" pitchFamily="2" charset="-127"/>
-                <a:cs typeface="Pretendard Light" panose="02000403000000020004" pitchFamily="2" charset="-127"/>
+              <a:t>Term</a:t>
+            </a:r>
+            <a:r>
+              <a:rPr kumimoji="0" lang="ko-KR" altLang="ko-KR" sz="1800" b="0" i="0" u="none" strike="noStrike" cap="none" normalizeH="0" baseline="0" dirty="0">
+                <a:ln>
+                  <a:noFill/>
+                </a:ln>
+                <a:solidFill>
+                  <a:schemeClr val="tx1"/>
+                </a:solidFill>
+                <a:effectLst/>
+                <a:latin typeface="Arial" panose="020B0604020202020204" pitchFamily="34" charset="0"/>
               </a:rPr>
-              <a:t>.</a:t>
-            </a:r>
-          </a:p>
-          <a:p>
-            <a:pPr marL="800100" lvl="1" indent="-342900">
-              <a:lnSpc>
-                <a:spcPct val="150000"/>
-              </a:lnSpc>
-              <a:buFont typeface="Arial" panose="020B0604020202020204" pitchFamily="34" charset="0"/>
-              <a:buChar char="•"/>
-            </a:pPr>
-            <a:r>
-              <a:rPr lang="ko-KR" altLang="en-US" sz="2000" b="1" dirty="0">
-                <a:latin typeface="Pretendard Light" panose="02000403000000020004" pitchFamily="2" charset="-127"/>
-                <a:ea typeface="Pretendard Light" panose="02000403000000020004" pitchFamily="2" charset="-127"/>
-                <a:cs typeface="Pretendard Light" panose="02000403000000020004" pitchFamily="2" charset="-127"/>
-              </a:rPr>
-              <a:t>특수 상황에 유리 </a:t>
-            </a:r>
-            <a:r>
-              <a:rPr lang="en-US" altLang="ko-KR" sz="2000" b="1" dirty="0">
-                <a:latin typeface="Pretendard Light" panose="02000403000000020004" pitchFamily="2" charset="-127"/>
-                <a:ea typeface="Pretendard Light" panose="02000403000000020004" pitchFamily="2" charset="-127"/>
-                <a:cs typeface="Pretendard Light" panose="02000403000000020004" pitchFamily="2" charset="-127"/>
-              </a:rPr>
-              <a:t>: </a:t>
-            </a:r>
-            <a:r>
-              <a:rPr lang="en-US" altLang="ko-KR" sz="2000" dirty="0">
-                <a:latin typeface="Pretendard Light" panose="02000403000000020004" pitchFamily="2" charset="-127"/>
-                <a:ea typeface="Pretendard Light" panose="02000403000000020004" pitchFamily="2" charset="-127"/>
-                <a:cs typeface="Pretendard Light" panose="02000403000000020004" pitchFamily="2" charset="-127"/>
-              </a:rPr>
-              <a:t>RNN(</a:t>
-            </a:r>
-            <a:r>
-              <a:rPr lang="ko-KR" altLang="en-US" sz="2000" dirty="0">
-                <a:latin typeface="Pretendard Light" panose="02000403000000020004" pitchFamily="2" charset="-127"/>
-                <a:ea typeface="Pretendard Light" panose="02000403000000020004" pitchFamily="2" charset="-127"/>
-                <a:cs typeface="Pretendard Light" panose="02000403000000020004" pitchFamily="2" charset="-127"/>
-              </a:rPr>
-              <a:t>연속 데이터 처리</a:t>
-            </a:r>
-            <a:r>
-              <a:rPr lang="en-US" altLang="ko-KR" sz="2000" dirty="0">
-                <a:latin typeface="Pretendard Light" panose="02000403000000020004" pitchFamily="2" charset="-127"/>
-                <a:ea typeface="Pretendard Light" panose="02000403000000020004" pitchFamily="2" charset="-127"/>
-                <a:cs typeface="Pretendard Light" panose="02000403000000020004" pitchFamily="2" charset="-127"/>
-              </a:rPr>
-              <a:t>)</a:t>
-            </a:r>
-            <a:r>
-              <a:rPr lang="ko-KR" altLang="en-US" sz="2000" dirty="0">
-                <a:latin typeface="Pretendard Light" panose="02000403000000020004" pitchFamily="2" charset="-127"/>
-                <a:ea typeface="Pretendard Light" panose="02000403000000020004" pitchFamily="2" charset="-127"/>
-                <a:cs typeface="Pretendard Light" panose="02000403000000020004" pitchFamily="2" charset="-127"/>
-              </a:rPr>
-              <a:t>이나 작은 배치 크기에서도 효과적</a:t>
-            </a:r>
-            <a:r>
-              <a:rPr lang="en-US" altLang="ko-KR" sz="2000" dirty="0">
-                <a:latin typeface="Pretendard Light" panose="02000403000000020004" pitchFamily="2" charset="-127"/>
-                <a:ea typeface="Pretendard Light" panose="02000403000000020004" pitchFamily="2" charset="-127"/>
-                <a:cs typeface="Pretendard Light" panose="02000403000000020004" pitchFamily="2" charset="-127"/>
-              </a:rPr>
-              <a:t>.</a:t>
+              <a:t> → L1 또는 L2</a:t>
             </a:r>
           </a:p>
         </p:txBody>
       </p:sp>
+      <p:pic>
+        <p:nvPicPr>
+          <p:cNvPr id="1027" name="Picture 3">
+            <a:extLst>
+              <a:ext uri="{FF2B5EF4-FFF2-40B4-BE49-F238E27FC236}">
+                <a16:creationId xmlns:a16="http://schemas.microsoft.com/office/drawing/2014/main" id="{9ED50694-C090-05E6-7BC7-F1B137890740}"/>
+              </a:ext>
+            </a:extLst>
+          </p:cNvPr>
+          <p:cNvPicPr>
+            <a:picLocks noChangeAspect="1" noChangeArrowheads="1"/>
+          </p:cNvPicPr>
+          <p:nvPr/>
+        </p:nvPicPr>
+        <p:blipFill>
+          <a:blip r:embed="rId3">
+            <a:extLst>
+              <a:ext uri="{28A0092B-C50C-407E-A947-70E740481C1C}">
+                <a14:useLocalDpi xmlns:a14="http://schemas.microsoft.com/office/drawing/2010/main" val="0"/>
+              </a:ext>
+            </a:extLst>
+          </a:blip>
+          <a:srcRect/>
+          <a:stretch>
+            <a:fillRect/>
+          </a:stretch>
+        </p:blipFill>
+        <p:spPr bwMode="auto">
+          <a:xfrm>
+            <a:off x="4149969" y="3028303"/>
+            <a:ext cx="6869430" cy="3336580"/>
+          </a:xfrm>
+          <a:prstGeom prst="rect">
+            <a:avLst/>
+          </a:prstGeom>
+          <a:noFill/>
+          <a:extLst>
+            <a:ext uri="{909E8E84-426E-40DD-AFC4-6F175D3DCCD1}">
+              <a14:hiddenFill xmlns:a14="http://schemas.microsoft.com/office/drawing/2010/main">
+                <a:solidFill>
+                  <a:srgbClr val="FFFFFF"/>
+                </a:solidFill>
+              </a14:hiddenFill>
+            </a:ext>
+          </a:extLst>
+        </p:spPr>
+      </p:pic>
     </p:spTree>
     <p:extLst>
       <p:ext uri="{BB962C8B-B14F-4D97-AF65-F5344CB8AC3E}">
-        <p14:creationId xmlns:p14="http://schemas.microsoft.com/office/powerpoint/2010/main" val="3324878557"/>
+        <p14:creationId xmlns:p14="http://schemas.microsoft.com/office/powerpoint/2010/main" val="370933815"/>
       </p:ext>
     </p:extLst>
   </p:cSld>
@@ -14352,881 +15565,9 @@
           </a:bodyPr>
           <a:lstStyle/>
           <a:p>
-            <a:pPr marL="0" indent="0">
-              <a:buFont typeface="Arial" panose="020B0604020202020204" pitchFamily="34" charset="0"/>
-              <a:buNone/>
-            </a:pPr>
-            <a:r>
-              <a:rPr lang="en-US" altLang="ko-KR" b="1" dirty="0">
-                <a:latin typeface="+mj-ea"/>
-              </a:rPr>
-              <a:t>Weight normalization</a:t>
-            </a:r>
-            <a:endParaRPr lang="ko-KR" altLang="en-US" b="1" dirty="0">
-              <a:latin typeface="+mj-ea"/>
-            </a:endParaRPr>
-          </a:p>
-        </p:txBody>
-      </p:sp>
-      <p:sp>
-        <p:nvSpPr>
-          <p:cNvPr id="4" name="날짜 개체 틀 3">
-            <a:extLst>
-              <a:ext uri="{FF2B5EF4-FFF2-40B4-BE49-F238E27FC236}">
-                <a16:creationId xmlns:a16="http://schemas.microsoft.com/office/drawing/2014/main" id="{590F8720-7C11-4CC8-8215-3F57F085A24B}"/>
-              </a:ext>
-            </a:extLst>
-          </p:cNvPr>
-          <p:cNvSpPr>
-            <a:spLocks noGrp="1"/>
-          </p:cNvSpPr>
-          <p:nvPr>
-            <p:ph type="dt" sz="half" idx="10"/>
-          </p:nvPr>
-        </p:nvSpPr>
-        <p:spPr/>
-        <p:txBody>
-          <a:bodyPr/>
-          <a:lstStyle/>
-          <a:p>
-            <a:fld id="{0F78D9C4-20C1-4B15-A116-16DC77AD9A1E}" type="datetime1">
-              <a:rPr lang="ko-KR" altLang="en-US" smtClean="0"/>
-              <a:t>2026-02-19</a:t>
-            </a:fld>
-            <a:endParaRPr lang="ko-KR" altLang="en-US"/>
-          </a:p>
-        </p:txBody>
-      </p:sp>
-      <p:sp>
-        <p:nvSpPr>
-          <p:cNvPr id="5" name="슬라이드 번호 개체 틀 4">
-            <a:extLst>
-              <a:ext uri="{FF2B5EF4-FFF2-40B4-BE49-F238E27FC236}">
-                <a16:creationId xmlns:a16="http://schemas.microsoft.com/office/drawing/2014/main" id="{E86D5960-457B-4CA2-B0B3-F7F0DADA85D8}"/>
-              </a:ext>
-            </a:extLst>
-          </p:cNvPr>
-          <p:cNvSpPr>
-            <a:spLocks noGrp="1"/>
-          </p:cNvSpPr>
-          <p:nvPr>
-            <p:ph type="sldNum" sz="quarter" idx="12"/>
-          </p:nvPr>
-        </p:nvSpPr>
-        <p:spPr/>
-        <p:txBody>
-          <a:bodyPr/>
-          <a:lstStyle/>
-          <a:p>
-            <a:fld id="{083A2CE0-18CD-4102-B738-4ACFF9E68BA4}" type="slidenum">
-              <a:rPr lang="ko-KR" altLang="en-US" smtClean="0"/>
-              <a:t>30</a:t>
-            </a:fld>
-            <a:endParaRPr lang="ko-KR" altLang="en-US"/>
-          </a:p>
-        </p:txBody>
-      </p:sp>
-      <p:grpSp>
-        <p:nvGrpSpPr>
-          <p:cNvPr id="7" name="그룹 6"/>
-          <p:cNvGrpSpPr/>
-          <p:nvPr/>
-        </p:nvGrpSpPr>
-        <p:grpSpPr>
-          <a:xfrm>
-            <a:off x="1599019" y="1674339"/>
-            <a:ext cx="8993962" cy="4276736"/>
-            <a:chOff x="2092596" y="2082479"/>
-            <a:chExt cx="7122841" cy="3688574"/>
-          </a:xfrm>
-        </p:grpSpPr>
-        <p:pic>
-          <p:nvPicPr>
-            <p:cNvPr id="13314" name="Picture 2" descr="인공 신경망 및 심층 신경망 소개 - Deeplearning4j: Open-source, Distributed Deep Learning  for the JVM"/>
-            <p:cNvPicPr>
-              <a:picLocks noChangeAspect="1" noChangeArrowheads="1"/>
-            </p:cNvPicPr>
-            <p:nvPr/>
-          </p:nvPicPr>
-          <p:blipFill>
-            <a:blip r:embed="rId2">
-              <a:extLst>
-                <a:ext uri="{28A0092B-C50C-407E-A947-70E740481C1C}">
-                  <a14:useLocalDpi xmlns:a14="http://schemas.microsoft.com/office/drawing/2010/main" val="0"/>
-                </a:ext>
-              </a:extLst>
-            </a:blip>
-            <a:srcRect/>
-            <a:stretch>
-              <a:fillRect/>
-            </a:stretch>
-          </p:blipFill>
-          <p:spPr bwMode="auto">
-            <a:xfrm>
-              <a:off x="2976562" y="2082479"/>
-              <a:ext cx="6238875" cy="3028950"/>
-            </a:xfrm>
-            <a:prstGeom prst="rect">
-              <a:avLst/>
-            </a:prstGeom>
-            <a:noFill/>
-            <a:extLst>
-              <a:ext uri="{909E8E84-426E-40DD-AFC4-6F175D3DCCD1}">
-                <a14:hiddenFill xmlns:a14="http://schemas.microsoft.com/office/drawing/2010/main">
-                  <a:solidFill>
-                    <a:srgbClr val="FFFFFF"/>
-                  </a:solidFill>
-                </a14:hiddenFill>
-              </a:ext>
-            </a:extLst>
-          </p:spPr>
-        </p:pic>
-        <p:sp>
-          <p:nvSpPr>
-            <p:cNvPr id="3" name="TextBox 2"/>
-            <p:cNvSpPr txBox="1"/>
-            <p:nvPr/>
-          </p:nvSpPr>
-          <p:spPr>
-            <a:xfrm>
-              <a:off x="2103015" y="2708476"/>
-              <a:ext cx="570990" cy="369332"/>
-            </a:xfrm>
-            <a:prstGeom prst="rect">
-              <a:avLst/>
-            </a:prstGeom>
-            <a:noFill/>
-          </p:spPr>
-          <p:txBody>
-            <a:bodyPr wrap="none" rtlCol="0">
-              <a:spAutoFit/>
-            </a:bodyPr>
-            <a:lstStyle/>
-            <a:p>
-              <a:pPr algn="ctr"/>
-              <a:r>
-                <a:rPr lang="ko-KR" altLang="en-US" dirty="0"/>
-                <a:t>장르</a:t>
-              </a:r>
-            </a:p>
-          </p:txBody>
-        </p:sp>
-        <p:sp>
-          <p:nvSpPr>
-            <p:cNvPr id="8" name="TextBox 7"/>
-            <p:cNvSpPr txBox="1"/>
-            <p:nvPr/>
-          </p:nvSpPr>
-          <p:spPr>
-            <a:xfrm>
-              <a:off x="2117077" y="3412288"/>
-              <a:ext cx="569387" cy="369332"/>
-            </a:xfrm>
-            <a:prstGeom prst="rect">
-              <a:avLst/>
-            </a:prstGeom>
-            <a:noFill/>
-          </p:spPr>
-          <p:txBody>
-            <a:bodyPr wrap="none" rtlCol="0">
-              <a:spAutoFit/>
-            </a:bodyPr>
-            <a:lstStyle/>
-            <a:p>
-              <a:pPr algn="ctr"/>
-              <a:r>
-                <a:rPr lang="ko-KR" altLang="en-US"/>
-                <a:t>감독</a:t>
-              </a:r>
-            </a:p>
-          </p:txBody>
-        </p:sp>
-        <p:sp>
-          <p:nvSpPr>
-            <p:cNvPr id="9" name="TextBox 8"/>
-            <p:cNvSpPr txBox="1"/>
-            <p:nvPr/>
-          </p:nvSpPr>
-          <p:spPr>
-            <a:xfrm>
-              <a:off x="2117077" y="3973539"/>
-              <a:ext cx="575799" cy="369332"/>
-            </a:xfrm>
-            <a:prstGeom prst="rect">
-              <a:avLst/>
-            </a:prstGeom>
-            <a:noFill/>
-          </p:spPr>
-          <p:txBody>
-            <a:bodyPr wrap="none" rtlCol="0">
-              <a:spAutoFit/>
-            </a:bodyPr>
-            <a:lstStyle/>
-            <a:p>
-              <a:pPr algn="ctr"/>
-              <a:r>
-                <a:rPr lang="ko-KR" altLang="en-US"/>
-                <a:t>배우</a:t>
-              </a:r>
-              <a:endParaRPr lang="ko-KR" altLang="en-US" dirty="0"/>
-            </a:p>
-          </p:txBody>
-        </p:sp>
-        <p:sp>
-          <p:nvSpPr>
-            <p:cNvPr id="10" name="TextBox 9"/>
-            <p:cNvSpPr txBox="1"/>
-            <p:nvPr/>
-          </p:nvSpPr>
-          <p:spPr>
-            <a:xfrm>
-              <a:off x="2092596" y="4465098"/>
-              <a:ext cx="591829" cy="646331"/>
-            </a:xfrm>
-            <a:prstGeom prst="rect">
-              <a:avLst/>
-            </a:prstGeom>
-            <a:noFill/>
-          </p:spPr>
-          <p:txBody>
-            <a:bodyPr wrap="none" rtlCol="0">
-              <a:spAutoFit/>
-            </a:bodyPr>
-            <a:lstStyle/>
-            <a:p>
-              <a:pPr algn="ctr"/>
-              <a:r>
-                <a:rPr lang="ko-KR" altLang="en-US" dirty="0"/>
-                <a:t>상영</a:t>
-              </a:r>
-              <a:endParaRPr lang="en-US" altLang="ko-KR" dirty="0"/>
-            </a:p>
-            <a:p>
-              <a:pPr algn="ctr"/>
-              <a:r>
-                <a:rPr lang="ko-KR" altLang="en-US" dirty="0"/>
-                <a:t>시간</a:t>
-              </a:r>
-            </a:p>
-          </p:txBody>
-        </p:sp>
-        <p:sp>
-          <p:nvSpPr>
-            <p:cNvPr id="11" name="TextBox 10"/>
-            <p:cNvSpPr txBox="1"/>
-            <p:nvPr/>
-          </p:nvSpPr>
-          <p:spPr>
-            <a:xfrm>
-              <a:off x="2191982" y="5401721"/>
-              <a:ext cx="393056" cy="369332"/>
-            </a:xfrm>
-            <a:prstGeom prst="rect">
-              <a:avLst/>
-            </a:prstGeom>
-            <a:noFill/>
-          </p:spPr>
-          <p:txBody>
-            <a:bodyPr wrap="none" rtlCol="0">
-              <a:spAutoFit/>
-            </a:bodyPr>
-            <a:lstStyle/>
-            <a:p>
-              <a:pPr algn="ctr"/>
-              <a:r>
-                <a:rPr lang="en-US" altLang="ko-KR" dirty="0"/>
-                <a:t>…</a:t>
-              </a:r>
-              <a:endParaRPr lang="ko-KR" altLang="en-US" dirty="0"/>
-            </a:p>
-          </p:txBody>
-        </p:sp>
-      </p:grpSp>
-      <p:sp>
-        <p:nvSpPr>
-          <p:cNvPr id="12" name="직사각형 11"/>
-          <p:cNvSpPr/>
-          <p:nvPr/>
-        </p:nvSpPr>
-        <p:spPr>
-          <a:xfrm>
-            <a:off x="1629931" y="2314937"/>
-            <a:ext cx="727057" cy="1980225"/>
-          </a:xfrm>
-          <a:prstGeom prst="rect">
-            <a:avLst/>
-          </a:prstGeom>
-          <a:noFill/>
-          <a:ln w="25400">
-            <a:solidFill>
-              <a:srgbClr val="FF0000"/>
-            </a:solidFill>
-          </a:ln>
-        </p:spPr>
-        <p:style>
-          <a:lnRef idx="2">
-            <a:schemeClr val="accent1">
-              <a:shade val="50000"/>
-            </a:schemeClr>
-          </a:lnRef>
-          <a:fillRef idx="1">
-            <a:schemeClr val="accent1"/>
-          </a:fillRef>
-          <a:effectRef idx="0">
-            <a:schemeClr val="accent1"/>
-          </a:effectRef>
-          <a:fontRef idx="minor">
-            <a:schemeClr val="lt1"/>
-          </a:fontRef>
-        </p:style>
-        <p:txBody>
-          <a:bodyPr rtlCol="0" anchor="ctr"/>
-          <a:lstStyle/>
-          <a:p>
-            <a:pPr algn="ctr"/>
-            <a:endParaRPr lang="ko-KR" altLang="en-US"/>
-          </a:p>
-        </p:txBody>
-      </p:sp>
-    </p:spTree>
-    <p:extLst>
-      <p:ext uri="{BB962C8B-B14F-4D97-AF65-F5344CB8AC3E}">
-        <p14:creationId xmlns:p14="http://schemas.microsoft.com/office/powerpoint/2010/main" val="1963314682"/>
-      </p:ext>
-    </p:extLst>
-  </p:cSld>
-  <p:clrMapOvr>
-    <a:masterClrMapping/>
-  </p:clrMapOvr>
-</p:sld>
-</file>
-
-<file path=ppt/slides/slide31.xml><?xml version="1.0" encoding="utf-8"?>
-<p:sld xmlns:a="http://schemas.openxmlformats.org/drawingml/2006/main" xmlns:r="http://schemas.openxmlformats.org/officeDocument/2006/relationships" xmlns:p="http://schemas.openxmlformats.org/presentationml/2006/main">
-  <p:cSld>
-    <p:spTree>
-      <p:nvGrpSpPr>
-        <p:cNvPr id="1" name=""/>
-        <p:cNvGrpSpPr/>
-        <p:nvPr/>
-      </p:nvGrpSpPr>
-      <p:grpSpPr>
-        <a:xfrm>
-          <a:off x="0" y="0"/>
-          <a:ext cx="0" cy="0"/>
-          <a:chOff x="0" y="0"/>
-          <a:chExt cx="0" cy="0"/>
-        </a:xfrm>
-      </p:grpSpPr>
-      <p:sp>
-        <p:nvSpPr>
-          <p:cNvPr id="2" name="제목 1">
-            <a:extLst>
-              <a:ext uri="{FF2B5EF4-FFF2-40B4-BE49-F238E27FC236}">
-                <a16:creationId xmlns:a16="http://schemas.microsoft.com/office/drawing/2014/main" id="{A8D8F1F4-4871-4B45-B08E-F92ACDB80FE6}"/>
-              </a:ext>
-            </a:extLst>
-          </p:cNvPr>
-          <p:cNvSpPr>
-            <a:spLocks noGrp="1"/>
-          </p:cNvSpPr>
-          <p:nvPr>
-            <p:ph type="title"/>
-          </p:nvPr>
-        </p:nvSpPr>
-        <p:spPr/>
-        <p:txBody>
-          <a:bodyPr>
-            <a:normAutofit/>
-          </a:bodyPr>
-          <a:lstStyle/>
-          <a:p>
-            <a:pPr marL="0" indent="0">
-              <a:buFont typeface="Arial" panose="020B0604020202020204" pitchFamily="34" charset="0"/>
-              <a:buNone/>
-            </a:pPr>
-            <a:r>
-              <a:rPr lang="en-US" altLang="ko-KR" b="1" dirty="0">
-                <a:latin typeface="+mj-ea"/>
-              </a:rPr>
-              <a:t>Weight normalization</a:t>
-            </a:r>
-            <a:endParaRPr lang="ko-KR" altLang="en-US" b="1" dirty="0">
-              <a:latin typeface="+mj-ea"/>
-            </a:endParaRPr>
-          </a:p>
-        </p:txBody>
-      </p:sp>
-      <p:sp>
-        <p:nvSpPr>
-          <p:cNvPr id="25" name="내용 개체 틀 24">
-            <a:extLst>
-              <a:ext uri="{FF2B5EF4-FFF2-40B4-BE49-F238E27FC236}">
-                <a16:creationId xmlns:a16="http://schemas.microsoft.com/office/drawing/2014/main" id="{43D7F560-8665-3595-7BA0-A2C3C8AC7665}"/>
-              </a:ext>
-            </a:extLst>
-          </p:cNvPr>
-          <p:cNvSpPr>
-            <a:spLocks noGrp="1"/>
-          </p:cNvSpPr>
-          <p:nvPr>
-            <p:ph idx="1"/>
-          </p:nvPr>
-        </p:nvSpPr>
-        <p:spPr>
-          <a:xfrm>
-            <a:off x="251788" y="1145407"/>
-            <a:ext cx="11516810" cy="3372524"/>
-          </a:xfrm>
-        </p:spPr>
-        <p:txBody>
-          <a:bodyPr>
-            <a:normAutofit/>
-          </a:bodyPr>
-          <a:lstStyle/>
-          <a:p>
-            <a:pPr marL="0" indent="0">
-              <a:lnSpc>
-                <a:spcPct val="150000"/>
-              </a:lnSpc>
-              <a:buNone/>
-            </a:pPr>
-            <a:r>
-              <a:rPr lang="ko-KR" altLang="en-US" sz="2400" b="1" dirty="0">
-                <a:latin typeface="+mn-ea"/>
-              </a:rPr>
-              <a:t>✅ </a:t>
-            </a:r>
-            <a:r>
-              <a:rPr lang="en-US" altLang="ko-KR" sz="2400" b="1" dirty="0">
-                <a:latin typeface="+mn-ea"/>
-              </a:rPr>
-              <a:t>L1, L2 </a:t>
-            </a:r>
-            <a:r>
-              <a:rPr lang="ko-KR" altLang="en-US" sz="2400" b="1" dirty="0">
-                <a:latin typeface="+mn-ea"/>
-              </a:rPr>
-              <a:t>정규화</a:t>
-            </a:r>
-            <a:endParaRPr lang="en-US" altLang="ko-KR" sz="2400" b="1" dirty="0">
-              <a:latin typeface="+mn-ea"/>
-            </a:endParaRPr>
-          </a:p>
-          <a:p>
-            <a:pPr lvl="1">
-              <a:lnSpc>
-                <a:spcPct val="150000"/>
-              </a:lnSpc>
-              <a:buFont typeface="Wingdings" panose="05000000000000000000" pitchFamily="2" charset="2"/>
-              <a:buChar char="§"/>
-            </a:pPr>
-            <a:r>
-              <a:rPr lang="en-US" altLang="ko-KR" dirty="0">
-                <a:latin typeface="+mn-ea"/>
-              </a:rPr>
-              <a:t>Norm</a:t>
-            </a:r>
-          </a:p>
-          <a:p>
-            <a:pPr lvl="2">
-              <a:lnSpc>
-                <a:spcPct val="150000"/>
-              </a:lnSpc>
-            </a:pPr>
-            <a:r>
-              <a:rPr lang="ko-KR" altLang="en-US" dirty="0">
-                <a:latin typeface="+mn-ea"/>
-              </a:rPr>
-              <a:t>벡터의 크기를 측정하는 방법</a:t>
-            </a:r>
-            <a:r>
-              <a:rPr lang="en-US" altLang="ko-KR" dirty="0">
-                <a:latin typeface="+mn-ea"/>
-              </a:rPr>
-              <a:t>, </a:t>
-            </a:r>
-            <a:r>
-              <a:rPr lang="ko-KR" altLang="en-US" dirty="0">
-                <a:latin typeface="+mn-ea"/>
-              </a:rPr>
-              <a:t>두 벡터 사이의 거리를 측정하는 방법</a:t>
-            </a:r>
-            <a:endParaRPr lang="en-US" altLang="ko-KR" dirty="0">
-              <a:latin typeface="+mn-ea"/>
-            </a:endParaRPr>
-          </a:p>
-          <a:p>
-            <a:pPr lvl="2">
-              <a:lnSpc>
-                <a:spcPct val="150000"/>
-              </a:lnSpc>
-            </a:pPr>
-            <a:r>
-              <a:rPr lang="en-US" altLang="ko-KR" dirty="0">
-                <a:latin typeface="+mn-ea"/>
-              </a:rPr>
+            <a:r>
+              <a:rPr lang="en-US" altLang="ko-KR" dirty="0"/>
               <a:t>L1</a:t>
-            </a:r>
-            <a:r>
-              <a:rPr lang="ko-KR" altLang="en-US" dirty="0">
-                <a:latin typeface="+mn-ea"/>
-              </a:rPr>
-              <a:t> </a:t>
-            </a:r>
-            <a:r>
-              <a:rPr lang="en-US" altLang="ko-KR" dirty="0">
-                <a:latin typeface="+mn-ea"/>
-              </a:rPr>
-              <a:t>Norm : </a:t>
-            </a:r>
-            <a:r>
-              <a:rPr lang="ko-KR" altLang="en-US" dirty="0">
-                <a:latin typeface="+mn-ea"/>
-              </a:rPr>
-              <a:t>두 벡터 각 원소들 차이의 절대값의 합</a:t>
-            </a:r>
-            <a:endParaRPr lang="en-US" altLang="ko-KR" dirty="0">
-              <a:latin typeface="+mn-ea"/>
-            </a:endParaRPr>
-          </a:p>
-          <a:p>
-            <a:pPr lvl="2">
-              <a:lnSpc>
-                <a:spcPct val="150000"/>
-              </a:lnSpc>
-            </a:pPr>
-            <a:r>
-              <a:rPr lang="en-US" altLang="ko-KR" dirty="0">
-                <a:latin typeface="+mn-ea"/>
-              </a:rPr>
-              <a:t>L2 Norm: </a:t>
-            </a:r>
-            <a:r>
-              <a:rPr lang="ko-KR" altLang="en-US" dirty="0">
-                <a:latin typeface="+mn-ea"/>
-              </a:rPr>
-              <a:t>두 벡터 사이의 직선 거리</a:t>
-            </a:r>
-            <a:endParaRPr lang="en-US" altLang="ko-KR" dirty="0">
-              <a:latin typeface="+mn-ea"/>
-            </a:endParaRPr>
-          </a:p>
-          <a:p>
-            <a:pPr lvl="2">
-              <a:lnSpc>
-                <a:spcPct val="150000"/>
-              </a:lnSpc>
-            </a:pPr>
-            <a:r>
-              <a:rPr lang="en-US" altLang="ko-KR" dirty="0" err="1">
-                <a:latin typeface="+mn-ea"/>
-              </a:rPr>
-              <a:t>Lp</a:t>
-            </a:r>
-            <a:r>
-              <a:rPr lang="en-US" altLang="ko-KR" dirty="0">
-                <a:latin typeface="+mn-ea"/>
-              </a:rPr>
-              <a:t> Norm</a:t>
-            </a:r>
-            <a:r>
-              <a:rPr lang="ko-KR" altLang="en-US" dirty="0">
-                <a:latin typeface="+mn-ea"/>
-              </a:rPr>
-              <a:t> </a:t>
-            </a:r>
-            <a:endParaRPr lang="en-US" altLang="ko-KR" dirty="0">
-              <a:latin typeface="+mn-ea"/>
-            </a:endParaRPr>
-          </a:p>
-          <a:p>
-            <a:pPr marL="914400" lvl="2" indent="0">
-              <a:lnSpc>
-                <a:spcPct val="150000"/>
-              </a:lnSpc>
-              <a:buNone/>
-            </a:pPr>
-            <a:endParaRPr lang="en-US" altLang="ko-KR" sz="2800" dirty="0">
-              <a:latin typeface="+mn-ea"/>
-            </a:endParaRPr>
-          </a:p>
-        </p:txBody>
-      </p:sp>
-      <p:sp>
-        <p:nvSpPr>
-          <p:cNvPr id="4" name="날짜 개체 틀 3">
-            <a:extLst>
-              <a:ext uri="{FF2B5EF4-FFF2-40B4-BE49-F238E27FC236}">
-                <a16:creationId xmlns:a16="http://schemas.microsoft.com/office/drawing/2014/main" id="{590F8720-7C11-4CC8-8215-3F57F085A24B}"/>
-              </a:ext>
-            </a:extLst>
-          </p:cNvPr>
-          <p:cNvSpPr>
-            <a:spLocks noGrp="1"/>
-          </p:cNvSpPr>
-          <p:nvPr>
-            <p:ph type="dt" sz="half" idx="10"/>
-          </p:nvPr>
-        </p:nvSpPr>
-        <p:spPr/>
-        <p:txBody>
-          <a:bodyPr/>
-          <a:lstStyle/>
-          <a:p>
-            <a:fld id="{0F78D9C4-20C1-4B15-A116-16DC77AD9A1E}" type="datetime1">
-              <a:rPr lang="ko-KR" altLang="en-US" smtClean="0"/>
-              <a:t>2026-02-19</a:t>
-            </a:fld>
-            <a:endParaRPr lang="ko-KR" altLang="en-US"/>
-          </a:p>
-        </p:txBody>
-      </p:sp>
-      <p:sp>
-        <p:nvSpPr>
-          <p:cNvPr id="5" name="슬라이드 번호 개체 틀 4">
-            <a:extLst>
-              <a:ext uri="{FF2B5EF4-FFF2-40B4-BE49-F238E27FC236}">
-                <a16:creationId xmlns:a16="http://schemas.microsoft.com/office/drawing/2014/main" id="{E86D5960-457B-4CA2-B0B3-F7F0DADA85D8}"/>
-              </a:ext>
-            </a:extLst>
-          </p:cNvPr>
-          <p:cNvSpPr>
-            <a:spLocks noGrp="1"/>
-          </p:cNvSpPr>
-          <p:nvPr>
-            <p:ph type="sldNum" sz="quarter" idx="12"/>
-          </p:nvPr>
-        </p:nvSpPr>
-        <p:spPr/>
-        <p:txBody>
-          <a:bodyPr/>
-          <a:lstStyle/>
-          <a:p>
-            <a:fld id="{083A2CE0-18CD-4102-B738-4ACFF9E68BA4}" type="slidenum">
-              <a:rPr lang="ko-KR" altLang="en-US" smtClean="0"/>
-              <a:t>31</a:t>
-            </a:fld>
-            <a:endParaRPr lang="ko-KR" altLang="en-US"/>
-          </a:p>
-        </p:txBody>
-      </p:sp>
-      <p:pic>
-        <p:nvPicPr>
-          <p:cNvPr id="8" name="그림 7">
-            <a:extLst>
-              <a:ext uri="{FF2B5EF4-FFF2-40B4-BE49-F238E27FC236}">
-                <a16:creationId xmlns:a16="http://schemas.microsoft.com/office/drawing/2014/main" id="{FA8F71D8-6E01-AD0B-1B8A-AFCFA1C28A49}"/>
-              </a:ext>
-            </a:extLst>
-          </p:cNvPr>
-          <p:cNvPicPr>
-            <a:picLocks noChangeAspect="1"/>
-          </p:cNvPicPr>
-          <p:nvPr/>
-        </p:nvPicPr>
-        <p:blipFill>
-          <a:blip r:embed="rId2"/>
-          <a:stretch>
-            <a:fillRect/>
-          </a:stretch>
-        </p:blipFill>
-        <p:spPr>
-          <a:xfrm>
-            <a:off x="1753538" y="4517931"/>
-            <a:ext cx="8684923" cy="1451043"/>
-          </a:xfrm>
-          <a:prstGeom prst="rect">
-            <a:avLst/>
-          </a:prstGeom>
-        </p:spPr>
-      </p:pic>
-    </p:spTree>
-    <p:extLst>
-      <p:ext uri="{BB962C8B-B14F-4D97-AF65-F5344CB8AC3E}">
-        <p14:creationId xmlns:p14="http://schemas.microsoft.com/office/powerpoint/2010/main" val="982474946"/>
-      </p:ext>
-    </p:extLst>
-  </p:cSld>
-  <p:clrMapOvr>
-    <a:masterClrMapping/>
-  </p:clrMapOvr>
-</p:sld>
-</file>
-
-<file path=ppt/slides/slide32.xml><?xml version="1.0" encoding="utf-8"?>
-<p:sld xmlns:a="http://schemas.openxmlformats.org/drawingml/2006/main" xmlns:r="http://schemas.openxmlformats.org/officeDocument/2006/relationships" xmlns:p="http://schemas.openxmlformats.org/presentationml/2006/main">
-  <p:cSld>
-    <p:spTree>
-      <p:nvGrpSpPr>
-        <p:cNvPr id="1" name=""/>
-        <p:cNvGrpSpPr/>
-        <p:nvPr/>
-      </p:nvGrpSpPr>
-      <p:grpSpPr>
-        <a:xfrm>
-          <a:off x="0" y="0"/>
-          <a:ext cx="0" cy="0"/>
-          <a:chOff x="0" y="0"/>
-          <a:chExt cx="0" cy="0"/>
-        </a:xfrm>
-      </p:grpSpPr>
-      <p:sp>
-        <p:nvSpPr>
-          <p:cNvPr id="2" name="제목 1">
-            <a:extLst>
-              <a:ext uri="{FF2B5EF4-FFF2-40B4-BE49-F238E27FC236}">
-                <a16:creationId xmlns:a16="http://schemas.microsoft.com/office/drawing/2014/main" id="{A8D8F1F4-4871-4B45-B08E-F92ACDB80FE6}"/>
-              </a:ext>
-            </a:extLst>
-          </p:cNvPr>
-          <p:cNvSpPr>
-            <a:spLocks noGrp="1"/>
-          </p:cNvSpPr>
-          <p:nvPr>
-            <p:ph type="title"/>
-          </p:nvPr>
-        </p:nvSpPr>
-        <p:spPr/>
-        <p:txBody>
-          <a:bodyPr>
-            <a:normAutofit/>
-          </a:bodyPr>
-          <a:lstStyle/>
-          <a:p>
-            <a:pPr marL="0" indent="0">
-              <a:buFont typeface="Arial" panose="020B0604020202020204" pitchFamily="34" charset="0"/>
-              <a:buNone/>
-            </a:pPr>
-            <a:r>
-              <a:rPr lang="en-US" altLang="ko-KR" b="1" dirty="0">
-                <a:latin typeface="+mj-ea"/>
-              </a:rPr>
-              <a:t>Weight normalization</a:t>
-            </a:r>
-            <a:endParaRPr lang="ko-KR" altLang="en-US" b="1" dirty="0">
-              <a:latin typeface="+mj-ea"/>
-            </a:endParaRPr>
-          </a:p>
-        </p:txBody>
-      </p:sp>
-      <p:sp>
-        <p:nvSpPr>
-          <p:cNvPr id="25" name="내용 개체 틀 24">
-            <a:extLst>
-              <a:ext uri="{FF2B5EF4-FFF2-40B4-BE49-F238E27FC236}">
-                <a16:creationId xmlns:a16="http://schemas.microsoft.com/office/drawing/2014/main" id="{43D7F560-8665-3595-7BA0-A2C3C8AC7665}"/>
-              </a:ext>
-            </a:extLst>
-          </p:cNvPr>
-          <p:cNvSpPr>
-            <a:spLocks noGrp="1"/>
-          </p:cNvSpPr>
-          <p:nvPr>
-            <p:ph idx="1"/>
-          </p:nvPr>
-        </p:nvSpPr>
-        <p:spPr>
-          <a:xfrm>
-            <a:off x="251788" y="2013214"/>
-            <a:ext cx="8479995" cy="2831571"/>
-          </a:xfrm>
-        </p:spPr>
-        <p:txBody>
-          <a:bodyPr>
-            <a:normAutofit/>
-          </a:bodyPr>
-          <a:lstStyle/>
-          <a:p>
-            <a:pPr marL="0" indent="0">
-              <a:lnSpc>
-                <a:spcPct val="150000"/>
-              </a:lnSpc>
-              <a:buNone/>
-            </a:pPr>
-            <a:r>
-              <a:rPr lang="ko-KR" altLang="en-US" sz="2400" dirty="0">
-                <a:latin typeface="+mn-ea"/>
-              </a:rPr>
-              <a:t>✅ </a:t>
-            </a:r>
-            <a:r>
-              <a:rPr lang="en-US" altLang="ko-KR" sz="2400" dirty="0">
-                <a:latin typeface="+mn-ea"/>
-              </a:rPr>
-              <a:t>L1, L2 </a:t>
-            </a:r>
-            <a:r>
-              <a:rPr lang="ko-KR" altLang="en-US" sz="2400" dirty="0">
-                <a:latin typeface="+mn-ea"/>
-              </a:rPr>
-              <a:t>정규화</a:t>
-            </a:r>
-            <a:endParaRPr lang="en-US" altLang="ko-KR" sz="2400" dirty="0">
-              <a:latin typeface="+mn-ea"/>
-            </a:endParaRPr>
-          </a:p>
-          <a:p>
-            <a:pPr lvl="1">
-              <a:lnSpc>
-                <a:spcPct val="150000"/>
-              </a:lnSpc>
-              <a:buFont typeface="Wingdings" panose="05000000000000000000" pitchFamily="2" charset="2"/>
-              <a:buChar char="§"/>
-            </a:pPr>
-            <a:r>
-              <a:rPr lang="en-US" altLang="ko-KR" dirty="0">
-                <a:latin typeface="+mn-ea"/>
-              </a:rPr>
-              <a:t>L1 Norm</a:t>
-            </a:r>
-            <a:r>
-              <a:rPr lang="ko-KR" altLang="en-US" dirty="0">
-                <a:latin typeface="+mn-ea"/>
-              </a:rPr>
-              <a:t>과 </a:t>
-            </a:r>
-            <a:r>
-              <a:rPr lang="en-US" altLang="ko-KR" dirty="0">
-                <a:latin typeface="+mn-ea"/>
-              </a:rPr>
-              <a:t>L2 Norm</a:t>
-            </a:r>
-            <a:r>
-              <a:rPr lang="ko-KR" altLang="en-US" dirty="0">
-                <a:latin typeface="+mn-ea"/>
-              </a:rPr>
-              <a:t>의 직관적 차이</a:t>
-            </a:r>
-            <a:endParaRPr lang="en-US" altLang="ko-KR" dirty="0">
-              <a:latin typeface="+mn-ea"/>
-            </a:endParaRPr>
-          </a:p>
-          <a:p>
-            <a:pPr lvl="2">
-              <a:lnSpc>
-                <a:spcPct val="150000"/>
-              </a:lnSpc>
-            </a:pPr>
-            <a:r>
-              <a:rPr lang="ko-KR" altLang="en-US" dirty="0"/>
-              <a:t>오른쪽 그림은 두개의 벡터를 잇는 선을 나타냄</a:t>
-            </a:r>
-            <a:endParaRPr lang="en-US" altLang="ko-KR" dirty="0"/>
-          </a:p>
-          <a:p>
-            <a:pPr lvl="2">
-              <a:lnSpc>
-                <a:spcPct val="150000"/>
-              </a:lnSpc>
-            </a:pPr>
-            <a:r>
-              <a:rPr lang="ko-KR" altLang="en-US" dirty="0"/>
-              <a:t>초록색선이 </a:t>
-            </a:r>
-            <a:r>
-              <a:rPr lang="en-US" altLang="ko-KR" dirty="0"/>
-              <a:t>L2</a:t>
             </a:r>
             <a:r>
               <a:rPr lang="ko-KR" altLang="en-US" dirty="0"/>
@@ -15234,225 +15575,7 @@
             </a:r>
             <a:r>
               <a:rPr lang="en-US" altLang="ko-KR" dirty="0"/>
-              <a:t>Norm(Euclidean</a:t>
-            </a:r>
-            <a:r>
-              <a:rPr lang="ko-KR" altLang="en-US" dirty="0"/>
-              <a:t> </a:t>
-            </a:r>
-            <a:r>
-              <a:rPr lang="en-US" altLang="ko-KR" dirty="0"/>
-              <a:t>distance)</a:t>
-            </a:r>
-          </a:p>
-          <a:p>
-            <a:pPr lvl="2">
-              <a:lnSpc>
-                <a:spcPct val="150000"/>
-              </a:lnSpc>
-            </a:pPr>
-            <a:r>
-              <a:rPr lang="ko-KR" altLang="en-US" dirty="0"/>
-              <a:t>나머지 빨강</a:t>
-            </a:r>
-            <a:r>
-              <a:rPr lang="en-US" altLang="ko-KR" dirty="0"/>
-              <a:t>,</a:t>
-            </a:r>
-            <a:r>
-              <a:rPr lang="ko-KR" altLang="en-US" dirty="0"/>
-              <a:t>파랑</a:t>
-            </a:r>
-            <a:r>
-              <a:rPr lang="en-US" altLang="ko-KR" dirty="0"/>
-              <a:t>,</a:t>
-            </a:r>
-            <a:r>
-              <a:rPr lang="ko-KR" altLang="en-US" dirty="0"/>
-              <a:t>노랑 선은 모두 </a:t>
-            </a:r>
-            <a:r>
-              <a:rPr lang="en-US" altLang="ko-KR" dirty="0"/>
-              <a:t>L1 Norm(</a:t>
-            </a:r>
-            <a:r>
-              <a:rPr lang="en-US" altLang="ko-KR" dirty="0" err="1"/>
-              <a:t>Texicab</a:t>
-            </a:r>
-            <a:r>
-              <a:rPr lang="en-US" altLang="ko-KR" dirty="0"/>
-              <a:t> geometry)</a:t>
-            </a:r>
-          </a:p>
-        </p:txBody>
-      </p:sp>
-      <p:sp>
-        <p:nvSpPr>
-          <p:cNvPr id="4" name="날짜 개체 틀 3">
-            <a:extLst>
-              <a:ext uri="{FF2B5EF4-FFF2-40B4-BE49-F238E27FC236}">
-                <a16:creationId xmlns:a16="http://schemas.microsoft.com/office/drawing/2014/main" id="{590F8720-7C11-4CC8-8215-3F57F085A24B}"/>
-              </a:ext>
-            </a:extLst>
-          </p:cNvPr>
-          <p:cNvSpPr>
-            <a:spLocks noGrp="1"/>
-          </p:cNvSpPr>
-          <p:nvPr>
-            <p:ph type="dt" sz="half" idx="10"/>
-          </p:nvPr>
-        </p:nvSpPr>
-        <p:spPr/>
-        <p:txBody>
-          <a:bodyPr/>
-          <a:lstStyle/>
-          <a:p>
-            <a:fld id="{0F78D9C4-20C1-4B15-A116-16DC77AD9A1E}" type="datetime1">
-              <a:rPr lang="ko-KR" altLang="en-US" smtClean="0"/>
-              <a:t>2026-02-19</a:t>
-            </a:fld>
-            <a:endParaRPr lang="ko-KR" altLang="en-US"/>
-          </a:p>
-        </p:txBody>
-      </p:sp>
-      <p:sp>
-        <p:nvSpPr>
-          <p:cNvPr id="5" name="슬라이드 번호 개체 틀 4">
-            <a:extLst>
-              <a:ext uri="{FF2B5EF4-FFF2-40B4-BE49-F238E27FC236}">
-                <a16:creationId xmlns:a16="http://schemas.microsoft.com/office/drawing/2014/main" id="{E86D5960-457B-4CA2-B0B3-F7F0DADA85D8}"/>
-              </a:ext>
-            </a:extLst>
-          </p:cNvPr>
-          <p:cNvSpPr>
-            <a:spLocks noGrp="1"/>
-          </p:cNvSpPr>
-          <p:nvPr>
-            <p:ph type="sldNum" sz="quarter" idx="12"/>
-          </p:nvPr>
-        </p:nvSpPr>
-        <p:spPr/>
-        <p:txBody>
-          <a:bodyPr/>
-          <a:lstStyle/>
-          <a:p>
-            <a:fld id="{083A2CE0-18CD-4102-B738-4ACFF9E68BA4}" type="slidenum">
-              <a:rPr lang="ko-KR" altLang="en-US" smtClean="0"/>
-              <a:t>32</a:t>
-            </a:fld>
-            <a:endParaRPr lang="ko-KR" altLang="en-US"/>
-          </a:p>
-        </p:txBody>
-      </p:sp>
-      <p:pic>
-        <p:nvPicPr>
-          <p:cNvPr id="6146" name="Picture 2">
-            <a:extLst>
-              <a:ext uri="{FF2B5EF4-FFF2-40B4-BE49-F238E27FC236}">
-                <a16:creationId xmlns:a16="http://schemas.microsoft.com/office/drawing/2014/main" id="{9962A15B-4B2B-47B0-7C28-51478107180B}"/>
-              </a:ext>
-            </a:extLst>
-          </p:cNvPr>
-          <p:cNvPicPr>
-            <a:picLocks noChangeAspect="1" noChangeArrowheads="1"/>
-          </p:cNvPicPr>
-          <p:nvPr/>
-        </p:nvPicPr>
-        <p:blipFill>
-          <a:blip r:embed="rId2">
-            <a:extLst>
-              <a:ext uri="{28A0092B-C50C-407E-A947-70E740481C1C}">
-                <a14:useLocalDpi xmlns:a14="http://schemas.microsoft.com/office/drawing/2010/main" val="0"/>
-              </a:ext>
-            </a:extLst>
-          </a:blip>
-          <a:srcRect/>
-          <a:stretch>
-            <a:fillRect/>
-          </a:stretch>
-        </p:blipFill>
-        <p:spPr bwMode="auto">
-          <a:xfrm>
-            <a:off x="8325451" y="1931859"/>
-            <a:ext cx="3367016" cy="3367016"/>
-          </a:xfrm>
-          <a:prstGeom prst="rect">
-            <a:avLst/>
-          </a:prstGeom>
-          <a:noFill/>
-          <a:extLst>
-            <a:ext uri="{909E8E84-426E-40DD-AFC4-6F175D3DCCD1}">
-              <a14:hiddenFill xmlns:a14="http://schemas.microsoft.com/office/drawing/2010/main">
-                <a:solidFill>
-                  <a:srgbClr val="FFFFFF"/>
-                </a:solidFill>
-              </a14:hiddenFill>
-            </a:ext>
-          </a:extLst>
-        </p:spPr>
-      </p:pic>
-    </p:spTree>
-    <p:extLst>
-      <p:ext uri="{BB962C8B-B14F-4D97-AF65-F5344CB8AC3E}">
-        <p14:creationId xmlns:p14="http://schemas.microsoft.com/office/powerpoint/2010/main" val="176377775"/>
-      </p:ext>
-    </p:extLst>
-  </p:cSld>
-  <p:clrMapOvr>
-    <a:masterClrMapping/>
-  </p:clrMapOvr>
-</p:sld>
-</file>
-
-<file path=ppt/slides/slide33.xml><?xml version="1.0" encoding="utf-8"?>
-<p:sld xmlns:a="http://schemas.openxmlformats.org/drawingml/2006/main" xmlns:r="http://schemas.openxmlformats.org/officeDocument/2006/relationships" xmlns:p="http://schemas.openxmlformats.org/presentationml/2006/main">
-  <p:cSld>
-    <p:spTree>
-      <p:nvGrpSpPr>
-        <p:cNvPr id="1" name=""/>
-        <p:cNvGrpSpPr/>
-        <p:nvPr/>
-      </p:nvGrpSpPr>
-      <p:grpSpPr>
-        <a:xfrm>
-          <a:off x="0" y="0"/>
-          <a:ext cx="0" cy="0"/>
-          <a:chOff x="0" y="0"/>
-          <a:chExt cx="0" cy="0"/>
-        </a:xfrm>
-      </p:grpSpPr>
-      <p:sp>
-        <p:nvSpPr>
-          <p:cNvPr id="2" name="제목 1">
-            <a:extLst>
-              <a:ext uri="{FF2B5EF4-FFF2-40B4-BE49-F238E27FC236}">
-                <a16:creationId xmlns:a16="http://schemas.microsoft.com/office/drawing/2014/main" id="{A8D8F1F4-4871-4B45-B08E-F92ACDB80FE6}"/>
-              </a:ext>
-            </a:extLst>
-          </p:cNvPr>
-          <p:cNvSpPr>
-            <a:spLocks noGrp="1"/>
-          </p:cNvSpPr>
-          <p:nvPr>
-            <p:ph type="title"/>
-          </p:nvPr>
-        </p:nvSpPr>
-        <p:spPr/>
-        <p:txBody>
-          <a:bodyPr>
-            <a:normAutofit/>
-          </a:bodyPr>
-          <a:lstStyle/>
-          <a:p>
-            <a:pPr marL="0" indent="0">
-              <a:buFont typeface="Arial" panose="020B0604020202020204" pitchFamily="34" charset="0"/>
-              <a:buNone/>
-            </a:pPr>
-            <a:r>
-              <a:rPr lang="en-US" altLang="ko-KR" b="1" dirty="0">
-                <a:latin typeface="+mj-ea"/>
-              </a:rPr>
-              <a:t>Weight normalization</a:t>
+              <a:t>Regularization</a:t>
             </a:r>
             <a:endParaRPr lang="ko-KR" altLang="en-US" b="1" dirty="0">
               <a:latin typeface="+mj-ea"/>
@@ -15488,73 +15611,49 @@
           </a:bodyPr>
           <a:lstStyle/>
           <a:p>
-            <a:pPr marL="0" indent="0">
+            <a:pPr>
               <a:lnSpc>
                 <a:spcPct val="150000"/>
               </a:lnSpc>
-              <a:buNone/>
             </a:pPr>
             <a:r>
+              <a:rPr lang="en-US" altLang="ko-KR" sz="2400" dirty="0"/>
+              <a:t>Cost function</a:t>
+            </a:r>
+            <a:r>
+              <a:rPr lang="ko-KR" altLang="en-US" sz="2400" dirty="0"/>
+              <a:t>에 가중치의 </a:t>
+            </a:r>
+            <a:r>
               <a:rPr lang="ko-KR" altLang="en-US" sz="2400" dirty="0">
-                <a:latin typeface="+mn-ea"/>
-              </a:rPr>
-              <a:t>✅ </a:t>
-            </a:r>
-            <a:r>
-              <a:rPr lang="en-US" altLang="ko-KR" sz="2400" dirty="0">
-                <a:latin typeface="+mn-ea"/>
-              </a:rPr>
-              <a:t>L1 Regularization</a:t>
-            </a:r>
-          </a:p>
-          <a:p>
-            <a:pPr lvl="1">
-              <a:lnSpc>
-                <a:spcPct val="150000"/>
-              </a:lnSpc>
-              <a:buFont typeface="Wingdings" panose="05000000000000000000" pitchFamily="2" charset="2"/>
-              <a:buChar char="§"/>
-            </a:pPr>
-            <a:r>
-              <a:rPr lang="en-US" altLang="ko-KR" sz="2000" dirty="0"/>
-              <a:t>Cost function</a:t>
-            </a:r>
-            <a:r>
-              <a:rPr lang="ko-KR" altLang="en-US" sz="2000" dirty="0"/>
-              <a:t>에 가중치의 </a:t>
-            </a:r>
-            <a:r>
-              <a:rPr lang="ko-KR" altLang="en-US" sz="2000" dirty="0">
                 <a:solidFill>
                   <a:srgbClr val="FF0000"/>
                 </a:solidFill>
               </a:rPr>
-              <a:t>절대값</a:t>
-            </a:r>
-            <a:r>
-              <a:rPr lang="ko-KR" altLang="en-US" sz="2000" dirty="0"/>
+              <a:t>절댓값</a:t>
+            </a:r>
+            <a:r>
+              <a:rPr lang="ko-KR" altLang="en-US" sz="2400" dirty="0"/>
               <a:t>을 더해줌</a:t>
             </a:r>
-            <a:endParaRPr lang="en-US" altLang="ko-KR" sz="2000" dirty="0"/>
-          </a:p>
-          <a:p>
-            <a:pPr lvl="1">
+            <a:endParaRPr lang="en-US" altLang="ko-KR" sz="2400" dirty="0"/>
+          </a:p>
+          <a:p>
+            <a:pPr>
               <a:lnSpc>
                 <a:spcPct val="150000"/>
               </a:lnSpc>
-              <a:buFont typeface="Wingdings" panose="05000000000000000000" pitchFamily="2" charset="2"/>
-              <a:buChar char="§"/>
             </a:pPr>
             <a:r>
-              <a:rPr lang="en-US" altLang="ko-KR" sz="2000" dirty="0"/>
+              <a:rPr lang="en-US" altLang="ko-KR" sz="2400" dirty="0"/>
               <a:t>L1 </a:t>
             </a:r>
             <a:r>
-              <a:rPr lang="ko-KR" altLang="en-US" sz="2000" dirty="0"/>
+              <a:rPr lang="ko-KR" altLang="en-US" sz="2400" dirty="0"/>
               <a:t>정규화를 사용하는 모델을 </a:t>
             </a:r>
             <a:r>
-              <a:rPr lang="en-US" altLang="ko-KR" sz="2000" dirty="0">
+              <a:rPr lang="en-US" altLang="ko-KR" sz="2400" dirty="0">
                 <a:solidFill>
                   <a:srgbClr val="FF0000"/>
                 </a:solidFill>
@@ -15562,25 +15661,23 @@
               <a:t>Lasso</a:t>
             </a:r>
             <a:r>
-              <a:rPr lang="en-US" altLang="ko-KR" sz="2000" dirty="0"/>
+              <a:rPr lang="en-US" altLang="ko-KR" sz="2400" dirty="0"/>
               <a:t> </a:t>
             </a:r>
             <a:r>
-              <a:rPr lang="ko-KR" altLang="en-US" sz="2000" dirty="0"/>
+              <a:rPr lang="ko-KR" altLang="en-US" sz="2400" dirty="0"/>
               <a:t>모델이라고 함</a:t>
             </a:r>
-            <a:endParaRPr lang="en-US" altLang="ko-KR" sz="2000" dirty="0"/>
-          </a:p>
-          <a:p>
-            <a:pPr lvl="1">
+            <a:endParaRPr lang="en-US" altLang="ko-KR" sz="2400" dirty="0"/>
+          </a:p>
+          <a:p>
+            <a:pPr>
               <a:lnSpc>
                 <a:spcPct val="150000"/>
               </a:lnSpc>
-              <a:buFont typeface="Wingdings" panose="05000000000000000000" pitchFamily="2" charset="2"/>
-              <a:buChar char="§"/>
             </a:pPr>
             <a:r>
-              <a:rPr lang="ko-KR" altLang="en-US" sz="2000" dirty="0">
+              <a:rPr lang="ko-KR" altLang="en-US" sz="2400" dirty="0">
                 <a:solidFill>
                   <a:srgbClr val="FF0000"/>
                 </a:solidFill>
@@ -15588,7 +15685,7 @@
               <a:t>불필요한 </a:t>
             </a:r>
             <a:r>
-              <a:rPr lang="en-US" altLang="ko-KR" sz="2000" dirty="0">
+              <a:rPr lang="en-US" altLang="ko-KR" sz="2400" dirty="0">
                 <a:solidFill>
                   <a:srgbClr val="FF0000"/>
                 </a:solidFill>
@@ -15596,7 +15693,7 @@
               <a:t>Weight</a:t>
             </a:r>
             <a:r>
-              <a:rPr lang="ko-KR" altLang="en-US" sz="2000" dirty="0">
+              <a:rPr lang="ko-KR" altLang="en-US" sz="2400" dirty="0">
                 <a:solidFill>
                   <a:srgbClr val="FF0000"/>
                 </a:solidFill>
@@ -15604,7 +15701,7 @@
               <a:t>를 </a:t>
             </a:r>
             <a:r>
-              <a:rPr lang="en-US" altLang="ko-KR" sz="2000" dirty="0">
+              <a:rPr lang="en-US" altLang="ko-KR" sz="2400" dirty="0">
                 <a:solidFill>
                   <a:srgbClr val="FF0000"/>
                 </a:solidFill>
@@ -15612,7 +15709,7 @@
               <a:t>0</a:t>
             </a:r>
             <a:r>
-              <a:rPr lang="ko-KR" altLang="en-US" sz="2000" dirty="0">
+              <a:rPr lang="ko-KR" altLang="en-US" sz="2400" dirty="0">
                 <a:solidFill>
                   <a:srgbClr val="FF0000"/>
                 </a:solidFill>
@@ -15620,7 +15717,7 @@
               <a:t>으로</a:t>
             </a:r>
             <a:r>
-              <a:rPr lang="en-US" altLang="ko-KR" sz="2000" dirty="0">
+              <a:rPr lang="en-US" altLang="ko-KR" sz="2400" dirty="0">
                 <a:solidFill>
                   <a:srgbClr val="FF0000"/>
                 </a:solidFill>
@@ -15628,7 +15725,7 @@
               <a:t> </a:t>
             </a:r>
             <a:r>
-              <a:rPr lang="ko-KR" altLang="en-US" sz="2000" dirty="0">
+              <a:rPr lang="ko-KR" altLang="en-US" sz="2400" dirty="0">
                 <a:solidFill>
                   <a:srgbClr val="FF0000"/>
                 </a:solidFill>
@@ -15636,7 +15733,7 @@
               <a:t>만들어버려서 </a:t>
             </a:r>
             <a:r>
-              <a:rPr lang="en-US" altLang="ko-KR" sz="2000" dirty="0">
+              <a:rPr lang="en-US" altLang="ko-KR" sz="2400" dirty="0">
                 <a:solidFill>
                   <a:srgbClr val="FF0000"/>
                 </a:solidFill>
@@ -15644,42 +15741,14 @@
               <a:t>Feature selection</a:t>
             </a:r>
             <a:r>
-              <a:rPr lang="ko-KR" altLang="en-US" sz="2000" dirty="0">
+              <a:rPr lang="ko-KR" altLang="en-US" sz="2400" dirty="0">
                 <a:solidFill>
                   <a:srgbClr val="FF0000"/>
                 </a:solidFill>
               </a:rPr>
               <a:t>의 효과</a:t>
             </a:r>
-            <a:endParaRPr lang="en-US" altLang="ko-KR" sz="2000" dirty="0"/>
-          </a:p>
-          <a:p>
-            <a:pPr lvl="2">
-              <a:lnSpc>
-                <a:spcPct val="150000"/>
-              </a:lnSpc>
-            </a:pPr>
-            <a:r>
-              <a:rPr lang="en-US" altLang="ko-KR" sz="1800" dirty="0"/>
-              <a:t>weight </a:t>
-            </a:r>
-            <a:r>
-              <a:rPr lang="ko-KR" altLang="en-US" sz="1800" dirty="0"/>
-              <a:t>의 크기에 상관없이 부호에 따라 일정한 </a:t>
-            </a:r>
-            <a:r>
-              <a:rPr lang="ko-KR" altLang="en-US" sz="1800" dirty="0" err="1"/>
-              <a:t>상수값을</a:t>
-            </a:r>
-            <a:r>
-              <a:rPr lang="ko-KR" altLang="en-US" sz="1800" dirty="0"/>
-              <a:t> 빼거나 </a:t>
-            </a:r>
-            <a:r>
-              <a:rPr lang="ko-KR" altLang="en-US" sz="1800" dirty="0" err="1"/>
-              <a:t>더해줌</a:t>
-            </a:r>
-            <a:endParaRPr lang="en-US" altLang="ko-KR" sz="1800" dirty="0"/>
+            <a:endParaRPr lang="en-US" altLang="ko-KR" sz="2400" dirty="0"/>
           </a:p>
           <a:p>
             <a:pPr lvl="1">
@@ -15688,64 +15757,90 @@
               </a:lnSpc>
             </a:pPr>
             <a:r>
-              <a:rPr lang="ko-KR" altLang="en-US" sz="2000" dirty="0"/>
-              <a:t>모델은 </a:t>
-            </a:r>
-            <a:r>
-              <a:rPr lang="en-US" altLang="ko-KR" sz="2000" dirty="0"/>
-              <a:t>cost</a:t>
-            </a:r>
-            <a:r>
-              <a:rPr lang="ko-KR" altLang="en-US" sz="2000" dirty="0"/>
-              <a:t>를 줄이는 방향으로 학습하기 때문에 가중치들이 작아지고 일부는 </a:t>
-            </a:r>
-            <a:r>
-              <a:rPr lang="en-US" altLang="ko-KR" sz="2000" dirty="0"/>
-              <a:t>0</a:t>
-            </a:r>
-            <a:r>
-              <a:rPr lang="ko-KR" altLang="en-US" sz="2000" dirty="0"/>
-              <a:t>으로 수렴</a:t>
-            </a:r>
-            <a:endParaRPr lang="en-US" altLang="ko-KR" sz="2000" dirty="0"/>
-          </a:p>
-          <a:p>
-            <a:pPr lvl="1">
+              <a:rPr lang="en-US" altLang="ko-KR" sz="2200" dirty="0"/>
+              <a:t>weight </a:t>
+            </a:r>
+            <a:r>
+              <a:rPr lang="ko-KR" altLang="en-US" sz="2200" dirty="0"/>
+              <a:t>의 크기에 상관없이 부호에 따라 일정한 </a:t>
+            </a:r>
+            <a:r>
+              <a:rPr lang="ko-KR" altLang="en-US" sz="2200" dirty="0" err="1"/>
+              <a:t>상수값을</a:t>
+            </a:r>
+            <a:r>
+              <a:rPr lang="ko-KR" altLang="en-US" sz="2200" dirty="0"/>
+              <a:t> 빼거나 </a:t>
+            </a:r>
+            <a:r>
+              <a:rPr lang="ko-KR" altLang="en-US" sz="2200" dirty="0" err="1"/>
+              <a:t>더해줌</a:t>
+            </a:r>
+            <a:endParaRPr lang="en-US" altLang="ko-KR" sz="2200" dirty="0"/>
+          </a:p>
+          <a:p>
+            <a:pPr>
               <a:lnSpc>
                 <a:spcPct val="150000"/>
               </a:lnSpc>
-              <a:buFont typeface="Wingdings" panose="05000000000000000000" pitchFamily="2" charset="2"/>
-              <a:buChar char="§"/>
             </a:pPr>
             <a:r>
-              <a:rPr lang="ko-KR" altLang="en-US" sz="2000" dirty="0"/>
+              <a:rPr lang="ko-KR" altLang="en-US" sz="2400" dirty="0"/>
+              <a:t>모델은 </a:t>
+            </a:r>
+            <a:r>
+              <a:rPr lang="en-US" altLang="ko-KR" sz="2400" dirty="0"/>
+              <a:t>cost</a:t>
+            </a:r>
+            <a:r>
+              <a:rPr lang="ko-KR" altLang="en-US" sz="2400" dirty="0"/>
+              <a:t>를 줄이는 방향으로 학습하기 때문에 가중치들이 작아지고 일부는 </a:t>
+            </a:r>
+            <a:r>
+              <a:rPr lang="en-US" altLang="ko-KR" sz="2400" dirty="0"/>
+              <a:t>0</a:t>
+            </a:r>
+            <a:r>
+              <a:rPr lang="ko-KR" altLang="en-US" sz="2400" dirty="0"/>
+              <a:t>으로 수렴</a:t>
+            </a:r>
+            <a:endParaRPr lang="en-US" altLang="ko-KR" sz="2400" dirty="0"/>
+          </a:p>
+          <a:p>
+            <a:pPr>
+              <a:lnSpc>
+                <a:spcPct val="150000"/>
+              </a:lnSpc>
+            </a:pPr>
+            <a:r>
+              <a:rPr lang="ko-KR" altLang="en-US" sz="2400" dirty="0"/>
               <a:t>람다 </a:t>
             </a:r>
             <a:r>
-              <a:rPr lang="en-US" altLang="ko-KR" sz="2000" dirty="0"/>
+              <a:rPr lang="en-US" altLang="ko-KR" sz="2400" dirty="0"/>
               <a:t>: </a:t>
             </a:r>
             <a:r>
-              <a:rPr lang="ko-KR" altLang="en-US" sz="2000" dirty="0"/>
+              <a:rPr lang="ko-KR" altLang="en-US" sz="2400" dirty="0"/>
               <a:t>정규화 항의 가중치</a:t>
             </a:r>
             <a:r>
-              <a:rPr lang="en-US" altLang="ko-KR" sz="2000" dirty="0"/>
+              <a:rPr lang="en-US" altLang="ko-KR" sz="2400" dirty="0"/>
               <a:t>, </a:t>
             </a:r>
             <a:r>
-              <a:rPr lang="ko-KR" altLang="en-US" sz="2000" dirty="0"/>
+              <a:rPr lang="ko-KR" altLang="en-US" sz="2400" dirty="0"/>
               <a:t>해당 값이 높을수록 가중치가 </a:t>
             </a:r>
             <a:r>
-              <a:rPr lang="en-US" altLang="ko-KR" sz="2000" dirty="0"/>
+              <a:rPr lang="en-US" altLang="ko-KR" sz="2400" dirty="0"/>
               <a:t>0</a:t>
             </a:r>
             <a:r>
-              <a:rPr lang="ko-KR" altLang="en-US" sz="2000" dirty="0"/>
+              <a:rPr lang="ko-KR" altLang="en-US" sz="2400" dirty="0"/>
               <a:t>으로 수렴</a:t>
             </a:r>
-            <a:endParaRPr lang="en-US" altLang="ko-KR" sz="2000" dirty="0"/>
+            <a:endParaRPr lang="en-US" altLang="ko-KR" sz="2400" dirty="0"/>
           </a:p>
         </p:txBody>
       </p:sp>
@@ -15801,7 +15896,7 @@
           <a:p>
             <a:fld id="{083A2CE0-18CD-4102-B738-4ACFF9E68BA4}" type="slidenum">
               <a:rPr lang="ko-KR" altLang="en-US" smtClean="0"/>
-              <a:t>33</a:t>
+              <a:t>30</a:t>
             </a:fld>
             <a:endParaRPr lang="ko-KR" altLang="en-US"/>
           </a:p>
@@ -15822,7 +15917,7 @@
           <p:nvPr/>
         </p:nvPicPr>
         <p:blipFill>
-          <a:blip r:embed="rId2">
+          <a:blip r:embed="rId3">
             <a:extLst>
               <a:ext uri="{28A0092B-C50C-407E-A947-70E740481C1C}">
                 <a14:useLocalDpi xmlns:a14="http://schemas.microsoft.com/office/drawing/2010/main" val="0"/>
@@ -15867,7 +15962,7 @@
 </p:sld>
 </file>
 
-<file path=ppt/slides/slide34.xml><?xml version="1.0" encoding="utf-8"?>
+<file path=ppt/slides/slide31.xml><?xml version="1.0" encoding="utf-8"?>
 <p:sld xmlns:a="http://schemas.openxmlformats.org/drawingml/2006/main" xmlns:r="http://schemas.openxmlformats.org/officeDocument/2006/relationships" xmlns:p="http://schemas.openxmlformats.org/presentationml/2006/main">
   <p:cSld>
     <p:spTree>
@@ -15907,15 +16002,17 @@
           </a:bodyPr>
           <a:lstStyle/>
           <a:p>
-            <a:pPr marL="0" indent="0">
-              <a:buFont typeface="Arial" panose="020B0604020202020204" pitchFamily="34" charset="0"/>
-              <a:buNone/>
-            </a:pPr>
-            <a:r>
-              <a:rPr lang="en-US" altLang="ko-KR" b="1" dirty="0">
-                <a:latin typeface="+mj-ea"/>
-              </a:rPr>
-              <a:t>Weight normalization</a:t>
+            <a:r>
+              <a:rPr lang="en-US" altLang="ko-KR" dirty="0"/>
+              <a:t>L2</a:t>
+            </a:r>
+            <a:r>
+              <a:rPr lang="ko-KR" altLang="en-US" dirty="0"/>
+              <a:t> </a:t>
+            </a:r>
+            <a:r>
+              <a:rPr lang="en-US" altLang="ko-KR" dirty="0"/>
+              <a:t>Regularization</a:t>
             </a:r>
             <a:endParaRPr lang="ko-KR" altLang="en-US" b="1" dirty="0">
               <a:latin typeface="+mj-ea"/>
@@ -15951,61 +16048,37 @@
           </a:bodyPr>
           <a:lstStyle/>
           <a:p>
-            <a:pPr marL="0" indent="0">
+            <a:pPr>
               <a:lnSpc>
                 <a:spcPct val="150000"/>
               </a:lnSpc>
-              <a:buNone/>
             </a:pPr>
             <a:r>
-              <a:rPr lang="ko-KR" altLang="en-US" sz="2400" b="1" dirty="0">
-                <a:latin typeface="+mn-ea"/>
-              </a:rPr>
-              <a:t>✅ </a:t>
-            </a:r>
-            <a:r>
-              <a:rPr lang="en-US" altLang="ko-KR" sz="2400" b="1" dirty="0">
-                <a:latin typeface="+mn-ea"/>
-              </a:rPr>
-              <a:t>L2 Regularization</a:t>
-            </a:r>
-          </a:p>
-          <a:p>
-            <a:pPr lvl="1">
+              <a:rPr lang="en-US" altLang="ko-KR" sz="2400" dirty="0"/>
+              <a:t>Cost function</a:t>
+            </a:r>
+            <a:r>
+              <a:rPr lang="ko-KR" altLang="en-US" sz="2400" dirty="0"/>
+              <a:t> 에 가중치의 제곱을 포함하여 더함</a:t>
+            </a:r>
+            <a:endParaRPr lang="en-US" altLang="ko-KR" sz="2400" dirty="0"/>
+          </a:p>
+          <a:p>
+            <a:pPr>
               <a:lnSpc>
                 <a:spcPct val="150000"/>
               </a:lnSpc>
-              <a:buFont typeface="Wingdings" panose="05000000000000000000" pitchFamily="2" charset="2"/>
-              <a:buChar char="§"/>
             </a:pPr>
             <a:r>
-              <a:rPr lang="en-US" altLang="ko-KR" sz="2000" dirty="0"/>
-              <a:t>Cost function</a:t>
-            </a:r>
-            <a:r>
-              <a:rPr lang="ko-KR" altLang="en-US" sz="2000" dirty="0"/>
-              <a:t> 에 가중치의 제곱을 포함하여 더함</a:t>
-            </a:r>
-            <a:endParaRPr lang="en-US" altLang="ko-KR" sz="2000" dirty="0"/>
-          </a:p>
-          <a:p>
-            <a:pPr lvl="1">
-              <a:lnSpc>
-                <a:spcPct val="150000"/>
-              </a:lnSpc>
-              <a:buFont typeface="Wingdings" panose="05000000000000000000" pitchFamily="2" charset="2"/>
-              <a:buChar char="§"/>
-            </a:pPr>
-            <a:r>
-              <a:rPr lang="ko-KR" altLang="en-US" sz="2000" dirty="0"/>
+              <a:rPr lang="ko-KR" altLang="en-US" sz="2400" dirty="0"/>
               <a:t>가중치가 너무 크지 않은 방향으로 학습되게 함</a:t>
             </a:r>
             <a:r>
-              <a:rPr lang="en-US" altLang="ko-KR" sz="2000" dirty="0"/>
+              <a:rPr lang="en-US" altLang="ko-KR" sz="2400" dirty="0"/>
               <a:t>. (</a:t>
             </a:r>
             <a:r>
-              <a:rPr lang="en-US" altLang="ko-KR" sz="2000" dirty="0">
+              <a:rPr lang="en-US" altLang="ko-KR" sz="2400" dirty="0">
                 <a:solidFill>
                   <a:srgbClr val="FF0000"/>
                 </a:solidFill>
@@ -16013,60 +16086,70 @@
               <a:t>Weight decay</a:t>
             </a:r>
             <a:r>
-              <a:rPr lang="en-US" altLang="ko-KR" sz="2000" dirty="0"/>
+              <a:rPr lang="en-US" altLang="ko-KR" sz="2400" dirty="0"/>
               <a:t>)</a:t>
             </a:r>
           </a:p>
           <a:p>
-            <a:pPr lvl="2">
+            <a:pPr lvl="1">
               <a:lnSpc>
                 <a:spcPct val="150000"/>
               </a:lnSpc>
             </a:pPr>
             <a:r>
-              <a:rPr lang="en-US" altLang="ko-KR" sz="1800" dirty="0"/>
-              <a:t>cost </a:t>
-            </a:r>
-            <a:r>
-              <a:rPr lang="ko-KR" altLang="en-US" sz="1800" dirty="0"/>
-              <a:t>뿐만 아니라 가중치 또한 줄어드는 방향으로 학습</a:t>
-            </a:r>
-            <a:endParaRPr lang="en-US" altLang="ko-KR" sz="1800" dirty="0"/>
-          </a:p>
-          <a:p>
-            <a:pPr lvl="2">
+              <a:rPr lang="ko-KR" altLang="en-US" sz="2000" dirty="0"/>
+              <a:t>손실 함수에 제곱 </a:t>
+            </a:r>
+            <a:r>
+              <a:rPr lang="ko-KR" altLang="en-US" sz="2000" dirty="0" err="1"/>
+              <a:t>패널티가</a:t>
+            </a:r>
+            <a:r>
+              <a:rPr lang="ko-KR" altLang="en-US" sz="2000" dirty="0"/>
+              <a:t> 추가되어</a:t>
+            </a:r>
+            <a:r>
+              <a:rPr lang="en-US" altLang="ko-KR" sz="2000" dirty="0"/>
+              <a:t>, </a:t>
+            </a:r>
+            <a:r>
+              <a:rPr lang="ko-KR" altLang="en-US" sz="2000" dirty="0"/>
+              <a:t>업데이트 시 가중치가 감소하는 방향으로 작용</a:t>
+            </a:r>
+            <a:endParaRPr lang="en-US" altLang="ko-KR" sz="2000" dirty="0"/>
+          </a:p>
+          <a:p>
+            <a:pPr lvl="1">
               <a:lnSpc>
                 <a:spcPct val="150000"/>
               </a:lnSpc>
             </a:pPr>
             <a:r>
-              <a:rPr lang="en-US" altLang="ko-KR" sz="1800" dirty="0"/>
-              <a:t>Weight</a:t>
-            </a:r>
-            <a:r>
-              <a:rPr lang="ko-KR" altLang="en-US" sz="1800" dirty="0"/>
+              <a:rPr lang="en-US" altLang="ko-KR" sz="2200" dirty="0"/>
+              <a:t>weight</a:t>
+            </a:r>
+            <a:r>
+              <a:rPr lang="ko-KR" altLang="en-US" sz="2200" dirty="0"/>
               <a:t> 가 클수록 더 빠르게 감소</a:t>
             </a:r>
-            <a:endParaRPr lang="en-US" altLang="ko-KR" sz="1800" dirty="0"/>
-          </a:p>
-          <a:p>
-            <a:pPr lvl="1">
+            <a:endParaRPr lang="en-US" altLang="ko-KR" sz="2200" dirty="0"/>
+          </a:p>
+          <a:p>
+            <a:pPr>
               <a:lnSpc>
                 <a:spcPct val="150000"/>
               </a:lnSpc>
-              <a:buFont typeface="Wingdings" panose="05000000000000000000" pitchFamily="2" charset="2"/>
-              <a:buChar char="§"/>
             </a:pPr>
             <a:r>
-              <a:rPr lang="en-US" altLang="ko-KR" sz="2000" dirty="0"/>
+              <a:rPr lang="en-US" altLang="ko-KR" sz="2400" dirty="0"/>
               <a:t>L2 </a:t>
             </a:r>
             <a:r>
-              <a:rPr lang="ko-KR" altLang="en-US" sz="2000" dirty="0"/>
+              <a:rPr lang="ko-KR" altLang="en-US" sz="2400" dirty="0"/>
               <a:t>정규화를 사용하는 모델을 </a:t>
             </a:r>
             <a:r>
-              <a:rPr lang="en-US" altLang="ko-KR" sz="2000" dirty="0">
+              <a:rPr lang="en-US" altLang="ko-KR" sz="2400" dirty="0">
                 <a:solidFill>
                   <a:srgbClr val="FF0000"/>
                 </a:solidFill>
@@ -16074,25 +16157,23 @@
               <a:t>Ridge</a:t>
             </a:r>
             <a:r>
-              <a:rPr lang="en-US" altLang="ko-KR" sz="2000" dirty="0"/>
+              <a:rPr lang="en-US" altLang="ko-KR" sz="2400" dirty="0"/>
               <a:t> </a:t>
             </a:r>
             <a:r>
-              <a:rPr lang="ko-KR" altLang="en-US" sz="2000" dirty="0"/>
+              <a:rPr lang="ko-KR" altLang="en-US" sz="2400" dirty="0"/>
               <a:t>모델이라고 부름</a:t>
             </a:r>
-            <a:endParaRPr lang="en-US" altLang="ko-KR" sz="2000" dirty="0"/>
-          </a:p>
-          <a:p>
-            <a:pPr lvl="1">
+            <a:endParaRPr lang="en-US" altLang="ko-KR" sz="2400" dirty="0"/>
+          </a:p>
+          <a:p>
+            <a:pPr>
               <a:lnSpc>
                 <a:spcPct val="150000"/>
               </a:lnSpc>
-              <a:buFont typeface="Wingdings" panose="05000000000000000000" pitchFamily="2" charset="2"/>
-              <a:buChar char="§"/>
             </a:pPr>
             <a:r>
-              <a:rPr lang="ko-KR" altLang="en-US" sz="2000" dirty="0">
+              <a:rPr lang="ko-KR" altLang="en-US" sz="2400" dirty="0">
                 <a:solidFill>
                   <a:srgbClr val="FF0000"/>
                 </a:solidFill>
@@ -16100,7 +16181,7 @@
               <a:t>불필요한 </a:t>
             </a:r>
             <a:r>
-              <a:rPr lang="en-US" altLang="ko-KR" sz="2000" dirty="0">
+              <a:rPr lang="en-US" altLang="ko-KR" sz="2400" dirty="0">
                 <a:solidFill>
                   <a:srgbClr val="FF0000"/>
                 </a:solidFill>
@@ -16108,7 +16189,7 @@
               <a:t>Feature</a:t>
             </a:r>
             <a:r>
-              <a:rPr lang="ko-KR" altLang="en-US" sz="2000" dirty="0">
+              <a:rPr lang="ko-KR" altLang="en-US" sz="2400" dirty="0">
                 <a:solidFill>
                   <a:srgbClr val="FF0000"/>
                 </a:solidFill>
@@ -16116,7 +16197,7 @@
               <a:t>를 </a:t>
             </a:r>
             <a:r>
-              <a:rPr lang="en-US" altLang="ko-KR" sz="2000" dirty="0">
+              <a:rPr lang="en-US" altLang="ko-KR" sz="2400" dirty="0">
                 <a:solidFill>
                   <a:srgbClr val="FF0000"/>
                 </a:solidFill>
@@ -16124,14 +16205,14 @@
               <a:t>0</a:t>
             </a:r>
             <a:r>
-              <a:rPr lang="ko-KR" altLang="en-US" sz="2000" dirty="0">
+              <a:rPr lang="ko-KR" altLang="en-US" sz="2400" dirty="0">
                 <a:solidFill>
                   <a:srgbClr val="FF0000"/>
                 </a:solidFill>
               </a:rPr>
               <a:t>에 가깝게 만드는 특성</a:t>
             </a:r>
-            <a:endParaRPr lang="en-US" altLang="ko-KR" sz="2000" dirty="0">
+            <a:endParaRPr lang="en-US" altLang="ko-KR" sz="2400" dirty="0">
               <a:solidFill>
                 <a:srgbClr val="FF0000"/>
               </a:solidFill>
@@ -16272,7 +16353,7 @@
           <a:p>
             <a:fld id="{083A2CE0-18CD-4102-B738-4ACFF9E68BA4}" type="slidenum">
               <a:rPr lang="ko-KR" altLang="en-US" smtClean="0"/>
-              <a:t>34</a:t>
+              <a:t>31</a:t>
             </a:fld>
             <a:endParaRPr lang="ko-KR" altLang="en-US"/>
           </a:p>
@@ -16293,7 +16374,7 @@
           <p:nvPr/>
         </p:nvPicPr>
         <p:blipFill>
-          <a:blip r:embed="rId2">
+          <a:blip r:embed="rId3">
             <a:extLst>
               <a:ext uri="{28A0092B-C50C-407E-A947-70E740481C1C}">
                 <a14:useLocalDpi xmlns:a14="http://schemas.microsoft.com/office/drawing/2010/main" val="0"/>
@@ -16338,7 +16419,7 @@
 </p:sld>
 </file>
 
-<file path=ppt/slides/slide35.xml><?xml version="1.0" encoding="utf-8"?>
+<file path=ppt/slides/slide32.xml><?xml version="1.0" encoding="utf-8"?>
 <p:sld xmlns:a="http://schemas.openxmlformats.org/drawingml/2006/main" xmlns:r="http://schemas.openxmlformats.org/officeDocument/2006/relationships" xmlns:p="http://schemas.openxmlformats.org/presentationml/2006/main">
   <p:cSld>
     <p:spTree>
@@ -16386,7 +16467,7 @@
               <a:rPr lang="en-US" altLang="ko-KR" b="1" dirty="0">
                 <a:latin typeface="+mj-ea"/>
               </a:rPr>
-              <a:t>Weight normalization</a:t>
+              <a:t>Lasso , Ridge</a:t>
             </a:r>
             <a:endParaRPr lang="ko-KR" altLang="en-US" b="1" dirty="0">
               <a:latin typeface="+mj-ea"/>
@@ -16495,7 +16576,7 @@
           <a:p>
             <a:fld id="{083A2CE0-18CD-4102-B738-4ACFF9E68BA4}" type="slidenum">
               <a:rPr lang="ko-KR" altLang="en-US" smtClean="0"/>
-              <a:t>35</a:t>
+              <a:t>32</a:t>
             </a:fld>
             <a:endParaRPr lang="ko-KR" altLang="en-US"/>
           </a:p>
@@ -16690,324 +16771,7 @@
 </p:sld>
 </file>
 
-<file path=ppt/slides/slide36.xml><?xml version="1.0" encoding="utf-8"?>
-<p:sld xmlns:a="http://schemas.openxmlformats.org/drawingml/2006/main" xmlns:r="http://schemas.openxmlformats.org/officeDocument/2006/relationships" xmlns:p="http://schemas.openxmlformats.org/presentationml/2006/main">
-  <p:cSld>
-    <p:spTree>
-      <p:nvGrpSpPr>
-        <p:cNvPr id="1" name=""/>
-        <p:cNvGrpSpPr/>
-        <p:nvPr/>
-      </p:nvGrpSpPr>
-      <p:grpSpPr>
-        <a:xfrm>
-          <a:off x="0" y="0"/>
-          <a:ext cx="0" cy="0"/>
-          <a:chOff x="0" y="0"/>
-          <a:chExt cx="0" cy="0"/>
-        </a:xfrm>
-      </p:grpSpPr>
-      <p:pic>
-        <p:nvPicPr>
-          <p:cNvPr id="1026" name="Picture 2">
-            <a:extLst>
-              <a:ext uri="{FF2B5EF4-FFF2-40B4-BE49-F238E27FC236}">
-                <a16:creationId xmlns:a16="http://schemas.microsoft.com/office/drawing/2014/main" id="{A8B16A7E-4F0F-B977-CED0-C5D279183E31}"/>
-              </a:ext>
-            </a:extLst>
-          </p:cNvPr>
-          <p:cNvPicPr>
-            <a:picLocks noChangeAspect="1" noChangeArrowheads="1"/>
-          </p:cNvPicPr>
-          <p:nvPr/>
-        </p:nvPicPr>
-        <p:blipFill>
-          <a:blip r:embed="rId2">
-            <a:extLst>
-              <a:ext uri="{28A0092B-C50C-407E-A947-70E740481C1C}">
-                <a14:useLocalDpi xmlns:a14="http://schemas.microsoft.com/office/drawing/2010/main" val="0"/>
-              </a:ext>
-            </a:extLst>
-          </a:blip>
-          <a:srcRect/>
-          <a:stretch>
-            <a:fillRect/>
-          </a:stretch>
-        </p:blipFill>
-        <p:spPr bwMode="auto">
-          <a:xfrm>
-            <a:off x="6246476" y="2268269"/>
-            <a:ext cx="5926666" cy="2586743"/>
-          </a:xfrm>
-          <a:prstGeom prst="rect">
-            <a:avLst/>
-          </a:prstGeom>
-          <a:noFill/>
-          <a:extLst>
-            <a:ext uri="{909E8E84-426E-40DD-AFC4-6F175D3DCCD1}">
-              <a14:hiddenFill xmlns:a14="http://schemas.microsoft.com/office/drawing/2010/main">
-                <a:solidFill>
-                  <a:srgbClr val="FFFFFF"/>
-                </a:solidFill>
-              </a14:hiddenFill>
-            </a:ext>
-          </a:extLst>
-        </p:spPr>
-      </p:pic>
-      <p:sp>
-        <p:nvSpPr>
-          <p:cNvPr id="2" name="제목 1">
-            <a:extLst>
-              <a:ext uri="{FF2B5EF4-FFF2-40B4-BE49-F238E27FC236}">
-                <a16:creationId xmlns:a16="http://schemas.microsoft.com/office/drawing/2014/main" id="{A8D8F1F4-4871-4B45-B08E-F92ACDB80FE6}"/>
-              </a:ext>
-            </a:extLst>
-          </p:cNvPr>
-          <p:cNvSpPr>
-            <a:spLocks noGrp="1"/>
-          </p:cNvSpPr>
-          <p:nvPr>
-            <p:ph type="title"/>
-          </p:nvPr>
-        </p:nvSpPr>
-        <p:spPr/>
-        <p:txBody>
-          <a:bodyPr>
-            <a:normAutofit/>
-          </a:bodyPr>
-          <a:lstStyle/>
-          <a:p>
-            <a:pPr marL="0" indent="0">
-              <a:buFont typeface="Arial" panose="020B0604020202020204" pitchFamily="34" charset="0"/>
-              <a:buNone/>
-            </a:pPr>
-            <a:r>
-              <a:rPr lang="en-US" altLang="ko-KR" b="1" dirty="0">
-                <a:latin typeface="+mj-ea"/>
-              </a:rPr>
-              <a:t>Weight normalization</a:t>
-            </a:r>
-            <a:endParaRPr lang="ko-KR" altLang="en-US" b="1" dirty="0">
-              <a:latin typeface="+mj-ea"/>
-            </a:endParaRPr>
-          </a:p>
-        </p:txBody>
-      </p:sp>
-      <p:sp>
-        <p:nvSpPr>
-          <p:cNvPr id="3" name="내용 개체 틀 2">
-            <a:extLst>
-              <a:ext uri="{FF2B5EF4-FFF2-40B4-BE49-F238E27FC236}">
-                <a16:creationId xmlns:a16="http://schemas.microsoft.com/office/drawing/2014/main" id="{E5DD7768-068E-EF1B-AB88-25A168CC736C}"/>
-              </a:ext>
-            </a:extLst>
-          </p:cNvPr>
-          <p:cNvSpPr>
-            <a:spLocks noGrp="1"/>
-          </p:cNvSpPr>
-          <p:nvPr>
-            <p:ph idx="1"/>
-          </p:nvPr>
-        </p:nvSpPr>
-        <p:spPr>
-          <a:xfrm>
-            <a:off x="251788" y="1382078"/>
-            <a:ext cx="6055441" cy="4444678"/>
-          </a:xfrm>
-        </p:spPr>
-        <p:txBody>
-          <a:bodyPr>
-            <a:noAutofit/>
-          </a:bodyPr>
-          <a:lstStyle/>
-          <a:p>
-            <a:pPr marL="0" indent="0">
-              <a:lnSpc>
-                <a:spcPct val="150000"/>
-              </a:lnSpc>
-              <a:buNone/>
-            </a:pPr>
-            <a:r>
-              <a:rPr lang="ko-KR" altLang="en-US" sz="2400" b="1" dirty="0"/>
-              <a:t>✅ 복잡한 모델로 </a:t>
-            </a:r>
-            <a:r>
-              <a:rPr lang="en-US" altLang="ko-KR" sz="2400" b="1" dirty="0" err="1"/>
-              <a:t>Overfitting</a:t>
-            </a:r>
-            <a:r>
-              <a:rPr lang="ko-KR" altLang="en-US" sz="2400" b="1" dirty="0"/>
-              <a:t>을 일으키기보다</a:t>
-            </a:r>
-            <a:r>
-              <a:rPr lang="en-US" altLang="ko-KR" sz="2400" dirty="0"/>
-              <a:t>:</a:t>
-            </a:r>
-          </a:p>
-          <a:p>
-            <a:pPr lvl="1">
-              <a:lnSpc>
-                <a:spcPct val="150000"/>
-              </a:lnSpc>
-            </a:pPr>
-            <a:r>
-              <a:rPr lang="ko-KR" altLang="en-US" sz="2000" dirty="0"/>
-              <a:t>약간의 정확도를 포기하고</a:t>
-            </a:r>
-            <a:r>
-              <a:rPr lang="en-US" altLang="ko-KR" sz="2000" dirty="0"/>
-              <a:t>, </a:t>
-            </a:r>
-            <a:r>
-              <a:rPr lang="ko-KR" altLang="en-US" sz="2000" dirty="0"/>
-              <a:t>모델을 단순하게 만들어 새로운 데이터에서도 잘 작동하게 함</a:t>
-            </a:r>
-            <a:endParaRPr lang="en-US" altLang="ko-KR" sz="2000" dirty="0"/>
-          </a:p>
-          <a:p>
-            <a:pPr marL="0" indent="0">
-              <a:lnSpc>
-                <a:spcPct val="150000"/>
-              </a:lnSpc>
-              <a:buNone/>
-            </a:pPr>
-            <a:r>
-              <a:rPr lang="ko-KR" altLang="en-US" sz="2400" b="1" dirty="0"/>
-              <a:t>✅ 규제를 통해 모델이 갈 수 있는 범위를 제한</a:t>
-            </a:r>
-            <a:r>
-              <a:rPr lang="en-US" altLang="ko-KR" sz="2400" dirty="0"/>
-              <a:t>:</a:t>
-            </a:r>
-          </a:p>
-          <a:p>
-            <a:pPr lvl="1">
-              <a:lnSpc>
-                <a:spcPct val="150000"/>
-              </a:lnSpc>
-            </a:pPr>
-            <a:r>
-              <a:rPr lang="ko-KR" altLang="en-US" sz="2000" dirty="0"/>
-              <a:t>제한된 범위 안에서 가장 좋은 위치</a:t>
-            </a:r>
-            <a:r>
-              <a:rPr lang="en-US" altLang="ko-KR" sz="2000" dirty="0"/>
-              <a:t>(Loss </a:t>
-            </a:r>
-            <a:r>
-              <a:rPr lang="ko-KR" altLang="en-US" sz="2000" dirty="0"/>
-              <a:t>최소화</a:t>
-            </a:r>
-            <a:r>
-              <a:rPr lang="en-US" altLang="ko-KR" sz="2000" dirty="0"/>
-              <a:t>)</a:t>
-            </a:r>
-            <a:r>
-              <a:rPr lang="ko-KR" altLang="en-US" sz="2000" dirty="0"/>
-              <a:t>를 찾음</a:t>
-            </a:r>
-            <a:r>
-              <a:rPr lang="en-US" altLang="ko-KR" sz="2000" dirty="0"/>
-              <a:t>.</a:t>
-            </a:r>
-          </a:p>
-          <a:p>
-            <a:pPr lvl="1">
-              <a:lnSpc>
-                <a:spcPct val="150000"/>
-              </a:lnSpc>
-            </a:pPr>
-            <a:r>
-              <a:rPr lang="ko-KR" altLang="en-US" sz="2000" dirty="0"/>
-              <a:t>이 위치는 이론적으로 가장 좋은 점</a:t>
-            </a:r>
-            <a:r>
-              <a:rPr lang="en-US" altLang="ko-KR" sz="2000" dirty="0"/>
-              <a:t>(Global Optimum)</a:t>
-            </a:r>
-            <a:r>
-              <a:rPr lang="ko-KR" altLang="en-US" sz="2000" dirty="0"/>
-              <a:t>에 최대한 가깝게 설정됨</a:t>
-            </a:r>
-            <a:r>
-              <a:rPr lang="en-US" altLang="ko-KR" sz="2000" dirty="0"/>
-              <a:t>.</a:t>
-            </a:r>
-          </a:p>
-        </p:txBody>
-      </p:sp>
-      <p:sp>
-        <p:nvSpPr>
-          <p:cNvPr id="4" name="날짜 개체 틀 3">
-            <a:extLst>
-              <a:ext uri="{FF2B5EF4-FFF2-40B4-BE49-F238E27FC236}">
-                <a16:creationId xmlns:a16="http://schemas.microsoft.com/office/drawing/2014/main" id="{590F8720-7C11-4CC8-8215-3F57F085A24B}"/>
-              </a:ext>
-            </a:extLst>
-          </p:cNvPr>
-          <p:cNvSpPr>
-            <a:spLocks noGrp="1"/>
-          </p:cNvSpPr>
-          <p:nvPr>
-            <p:ph type="dt" sz="half" idx="10"/>
-          </p:nvPr>
-        </p:nvSpPr>
-        <p:spPr/>
-        <p:txBody>
-          <a:bodyPr/>
-          <a:lstStyle/>
-          <a:p>
-            <a:fld id="{0F78D9C4-20C1-4B15-A116-16DC77AD9A1E}" type="datetime1">
-              <a:rPr lang="ko-KR" altLang="en-US" smtClean="0"/>
-              <a:t>2026-02-19</a:t>
-            </a:fld>
-            <a:endParaRPr lang="ko-KR" altLang="en-US"/>
-          </a:p>
-        </p:txBody>
-      </p:sp>
-      <p:sp>
-        <p:nvSpPr>
-          <p:cNvPr id="5" name="슬라이드 번호 개체 틀 4">
-            <a:extLst>
-              <a:ext uri="{FF2B5EF4-FFF2-40B4-BE49-F238E27FC236}">
-                <a16:creationId xmlns:a16="http://schemas.microsoft.com/office/drawing/2014/main" id="{E86D5960-457B-4CA2-B0B3-F7F0DADA85D8}"/>
-              </a:ext>
-            </a:extLst>
-          </p:cNvPr>
-          <p:cNvSpPr>
-            <a:spLocks noGrp="1"/>
-          </p:cNvSpPr>
-          <p:nvPr>
-            <p:ph type="sldNum" sz="quarter" idx="12"/>
-          </p:nvPr>
-        </p:nvSpPr>
-        <p:spPr/>
-        <p:txBody>
-          <a:bodyPr/>
-          <a:lstStyle/>
-          <a:p>
-            <a:fld id="{083A2CE0-18CD-4102-B738-4ACFF9E68BA4}" type="slidenum">
-              <a:rPr lang="ko-KR" altLang="en-US" smtClean="0"/>
-              <a:t>36</a:t>
-            </a:fld>
-            <a:endParaRPr lang="ko-KR" altLang="en-US"/>
-          </a:p>
-        </p:txBody>
-      </p:sp>
-    </p:spTree>
-    <p:extLst>
-      <p:ext uri="{BB962C8B-B14F-4D97-AF65-F5344CB8AC3E}">
-        <p14:creationId xmlns:p14="http://schemas.microsoft.com/office/powerpoint/2010/main" val="2274777549"/>
-      </p:ext>
-    </p:extLst>
-  </p:cSld>
-  <p:clrMapOvr>
-    <a:masterClrMapping/>
-  </p:clrMapOvr>
-</p:sld>
-</file>
-
-<file path=ppt/slides/slide37.xml><?xml version="1.0" encoding="utf-8"?>
+<file path=ppt/slides/slide33.xml><?xml version="1.0" encoding="utf-8"?>
 <p:sld xmlns:a="http://schemas.openxmlformats.org/drawingml/2006/main" xmlns:r="http://schemas.openxmlformats.org/officeDocument/2006/relationships" xmlns:p="http://schemas.openxmlformats.org/presentationml/2006/main">
   <p:cSld>
     <p:spTree>
@@ -17564,15 +17328,7 @@
             </a:r>
             <a:r>
               <a:rPr lang="en-US" altLang="ko-KR" sz="2400" dirty="0"/>
-              <a:t>(</a:t>
-            </a:r>
-            <a:r>
-              <a:rPr lang="en-US" altLang="ko-KR" sz="2400" dirty="0" err="1"/>
-              <a:t>Gradinet</a:t>
-            </a:r>
-            <a:r>
-              <a:rPr lang="en-US" altLang="ko-KR" sz="2400" dirty="0"/>
-              <a:t>)</a:t>
+              <a:t>(Gradient)</a:t>
             </a:r>
             <a:r>
               <a:rPr lang="ko-KR" altLang="en-US" sz="2400" dirty="0"/>
@@ -18453,16 +18209,10 @@
               <a:buNone/>
             </a:pPr>
             <a:r>
-              <a:rPr lang="en-US" altLang="ko-KR" b="1" dirty="0" err="1">
-                <a:latin typeface="+mj-ea"/>
-              </a:rPr>
-              <a:t>Leakly</a:t>
-            </a:r>
-            <a:r>
               <a:rPr lang="en-US" altLang="ko-KR" b="1" dirty="0">
                 <a:latin typeface="+mj-ea"/>
               </a:rPr>
-              <a:t> </a:t>
+              <a:t>Leaky </a:t>
             </a:r>
             <a:r>
               <a:rPr lang="en-US" altLang="ko-KR" b="1" dirty="0" err="1">

</xml_diff>